<commit_message>
feat(16-dependency-injection): publish carousel presentation, articles, and media deliverables
Complete publication package for Lab 16 (Dependency Injection):
Topic: Constructor Injection vs Service Locator: A Concrete Trade-off for Testability

- Carousel Deck: 24-slide visual storytelling deck in PDF and editable PPTX format
- Cover Artworks: Dual-language CRT covers (ID & EN 1920x1080 PNG)
- Technical Articles: Dev.to markdown draft and Medium HTML publication
- Reproducible Source: Defined via content_def.py with strict quality gates
- Claim Boundaries: Grounded in lab test assertions without exaggerated production claims
</commit_message>
<xml_diff>
--- a/labs/16-dependency-injection/result/linkedin/lab-16-dependency-injection-carousel.pptx
+++ b/labs/16-dependency-injection/result/linkedin/lab-16-dependency-injection-carousel.pptx
@@ -525,7 +525,7 @@
           <a:lstStyle/>
           <a:p>
             <a:r>
-              <a:t>SLIDE 1: Dependency Injection &amp; IoC</a:t>
+              <a:t>SLIDE 1: Dependency Injection di Go</a:t>
             </a:r>
           </a:p>
           <a:p/>
@@ -536,12 +536,12 @@
           </a:p>
           <a:p>
             <a:r>
-              <a:t>- Component containers and inversion of control visualization</a:t>
-            </a:r>
-          </a:p>
-          <a:p>
-            <a:r>
-              <a:t>- Decoupling construction from execution in Go services</a:t>
+              <a:t>- Three module cards labeled 'Gateway', 'Payment', 'Notification' plugged into a central socket shape</a:t>
+            </a:r>
+          </a:p>
+          <a:p>
+            <a:r>
+              <a:t>- Asymmetric connection lines from modules into the socket, implying injection</a:t>
             </a:r>
           </a:p>
           <a:p>
@@ -617,44 +617,89 @@
           <a:lstStyle/>
           <a:p>
             <a:r>
-              <a:t>SLIDE 10: Output Demo: Verifikasi Eksekusi Terpisah</a:t>
+              <a:t>SLIDE 10: Semua 6 Test Pass, Race Detector Clean</a:t>
             </a:r>
           </a:p>
           <a:p/>
           <a:p>
             <a:r>
-              <a:t>Mental Model: Identical runtime output does not imply identical architectural maintainability.</a:t>
+              <a:t>Mental Model: Zero race warnings on a small sequential suite prove the tested paths; they do not prove the whole runtime safe.</a:t>
             </a:r>
           </a:p>
           <a:p/>
           <a:p>
             <a:r>
-              <a:t>[TERMINAL DEMO OUTPUT]</a:t>
-            </a:r>
-          </a:p>
-          <a:p>
-            <a:r>
-              <a:t>- $ go run ./cmd/demo</a:t>
-            </a:r>
-          </a:p>
-          <a:p>
-            <a:r>
-              <a:t>- --- Running Constructor Injection ---</a:t>
-            </a:r>
-          </a:p>
-          <a:p>
-            <a:r>
-              <a:t>- RealGateway charging 100 USD</a:t>
-            </a:r>
-          </a:p>
-          <a:p>
-            <a:r>
-              <a:t>- --- Running Service Locator ---</a:t>
-            </a:r>
-          </a:p>
-          <a:p>
-            <a:r>
-              <a:t>- RealGateway charging 200 USD</a:t>
+              <a:t>[TERMINAL OUTPUT]</a:t>
+            </a:r>
+          </a:p>
+          <a:p>
+            <a:r>
+              <a:t>- $ go test -race -v ./tests/</a:t>
+            </a:r>
+          </a:p>
+          <a:p>
+            <a:r>
+              <a:t>- === RUN   TestProcessor_Success</a:t>
+            </a:r>
+          </a:p>
+          <a:p>
+            <a:r>
+              <a:t>- --- PASS: TestProcessor_Success (0.00s)</a:t>
+            </a:r>
+          </a:p>
+          <a:p>
+            <a:r>
+              <a:t>- === RUN   TestProcessor_GatewayError</a:t>
+            </a:r>
+          </a:p>
+          <a:p>
+            <a:r>
+              <a:t>- --- PASS: TestProcessor_GatewayError (0.00s)</a:t>
+            </a:r>
+          </a:p>
+          <a:p>
+            <a:r>
+              <a:t>- === RUN   TestProcessor_InvalidAmount</a:t>
+            </a:r>
+          </a:p>
+          <a:p>
+            <a:r>
+              <a:t>- --- PASS: TestProcessor_InvalidAmount (0.00s)</a:t>
+            </a:r>
+          </a:p>
+          <a:p>
+            <a:r>
+              <a:t>- === RUN   TestBadProcessor_Success</a:t>
+            </a:r>
+          </a:p>
+          <a:p>
+            <a:r>
+              <a:t>- --- PASS: TestBadProcessor_Success (0.00s)</a:t>
+            </a:r>
+          </a:p>
+          <a:p>
+            <a:r>
+              <a:t>- === RUN   TestBadProcessor_GatewayError</a:t>
+            </a:r>
+          </a:p>
+          <a:p>
+            <a:r>
+              <a:t>- --- PASS: TestBadProcessor_GatewayError (0.00s)</a:t>
+            </a:r>
+          </a:p>
+          <a:p>
+            <a:r>
+              <a:t>- === RUN   TestBadProcessor_InvalidAmount</a:t>
+            </a:r>
+          </a:p>
+          <a:p>
+            <a:r>
+              <a:t>- --- PASS: TestBadProcessor_InvalidAmount (0.00s)</a:t>
+            </a:r>
+          </a:p>
+          <a:p>
+            <a:r>
+              <a:t>- PASS: ok lab16/tests (cached)</a:t>
             </a:r>
           </a:p>
           <a:p/>
@@ -725,54 +770,44 @@
           <a:lstStyle/>
           <a:p>
             <a:r>
-              <a:t>SLIDE 11: Test Memvalidasi Alur, Bukan Kesiapan Skala</a:t>
+              <a:t>SLIDE 11: Angka 0.00s Tidak Otomatis Jadi SLO Production</a:t>
             </a:r>
           </a:p>
           <a:p/>
           <a:p>
             <a:r>
-              <a:t>Mental Model: Passing mock tests prove logic isolation; production still requires resilience tests.</a:t>
+              <a:t>Mental Model: Benchmark numbers are context-bound; they measure what the harness measures, nothing more.</a:t>
             </a:r>
           </a:p>
           <a:p/>
           <a:p>
             <a:r>
-              <a:t>[YANG DIBUKTIKAN TEST]</a:t>
-            </a:r>
-          </a:p>
-          <a:p>
-            <a:r>
-              <a:t>- Processor mendelegasikan pembayaran ke MockGateway tanpa jaringan.</a:t>
-            </a:r>
-          </a:p>
-          <a:p>
-            <a:r>
-              <a:t>- Validasi amount &lt;= 0 menolak eksekusi sebelum memanggil gateway.</a:t>
-            </a:r>
-          </a:p>
-          <a:p>
-            <a:r>
-              <a:t>- Race detector bersih pada seluruh skenario pengujian unit.</a:t>
-            </a:r>
-          </a:p>
-          <a:p>
-            <a:r>
-              <a:t>[YANG TIDAK DIBUKTIKAN]</a:t>
-            </a:r>
-          </a:p>
-          <a:p>
-            <a:r>
-              <a:t>- Ketahanan koneksi HTTP saat gateway riil mengalami timeout.</a:t>
-            </a:r>
-          </a:p>
-          <a:p>
-            <a:r>
-              <a:t>- Manajemen connection pool dan lifecycle pada beban production.</a:t>
-            </a:r>
-          </a:p>
-          <a:p>
-            <a:r>
-              <a:t>- Keamanan race condition pada shared state antar-goroutine.</a:t>
+              <a:t>[METRIK HASIL]</a:t>
+            </a:r>
+          </a:p>
+          <a:p>
+            <a:r>
+              <a:t>- Metric | Nilai | Makna | Batas</a:t>
+            </a:r>
+          </a:p>
+          <a:p>
+            <a:r>
+              <a:t>- Test duration | 0.00s/case | Unit test in-memory | Bukan network latency</a:t>
+            </a:r>
+          </a:p>
+          <a:p>
+            <a:r>
+              <a:t>- Race warnings | 0 | Sequential test clean | Belum concurrent test</a:t>
+            </a:r>
+          </a:p>
+          <a:p>
+            <a:r>
+              <a:t>- Mock coverage | Charge captured | Path: valid+error+invalid | Belum edge: timeout</a:t>
+            </a:r>
+          </a:p>
+          <a:p>
+            <a:r>
+              <a:t>- Demo output | RealGateway charging | Integration manual verified | Bukan automated claim</a:t>
             </a:r>
           </a:p>
           <a:p/>
@@ -843,54 +878,39 @@
           <a:lstStyle/>
           <a:p>
             <a:r>
-              <a:t>SLIDE 12: Trade-off: Fleksibilitas vs Kejelasan Kontrak</a:t>
+              <a:t>SLIDE 12: Trade-off: Boilerplate Konstruksi vs Kemampuan Uji</a:t>
             </a:r>
           </a:p>
           <a:p/>
           <a:p>
             <a:r>
-              <a:t>Mental Model: Explicit constructor parameters protect architectural clarity at the cost of signature length.</a:t>
+              <a:t>Mental Model: DI trades a small construction cost for isolation gains; it does not buy production safety.</a:t>
             </a:r>
           </a:p>
           <a:p/>
           <a:p>
             <a:r>
-              <a:t>[CONSTRUCTOR INJECTION]</a:t>
-            </a:r>
-          </a:p>
-          <a:p>
-            <a:r>
-              <a:t>- Kontrak terlihat jelas pada signature konstruktor.</a:t>
-            </a:r>
-          </a:p>
-          <a:p>
-            <a:r>
-              <a:t>- Compiler menolak caller jika argumen kurang.</a:t>
-            </a:r>
-          </a:p>
-          <a:p>
-            <a:r>
-              <a:t>- Constructor berisiko panjang jika kelas terlalu sibuk.</a:t>
-            </a:r>
-          </a:p>
-          <a:p>
-            <a:r>
-              <a:t>[SERVICE LOCATOR]</a:t>
-            </a:r>
-          </a:p>
-          <a:p>
-            <a:r>
-              <a:t>- Signature konstruktor tetap ringkas menerima Container tunggal.</a:t>
-            </a:r>
-          </a:p>
-          <a:p>
-            <a:r>
-              <a:t>- Kebutuhan dependensi tersembunyi di dalam implementasi method.</a:t>
-            </a:r>
-          </a:p>
-          <a:p>
-            <a:r>
-              <a:t>- Kompilasi lolos meski service belum terdaftar di container.</a:t>
+              <a:t>[BIAYA &amp; MANFAAT]</a:t>
+            </a:r>
+          </a:p>
+          <a:p>
+            <a:r>
+              <a:t>- Biaya: Tambah 1 parameter di constructor</a:t>
+            </a:r>
+          </a:p>
+          <a:p>
+            <a:r>
+              <a:t>- Manfaat: Mocking tanpa network call di unit test</a:t>
+            </a:r>
+          </a:p>
+          <a:p>
+            <a:r>
+              <a:t>- Biaya: Composition root perlu tahu concrete type</a:t>
+            </a:r>
+          </a:p>
+          <a:p>
+            <a:r>
+              <a:t>- Manfaat: Error propagation tetap terverifikasi rapi</a:t>
             </a:r>
           </a:p>
           <a:p/>
@@ -961,34 +981,34 @@
           <a:lstStyle/>
           <a:p>
             <a:r>
-              <a:t>SLIDE 13: Value Object Tidak Memerlukan Injeksi</a:t>
+              <a:t>SLIDE 13: Nil Guard Menutupi Runtime Risk</a:t>
             </a:r>
           </a:p>
           <a:p/>
           <a:p>
             <a:r>
-              <a:t>Mental Model: Reserve dependency injection for behavioral services, not pure value objects.</a:t>
+              <a:t>Mental Model: Explicit nil checks convert runtime surprises into compile-time or call-site failures.</a:t>
             </a:r>
           </a:p>
           <a:p/>
           <a:p>
             <a:r>
-              <a:t>[DIRECT INSTANTIATION]</a:t>
-            </a:r>
-          </a:p>
-          <a:p>
-            <a:r>
-              <a:t>- func (p *Processor) ProcessPayment(amount int) error {</a:t>
-            </a:r>
-          </a:p>
-          <a:p>
-            <a:r>
-              <a:t>-     if amount &lt;= 0 {</a:t>
-            </a:r>
-          </a:p>
-          <a:p>
-            <a:r>
-              <a:t>-         return errors.New("invalid amount")</a:t>
+              <a:t>[IMPROVED CODE]</a:t>
+            </a:r>
+          </a:p>
+          <a:p>
+            <a:r>
+              <a:t>- func NewProcessor(g PaymentGateway) *Processor {</a:t>
+            </a:r>
+          </a:p>
+          <a:p>
+            <a:r>
+              <a:t>-     if g == nil {</a:t>
+            </a:r>
+          </a:p>
+          <a:p>
+            <a:r>
+              <a:t>-         return nil // atau panic, tergantung kebijakan tim</a:t>
             </a:r>
           </a:p>
           <a:p>
@@ -998,12 +1018,7 @@
           </a:p>
           <a:p>
             <a:r>
-              <a:t>-     m := Money{Amount: amount, Currency: "USD"}</a:t>
-            </a:r>
-          </a:p>
-          <a:p>
-            <a:r>
-              <a:t>-     return p.gateway.Charge(m)</a:t>
+              <a:t>-     return &amp;Processor{gateway: g}</a:t>
             </a:r>
           </a:p>
           <a:p>
@@ -1079,54 +1094,64 @@
           <a:lstStyle/>
           <a:p>
             <a:r>
-              <a:t>SLIDE 14: Sebelum vs Sesudah Constructor Injection</a:t>
+              <a:t>SLIDE 14: Sebelum vs Sesudah: Konstruktor Injection</a:t>
             </a:r>
           </a:p>
           <a:p/>
           <a:p>
             <a:r>
-              <a:t>Mental Model: Externalizing construction decouples business logic from concrete infrastructure.</a:t>
+              <a:t>Mental Model: The biggest change is at the composition boundary, not inside the domain logic.</a:t>
             </a:r>
           </a:p>
           <a:p/>
           <a:p>
             <a:r>
-              <a:t>[HARDCODED REAL GATEWAY]</a:t>
-            </a:r>
-          </a:p>
-          <a:p>
-            <a:r>
-              <a:t>- Processor membuat new RealGateway() di method.</a:t>
-            </a:r>
-          </a:p>
-          <a:p>
-            <a:r>
-              <a:t>- Test terpaksa memanggil network eksternal.</a:t>
-            </a:r>
-          </a:p>
-          <a:p>
-            <a:r>
-              <a:t>- Gagal ganti provider tanpa mengubah domain code.</a:t>
-            </a:r>
-          </a:p>
-          <a:p>
-            <a:r>
-              <a:t>[CONSTRUCTOR INJECTION]</a:t>
-            </a:r>
-          </a:p>
-          <a:p>
-            <a:r>
-              <a:t>- Processor menerima interface PaymentGateway.</a:t>
-            </a:r>
-          </a:p>
-          <a:p>
-            <a:r>
-              <a:t>- Test menyuntikkan MockGateway in-memory seketika.</a:t>
-            </a:r>
-          </a:p>
-          <a:p>
-            <a:r>
-              <a:t>- Caller bebas menukar provider di composition root.</a:t>
+              <a:t>[BEFORE (Tight Coupling)]</a:t>
+            </a:r>
+          </a:p>
+          <a:p>
+            <a:r>
+              <a:t>- Processor { gateway RealGateway }</a:t>
+            </a:r>
+          </a:p>
+          <a:p>
+            <a:r>
+              <a:t>- NewProcessor() → &amp;Processor{gateway: &amp;RealGateway{}}</a:t>
+            </a:r>
+          </a:p>
+          <a:p>
+            <a:r>
+              <a:t>- Test: harus pakai RealGateway atau setup mocking kompleks</a:t>
+            </a:r>
+          </a:p>
+          <a:p>
+            <a:r>
+              <a:t>- Swap: edit seluruh call site</a:t>
+            </a:r>
+          </a:p>
+          <a:p>
+            <a:r>
+              <a:t>[AFTER (Constructor Injection)]</a:t>
+            </a:r>
+          </a:p>
+          <a:p>
+            <a:r>
+              <a:t>- Processor { gateway PaymentGateway }</a:t>
+            </a:r>
+          </a:p>
+          <a:p>
+            <a:r>
+              <a:t>- NewProcessor(g PaymentGateway) → &amp;Processor{gateway: g}</a:t>
+            </a:r>
+          </a:p>
+          <a:p>
+            <a:r>
+              <a:t>- Test: cukup passed MockGateway{}</a:t>
+            </a:r>
+          </a:p>
+          <a:p>
+            <a:r>
+              <a:t>- Swap: satu baris di main.go</a:t>
             </a:r>
           </a:p>
           <a:p/>
@@ -1197,54 +1222,59 @@
           <a:lstStyle/>
           <a:p>
             <a:r>
-              <a:t>SLIDE 15: Batasan Lab: Manual Wiring In-Memory</a:t>
+              <a:t>SLIDE 15: Apa yang Tidak Dicakup oleh Lab Ini</a:t>
             </a:r>
           </a:p>
           <a:p/>
           <a:p>
             <a:r>
-              <a:t>Mental Model: Manual wiring demonstrates the core principle without the complexity of automated frameworks.</a:t>
+              <a:t>Mental Model: A lab proves what it designs to prove; it does not absolve you from production considerations.</a:t>
             </a:r>
           </a:p>
           <a:p/>
           <a:p>
             <a:r>
-              <a:t>[CAKUPAN IMPLEMENTASI]</a:t>
-            </a:r>
-          </a:p>
-          <a:p>
-            <a:r>
-              <a:t>- Manual composition root di cmd/demo/main.go.</a:t>
-            </a:r>
-          </a:p>
-          <a:p>
-            <a:r>
-              <a:t>- Single interface PaymentGateway dan implementasi mock.</a:t>
-            </a:r>
-          </a:p>
-          <a:p>
-            <a:r>
-              <a:t>- Validasi domain sebelum delegasi ke infrastruktur.</a:t>
-            </a:r>
-          </a:p>
-          <a:p>
-            <a:r>
-              <a:t>[TIDAK TERCAKUP DALAM LAB]</a:t>
-            </a:r>
-          </a:p>
-          <a:p>
-            <a:r>
-              <a:t>- DI framework otomatis seperti Wire, Dig, atau Fx.</a:t>
-            </a:r>
-          </a:p>
-          <a:p>
-            <a:r>
-              <a:t>- Lifecycle management: Singleton, Scoped, dan Transient.</a:t>
-            </a:r>
-          </a:p>
-          <a:p>
-            <a:r>
-              <a:t>- Scope validation untuk mencegah memory leak antar-request.</a:t>
+              <a:t>[YANG DILAB]</a:t>
+            </a:r>
+          </a:p>
+          <a:p>
+            <a:r>
+              <a:t>- Kontras struktural antara Constructor Injection dan Service Locator.</a:t>
+            </a:r>
+          </a:p>
+          <a:p>
+            <a:r>
+              <a:t>- Verifikasi mock substitution bekerja pada test sequential.</a:t>
+            </a:r>
+          </a:p>
+          <a:p>
+            <a:r>
+              <a:t>- Race detector bersih pada test suite saat ini.</a:t>
+            </a:r>
+          </a:p>
+          <a:p>
+            <a:r>
+              <a:t>[YANG TIDAK DILAB]</a:t>
+            </a:r>
+          </a:p>
+          <a:p>
+            <a:r>
+              <a:t>- Lifecycle management (singleton, scoped, transient).</a:t>
+            </a:r>
+          </a:p>
+          <a:p>
+            <a:r>
+              <a:t>- Performance overhead reflection-based DI frameworks.</a:t>
+            </a:r>
+          </a:p>
+          <a:p>
+            <a:r>
+              <a:t>- Concurrent access patterns pada shared dependencies.</a:t>
+            </a:r>
+          </a:p>
+          <a:p>
+            <a:r>
+              <a:t>- Production defect rate reduction claim.</a:t>
             </a:r>
           </a:p>
           <a:p/>
@@ -1315,59 +1345,39 @@
           <a:lstStyle/>
           <a:p>
             <a:r>
-              <a:t>SLIDE 16: Kasus Batas: Penanganan Parameter Tidak Valid</a:t>
+              <a:t>SLIDE 16: Edge Case: Nil Dependency Menghasilkan Panic</a:t>
             </a:r>
           </a:p>
           <a:p/>
           <a:p>
             <a:r>
-              <a:t>Mental Model: Validate input at domain boundaries before delegating to injected infrastructure.</a:t>
+              <a:t>Mental Model: Absence of a guard is not a DI flaw; it is a defensive programming gap that any pattern must address.</a:t>
             </a:r>
           </a:p>
           <a:p/>
           <a:p>
             <a:r>
-              <a:t>[TEST INVALID AMOUNT]</a:t>
-            </a:r>
-          </a:p>
-          <a:p>
-            <a:r>
-              <a:t>- proc := di.NewProcessor(mock)</a:t>
-            </a:r>
-          </a:p>
-          <a:p>
-            <a:r>
-              <a:t>- err := proc.ProcessPayment(-10)</a:t>
-            </a:r>
-          </a:p>
-          <a:p>
-            <a:r>
-              <a:t>- if err == nil {</a:t>
-            </a:r>
-          </a:p>
-          <a:p>
-            <a:r>
-              <a:t>-     t.Fatalf("expected error for negative amount")</a:t>
-            </a:r>
-          </a:p>
-          <a:p>
-            <a:r>
-              <a:t>- }</a:t>
-            </a:r>
-          </a:p>
-          <a:p>
-            <a:r>
-              <a:t>- if mock.ChargedMoney.Amount != 0 {</a:t>
-            </a:r>
-          </a:p>
-          <a:p>
-            <a:r>
-              <a:t>-     t.Errorf("gateway should not have been called")</a:t>
-            </a:r>
-          </a:p>
-          <a:p>
-            <a:r>
-              <a:t>- }</a:t>
+              <a:t>[Skenario Edge]</a:t>
+            </a:r>
+          </a:p>
+          <a:p>
+            <a:r>
+              <a:t>- Caller mengoper nil sebagai PaymentGateway.</a:t>
+            </a:r>
+          </a:p>
+          <a:p>
+            <a:r>
+              <a:t>- Constructor tidak menolak; Processor tetap terbuat.</a:t>
+            </a:r>
+          </a:p>
+          <a:p>
+            <a:r>
+              <a:t>- ProcessPayment(100) → gateway.Charge(m) → nil pointer panic.</a:t>
+            </a:r>
+          </a:p>
+          <a:p>
+            <a:r>
+              <a:t>- Error tidak ter-catch; crash terjadi di runtime.</a:t>
             </a:r>
           </a:p>
           <a:p/>
@@ -1438,39 +1448,34 @@
           <a:lstStyle/>
           <a:p>
             <a:r>
-              <a:t>SLIDE 17: Fakta yang Dibuktikan Suite Pengujian</a:t>
+              <a:t>SLIDE 17: Test Suite Membuktikan Tiga Jalur Saja</a:t>
             </a:r>
           </a:p>
           <a:p/>
           <a:p>
             <a:r>
-              <a:t>Mental Model: Clean unit tests confirm structural wiring under specified test fixtures.</a:t>
+              <a:t>Mental Model: Tests prove the paths they cover; they do not prove the paths they do not traverse.</a:t>
             </a:r>
           </a:p>
           <a:p/>
           <a:p>
             <a:r>
-              <a:t>[FAKTA TERVERIFIKASI]</a:t>
-            </a:r>
-          </a:p>
-          <a:p>
-            <a:r>
-              <a:t>- Processor dan BadProcessor sukses mendelegasikan transaksi valid.</a:t>
-            </a:r>
-          </a:p>
-          <a:p>
-            <a:r>
-              <a:t>- Error dari PaymentGateway dipropagasikan utuh ke caller.</a:t>
-            </a:r>
-          </a:p>
-          <a:p>
-            <a:r>
-              <a:t>- Input negatif ditolak tanpa memanggil gateway eksternal.</a:t>
-            </a:r>
-          </a:p>
-          <a:p>
-            <a:r>
-              <a:t>- go test -race tidak mendeteksi data race pada skenario uji.</a:t>
+              <a:t>[YANG DIBUKTIKAN]</a:t>
+            </a:r>
+          </a:p>
+          <a:p>
+            <a:r>
+              <a:t>- MockGateway berhasil menangkap panggilan Charge dengan amount dan currency benar.</a:t>
+            </a:r>
+          </a:p>
+          <a:p>
+            <a:r>
+              <a:t>- Error dari gateway dipropagasikan ke caller tanpa di-suppress.</a:t>
+            </a:r>
+          </a:p>
+          <a:p>
+            <a:r>
+              <a:t>- Pre-check amount &lt;= 0 mencegah panggilan gateway (ChargedMoney tetap 0).</a:t>
             </a:r>
           </a:p>
           <a:p/>
@@ -1541,39 +1546,39 @@
           <a:lstStyle/>
           <a:p>
             <a:r>
-              <a:t>SLIDE 18: Batas Integritas: Apa yang Tidak Diuji</a:t>
+              <a:t>SLIDE 18: Yang Belum Dibuktikan oleh Test Suite</a:t>
             </a:r>
           </a:p>
           <a:p/>
           <a:p>
             <a:r>
-              <a:t>Mental Model: Unit test assertions verify local contracts, not distributed system stability.</a:t>
+              <a:t>Mental Model: The absence of evidence is not evidence of absence; it is a scope declaration.</a:t>
             </a:r>
           </a:p>
           <a:p/>
           <a:p>
             <a:r>
-              <a:t>[DI LUAR BUKTI LAB]</a:t>
-            </a:r>
-          </a:p>
-          <a:p>
-            <a:r>
-              <a:t>- Bukan jaminan zero-overhead pada graf dependensi kompleks.</a:t>
-            </a:r>
-          </a:p>
-          <a:p>
-            <a:r>
-              <a:t>- Belum membuktikan keandalan retries saat gateway riil timeout.</a:t>
-            </a:r>
-          </a:p>
-          <a:p>
-            <a:r>
-              <a:t>- Race detector hanya membaca jalur pengujian yang dijalankan.</a:t>
-            </a:r>
-          </a:p>
-          <a:p>
-            <a:r>
-              <a:t>- Tidak membuktikan efisiensi memory lifecycle skala production.</a:t>
+              <a:t>[YANG TIDAK DIBUKTIKAN]</a:t>
+            </a:r>
+          </a:p>
+          <a:p>
+            <a:r>
+              <a:t>- Concurrency safety: tidak ada concurrent test yang memicu race condition.</a:t>
+            </a:r>
+          </a:p>
+          <a:p>
+            <a:r>
+              <a:t>- Lifecycle management: tidak adauji singleton vs transient vs scoped.</a:t>
+            </a:r>
+          </a:p>
+          <a:p>
+            <a:r>
+              <a:t>- Framework DI overhead: tidak diukur latency injection vs manual new.</a:t>
+            </a:r>
+          </a:p>
+          <a:p>
+            <a:r>
+              <a:t>- Production defect reduction: tidak ada studi empiris dalam lab ini.</a:t>
             </a:r>
           </a:p>
           <a:p/>
@@ -1644,39 +1649,39 @@
           <a:lstStyle/>
           <a:p>
             <a:r>
-              <a:t>SLIDE 19: Risiko: Constructor Over-Injection</a:t>
+              <a:t>SLIDE 19: Risiko Menerapkan Pola Tanpa Pertimbangan Lifecycle</a:t>
             </a:r>
           </a:p>
           <a:p/>
           <a:p>
             <a:r>
-              <a:t>Mental Model: A constructor with too many dependencies is a code smell for single-responsibility violation.</a:t>
+              <a:t>Mental Model: Pattern application without lifecycle awareness turns a testing benefit into an operational risk.</a:t>
             </a:r>
           </a:p>
           <a:p/>
           <a:p>
             <a:r>
-              <a:t>[GEJALA KERUSAKAN DESAIN]</a:t>
-            </a:r>
-          </a:p>
-          <a:p>
-            <a:r>
-              <a:t>- Constructor menerima belasan parameter interface berbeda.</a:t>
-            </a:r>
-          </a:p>
-          <a:p>
-            <a:r>
-              <a:t>- Kelas mengurusi terlalu banyak domain logic (God Object).</a:t>
-            </a:r>
-          </a:p>
-          <a:p>
-            <a:r>
-              <a:t>- Setiap unit test memerlukan belasan mock setup yang rapuh.</a:t>
-            </a:r>
-          </a:p>
-          <a:p>
-            <a:r>
-              <a:t>- Solusi: pecah service menjadi komponen yang lebih granular.</a:t>
+              <a:t>[RISIKO POTENSIAL]</a:t>
+            </a:r>
+          </a:p>
+          <a:p>
+            <a:r>
+              <a:t>- Setiap call site membuat Processor baru → object graph tumbuh tanpa batas.</a:t>
+            </a:r>
+          </a:p>
+          <a:p>
+            <a:r>
+              <a:t>- Shared state di dalam PaymentGateway (misal token cache) perlu sinkronisasi.</a:t>
+            </a:r>
+          </a:p>
+          <a:p>
+            <a:r>
+              <a:t>- Nil guard tidak ada → caller error menghasilkan panic di runtime.</a:t>
+            </a:r>
+          </a:p>
+          <a:p>
+            <a:r>
+              <a:t>- Komposisi root tunggal (`main.go`) bisa menjadi bottleneck pada sistem besar.</a:t>
             </a:r>
           </a:p>
           <a:p/>
@@ -1747,34 +1752,34 @@
           <a:lstStyle/>
           <a:p>
             <a:r>
-              <a:t>SLIDE 2: Hardcoded Dependency Merusak Uji Sistem</a:t>
+              <a:t>SLIDE 2: Coupling Mengunci Gateway di Domain</a:t>
             </a:r>
           </a:p>
           <a:p/>
           <a:p>
             <a:r>
-              <a:t>Mental Model: Hardcoded dependencies force integration tests where unit tests belong.</a:t>
+              <a:t>Mental Model: When a component builds its own dependencies, replacing them requires editing the component itself.</a:t>
             </a:r>
           </a:p>
           <a:p/>
           <a:p>
             <a:r>
-              <a:t>[MASALAH ARSITEKTUR NYATA]</a:t>
-            </a:r>
-          </a:p>
-          <a:p>
-            <a:r>
-              <a:t>- Processor memanggil RealGateway secara langsung di dalam method.</a:t>
-            </a:r>
-          </a:p>
-          <a:p>
-            <a:r>
-              <a:t>- Unit test terpaksa membuat panggilan jaringan ke gateway eksternal.</a:t>
-            </a:r>
-          </a:p>
-          <a:p>
-            <a:r>
-              <a:t>- Kegagalan koneksi pihak ketiga membuat build CI merah seketika.</a:t>
+              <a:t>[MASALAH STRUKTURAL]</a:t>
+            </a:r>
+          </a:p>
+          <a:p>
+            <a:r>
+              <a:t>- Processor meng-instantiate &amp;RealGateway{} secara internal.</a:t>
+            </a:r>
+          </a:p>
+          <a:p>
+            <a:r>
+              <a:t>- Swap provider gateway memaksa edit domain code.</a:t>
+            </a:r>
+          </a:p>
+          <a:p>
+            <a:r>
+              <a:t>- Test menjadi integration test lambat dan flaky.</a:t>
             </a:r>
           </a:p>
           <a:p/>
@@ -1845,39 +1850,49 @@
           <a:lstStyle/>
           <a:p>
             <a:r>
-              <a:t>SLIDE 20: Panduan Implementasi DI yang Aman</a:t>
+              <a:t>SLIDE 20: Checklist Implementasi Dependency Injection yang Aman</a:t>
             </a:r>
           </a:p>
           <a:p/>
           <a:p>
             <a:r>
-              <a:t>Mental Model: Define interfaces at consumption boundaries and centralize wiring in the composition root.</a:t>
+              <a:t>Mental Model: Checklists guide practice; they do not replace architectural judgment or runtime verification.</a:t>
             </a:r>
           </a:p>
           <a:p/>
           <a:p>
             <a:r>
-              <a:t>[CHECKLIST ARSITEKTUR]</a:t>
-            </a:r>
-          </a:p>
-          <a:p>
-            <a:r>
-              <a:t>- Definisikan interface di sisi consumer, bukan di sisi provider.</a:t>
-            </a:r>
-          </a:p>
-          <a:p>
-            <a:r>
-              <a:t>- Gunakan Constructor Injection sebagai default untuk seluruh service.</a:t>
-            </a:r>
-          </a:p>
-          <a:p>
-            <a:r>
-              <a:t>- Tambahkan guard validasi nil pada setiap konstruktor.</a:t>
-            </a:r>
-          </a:p>
-          <a:p>
-            <a:r>
-              <a:t>- Pusatkan instansiasi konkret di composition root (main.go).</a:t>
+              <a:t>[LANGKAH KERJA]</a:t>
+            </a:r>
+          </a:p>
+          <a:p>
+            <a:r>
+              <a:t>- [ ] Dependeansi dideklarasikan sebagai interface, bukan concrete type.</a:t>
+            </a:r>
+          </a:p>
+          <a:p>
+            <a:r>
+              <a:t>- [ ] Constructor injection digunakan; semua dependency eksplisit di signature.</a:t>
+            </a:r>
+          </a:p>
+          <a:p>
+            <a:r>
+              <a:t>- [ ] Composition root (`main.go`) adalah satu-satunya tempat konstruksi concrete.</a:t>
+            </a:r>
+          </a:p>
+          <a:p>
+            <a:r>
+              <a:t>- [ ] Value objects (seperti `Money`) diinstansiasi langsung, bukan melalui DI.</a:t>
+            </a:r>
+          </a:p>
+          <a:p>
+            <a:r>
+              <a:t>- [ ] Validasi input dilakukan sebelum delegasi ke dependency eksternal.</a:t>
+            </a:r>
+          </a:p>
+          <a:p>
+            <a:r>
+              <a:t>- [ ] `go test -race ./...` dijalankan dan PASS sebelum merge.</a:t>
             </a:r>
           </a:p>
           <a:p/>
@@ -1948,39 +1963,39 @@
           <a:lstStyle/>
           <a:p>
             <a:r>
-              <a:t>SLIDE 21: Anti-Pattern: Passing Container ke Domain</a:t>
+              <a:t>SLIDE 21: Anti-Pattern: Service Locator di Domain Logic</a:t>
             </a:r>
           </a:p>
           <a:p/>
           <a:p>
             <a:r>
-              <a:t>Mental Model: Never inject the container: pass only the specific service required by the domain.</a:t>
+              <a:t>Mental Model: Service Locator is a tool, not a sin; misuse depends on where and why it is applied.</a:t>
             </a:r>
           </a:p>
           <a:p/>
           <a:p>
             <a:r>
-              <a:t>[ALASAN MENGHINDARI LOCATOR]</a:t>
-            </a:r>
-          </a:p>
-          <a:p>
-            <a:r>
-              <a:t>- PSR-11 dan standar industri menegaskan: 'Users SHOULD NOT pass container'.</a:t>
-            </a:r>
-          </a:p>
-          <a:p>
-            <a:r>
-              <a:t>- Domain terikat pada interface container milik framework.</a:t>
-            </a:r>
-          </a:p>
-          <a:p>
-            <a:r>
-              <a:t>- Mocking menjadi sulit karena seluruh container harus ditiru.</a:t>
-            </a:r>
-          </a:p>
-          <a:p>
-            <a:r>
-              <a:t>- Kompilasi berhasil meski service target belum terdaftar.</a:t>
+              <a:t>[HINDARI POLA INI]</a:t>
+            </a:r>
+          </a:p>
+          <a:p>
+            <a:r>
+              <a:t>- NewBadProcessor(c Container) — signature menyembunyikan PaymentGateway.</a:t>
+            </a:r>
+          </a:p>
+          <a:p>
+            <a:r>
+              <a:t>- container.GetPaymentGateway() dipanggil di dalam method domain.</a:t>
+            </a:r>
+          </a:p>
+          <a:p>
+            <a:r>
+              <a:t>- Test harus mock Container alih-alih gateway — tambahan kompleksitas.</a:t>
+            </a:r>
+          </a:p>
+          <a:p>
+            <a:r>
+              <a:t>- Swap provider tetap satu baris, tetapi readability dan traceability menurun.</a:t>
             </a:r>
           </a:p>
           <a:p/>
@@ -2057,7 +2072,7 @@
           <a:p/>
           <a:p>
             <a:r>
-              <a:t>Mental Model: Standard library tests ensure deterministic verification without external tooling overhead.</a:t>
+              <a:t>Mental Model: Reproducibility on a local machine is necessary but not sufficient for production confidence.</a:t>
             </a:r>
           </a:p>
           <a:p/>
@@ -2073,17 +2088,17 @@
           </a:p>
           <a:p>
             <a:r>
-              <a:t>- go test -v ./...    # validasi 6 test cases</a:t>
-            </a:r>
-          </a:p>
-          <a:p>
-            <a:r>
-              <a:t>- go test -race ./... # verifikasi race detector</a:t>
-            </a:r>
-          </a:p>
-          <a:p>
-            <a:r>
-              <a:t>- go run ./cmd/demo   # simulasi DI vs Service Locator</a:t>
+              <a:t>- go test -race -v ./tests/     # validasi 6 test cases</a:t>
+            </a:r>
+          </a:p>
+          <a:p>
+            <a:r>
+              <a:t>- go run ./cmd/demo            # jalankan demo kedua pola</a:t>
+            </a:r>
+          </a:p>
+          <a:p>
+            <a:r>
+              <a:t>- go vet ./...                 # statik analisis tambahan</a:t>
             </a:r>
           </a:p>
           <a:p/>
@@ -2154,13 +2169,13 @@
           <a:lstStyle/>
           <a:p>
             <a:r>
-              <a:t>SLIDE 23: DI Memperlihatkan Dependency Komponen</a:t>
+              <a:t>SLIDE 23: Constructor Membuat Dependency Terlihat</a:t>
             </a:r>
           </a:p>
           <a:p/>
           <a:p>
             <a:r>
-              <a:t>Mental Model: Dependency injection makes dependencies visible; it does not replace runtime validation.</a:t>
+              <a:t>Mental Model: DI shifts ownership from the component to its assembler; visibility improves testability.</a:t>
             </a:r>
           </a:p>
           <a:p/>
@@ -2171,17 +2186,22 @@
           </a:p>
           <a:p>
             <a:r>
-              <a:t>- Constructor injection membuat kontrak ketergantungan eksplisit.</a:t>
-            </a:r>
-          </a:p>
-          <a:p>
-            <a:r>
-              <a:t>- Validasi nil tetap menjadi tanggung jawab konstruktor.</a:t>
-            </a:r>
-          </a:p>
-          <a:p>
-            <a:r>
-              <a:t>- Pemisahan konstruksi dari penggunaan memungkinkan pengujian terisolasi.</a:t>
+              <a:t>- DI bukan fitur framework — ia arah kendali atas instantiation.</a:t>
+            </a:r>
+          </a:p>
+          <a:p>
+            <a:r>
+              <a:t>- Constructor injection memindahkan keputusan ke composition root.</a:t>
+            </a:r>
+          </a:p>
+          <a:p>
+            <a:r>
+              <a:t>- Service Locator mengurangi boilerplate parameter, tetapi menambah indirection.</a:t>
+            </a:r>
+          </a:p>
+          <a:p>
+            <a:r>
+              <a:t>- Nil guard dan lifecycle management adalah tanggung jawab implementasi, bukan pola.</a:t>
             </a:r>
           </a:p>
           <a:p/>
@@ -2252,13 +2272,13 @@
           <a:lstStyle/>
           <a:p>
             <a:r>
-              <a:t>SLIDE 24: Constructor membuat dependency terlihat; domain tetap independen.</a:t>
+              <a:t>SLIDE 24: Constructor memperlihatkan dependency wajib; validasi nil tetap tanggung jawab constructor.</a:t>
             </a:r>
           </a:p>
           <a:p/>
           <a:p>
             <a:r>
-              <a:t>Mental Model: Constructor injection exposes dependencies explicitly; configuration remains external to use.</a:t>
+              <a:t>Mental Model: Constructor injection makes dependencies explicit; it does not replace lifecycle management or nil safety.</a:t>
             </a:r>
           </a:p>
           <a:p/>
@@ -2269,17 +2289,17 @@
           </a:p>
           <a:p>
             <a:r>
-              <a:t>- internal/di/gateway.go • internal/di/processor.go</a:t>
-            </a:r>
-          </a:p>
-          <a:p>
-            <a:r>
-              <a:t>- internal/di/locator.go • cmd/demo/main.go</a:t>
-            </a:r>
-          </a:p>
-          <a:p>
-            <a:r>
-              <a:t>- tests/processor_test.go • README.md</a:t>
+              <a:t>- internal/di/processor.go • internal/di/locator.go • internal/di/gateway.go</a:t>
+            </a:r>
+          </a:p>
+          <a:p>
+            <a:r>
+              <a:t>- cmd/demo/main.go • tests/processor_test.go</a:t>
+            </a:r>
+          </a:p>
+          <a:p>
+            <a:r>
+              <a:t>- README.md • content/02-master-draft.md</a:t>
             </a:r>
           </a:p>
           <a:p>
@@ -2289,7 +2309,7 @@
           </a:p>
           <a:p>
             <a:r>
-              <a:t>- Sumber: commit 76f0059</a:t>
+              <a:t>- Sumber: commit d7fb619</a:t>
             </a:r>
           </a:p>
           <a:p>
@@ -2304,7 +2324,7 @@
           </a:p>
           <a:p>
             <a:r>
-              <a:t>- Manual in-memory wiring; bukan proof framework DI production completeness.</a:t>
+              <a:t>- Simulasi in-memory mock; bukan proof production DI governance completeness.</a:t>
             </a:r>
           </a:p>
           <a:p/>
@@ -2375,34 +2395,54 @@
           <a:lstStyle/>
           <a:p>
             <a:r>
-              <a:t>SLIDE 3: Service Locator Menyembunyikan Kebutuhan Komponen</a:t>
+              <a:t>SLIDE 3: Konstruktor Tanpa Interface Menyulitkan Swap</a:t>
             </a:r>
           </a:p>
           <a:p/>
           <a:p>
             <a:r>
-              <a:t>Mental Model: Service Locator trades compile-time visibility for hidden runtime lookups.</a:t>
+              <a:t>Mental Model: Injecting an interface moves the selection point from domain to the composition root.</a:t>
             </a:r>
           </a:p>
           <a:p/>
           <a:p>
             <a:r>
-              <a:t>[KELEMAHAN SERVICE LOCATOR]</a:t>
-            </a:r>
-          </a:p>
-          <a:p>
-            <a:r>
-              <a:t>- Signature fungsi menyembunyikan dependensi asli di balik interface Container.</a:t>
-            </a:r>
-          </a:p>
-          <a:p>
-            <a:r>
-              <a:t>- Compiler tidak tahu apakah service yang dicari benar-benar ada di registry.</a:t>
-            </a:r>
-          </a:p>
-          <a:p>
-            <a:r>
-              <a:t>- Missing dependency baru memicu error saat transaksi dieksekusi di runtime.</a:t>
+              <a:t>[BEFORE (Tight Coupling)]</a:t>
+            </a:r>
+          </a:p>
+          <a:p>
+            <a:r>
+              <a:t>- NewProcessor() — tidak ada parameter dependency.</a:t>
+            </a:r>
+          </a:p>
+          <a:p>
+            <a:r>
+              <a:t>- Setiap test harus menggunakan RealGateway asli.</a:t>
+            </a:r>
+          </a:p>
+          <a:p>
+            <a:r>
+              <a:t>- Ganti provider = ubah seluruh call site.</a:t>
+            </a:r>
+          </a:p>
+          <a:p>
+            <a:r>
+              <a:t>[AFTER (Constructor Injection)]</a:t>
+            </a:r>
+          </a:p>
+          <a:p>
+            <a:r>
+              <a:t>- NewProcessor(g PaymentGateway) — menerima interface.</a:t>
+            </a:r>
+          </a:p>
+          <a:p>
+            <a:r>
+              <a:t>- Test cukup berikan MockGateway.</a:t>
+            </a:r>
+          </a:p>
+          <a:p>
+            <a:r>
+              <a:t>- Ganti provider = ubah satu baris di composition root.</a:t>
             </a:r>
           </a:p>
           <a:p/>
@@ -2479,7 +2519,7 @@
           <a:p/>
           <a:p>
             <a:r>
-              <a:t>Mental Model: Separate configuration from use: assemble components before running logic.</a:t>
+              <a:t>Mental Model: IoC is a principle of control direction; DI is one specific mechanism to realize it for dependencies.</a:t>
             </a:r>
           </a:p>
           <a:p/>
@@ -2490,17 +2530,17 @@
           </a:p>
           <a:p>
             <a:r>
-              <a:t>- Pisahkan fase konfigurasi (wiring) dari fase penggunaan (execution).</a:t>
-            </a:r>
-          </a:p>
-          <a:p>
-            <a:r>
-              <a:t>- Modul domain tidak boleh mengimpor paket infrastruktur konkret.</a:t>
-            </a:r>
-          </a:p>
-          <a:p>
-            <a:r>
-              <a:t>- Composition root bertindak sebagai perakit tunggal object graph.</a:t>
+              <a:t>- Constructor injection memindahkan instantiation ke caller.</a:t>
+            </a:r>
+          </a:p>
+          <a:p>
+            <a:r>
+              <a:t>- Processor bergantung pada PaymentGateway interface, bukan implementasi.</a:t>
+            </a:r>
+          </a:p>
+          <a:p>
+            <a:r>
+              <a:t>- Komposisi terjadi sekali di composition root (main.go).</a:t>
             </a:r>
           </a:p>
           <a:p/>
@@ -2571,39 +2611,39 @@
           <a:lstStyle/>
           <a:p>
             <a:r>
-              <a:t>SLIDE 5: Alur Request Melalui Boundary Abstraksi</a:t>
+              <a:t>SLIDE 5: Alur Request dari Composition Root ke Gateway</a:t>
             </a:r>
           </a:p>
           <a:p/>
           <a:p>
             <a:r>
-              <a:t>Mental Model: Interfaces establish clear boundaries between domain rules and external side effects.</a:t>
+              <a:t>Mental Model: A clean request flow separates configuration, validation, and external call concerns.</a:t>
             </a:r>
           </a:p>
           <a:p/>
           <a:p>
             <a:r>
-              <a:t>[]</a:t>
-            </a:r>
-          </a:p>
-          <a:p>
-            <a:r>
-              <a:t>- Client Request | Memanggil ProcessPayment(amount)</a:t>
-            </a:r>
-          </a:p>
-          <a:p>
-            <a:r>
-              <a:t>- Processor Domain | Validasi amount &gt; 0 &amp; buat Money</a:t>
-            </a:r>
-          </a:p>
-          <a:p>
-            <a:r>
-              <a:t>- PaymentGateway | Abstraksi kontrak Charge(Money)</a:t>
-            </a:r>
-          </a:p>
-          <a:p>
-            <a:r>
-              <a:t>- Real/Mock Gateway | Eksekusi jaringan atau verifikasi test</a:t>
+              <a:t>[REQUEST FLOW]</a:t>
+            </a:r>
+          </a:p>
+          <a:p>
+            <a:r>
+              <a:t>- main.go membuat RealGateway &amp; menyuntikkannya ke NewProcessor.</a:t>
+            </a:r>
+          </a:p>
+          <a:p>
+            <a:r>
+              <a:t>- Call site memanggil ProcessPayment(100).</a:t>
+            </a:r>
+          </a:p>
+          <a:p>
+            <a:r>
+              <a:t>- Processor validasi amount &gt; 0, lalu buat Money{100, USD}.</a:t>
+            </a:r>
+          </a:p>
+          <a:p>
+            <a:r>
+              <a:t>- Gateway.Charge(m) dipanggil; error dikembalikan ke caller.</a:t>
             </a:r>
           </a:p>
           <a:p/>
@@ -2680,23 +2720,23 @@
           <a:p/>
           <a:p>
             <a:r>
-              <a:t>Mental Model: Explicit constructor parameters make missing dependencies impossible at compile time.</a:t>
+              <a:t>Mental Model: Constructor parameters are the public contract for dependencies; missing nil guard means runtime risk remains.</a:t>
             </a:r>
           </a:p>
           <a:p/>
           <a:p>
             <a:r>
-              <a:t>[PROCESSOR.GO]</a:t>
-            </a:r>
-          </a:p>
-          <a:p>
-            <a:r>
-              <a:t>- type Processor struct {</a:t>
-            </a:r>
-          </a:p>
-          <a:p>
-            <a:r>
-              <a:t>-     gateway PaymentGateway</a:t>
+              <a:t>[KODE KRITIS]</a:t>
+            </a:r>
+          </a:p>
+          <a:p>
+            <a:r>
+              <a:t>- func NewProcessor(g PaymentGateway) *Processor {</a:t>
+            </a:r>
+          </a:p>
+          <a:p>
+            <a:r>
+              <a:t>-     return &amp;Processor{gateway: g}</a:t>
             </a:r>
           </a:p>
           <a:p>
@@ -2706,12 +2746,27 @@
           </a:p>
           <a:p>
             <a:r>
-              <a:t>- func NewProcessor(g PaymentGateway) *Processor {</a:t>
-            </a:r>
-          </a:p>
-          <a:p>
-            <a:r>
-              <a:t>-     return &amp;Processor{gateway: g}</a:t>
+              <a:t>- </a:t>
+            </a:r>
+          </a:p>
+          <a:p>
+            <a:r>
+              <a:t>- func (p *Processor) ProcessPayment(amount int) error {</a:t>
+            </a:r>
+          </a:p>
+          <a:p>
+            <a:r>
+              <a:t>-     if amount &lt;= 0 { return errors.New("invalid amount") }</a:t>
+            </a:r>
+          </a:p>
+          <a:p>
+            <a:r>
+              <a:t>-     m := Money{Amount: amount, Currency: "USD"}</a:t>
+            </a:r>
+          </a:p>
+          <a:p>
+            <a:r>
+              <a:t>-     return p.gateway.Charge(m)</a:t>
             </a:r>
           </a:p>
           <a:p>
@@ -2787,39 +2842,39 @@
           <a:lstStyle/>
           <a:p>
             <a:r>
-              <a:t>SLIDE 7: Jalur Kegagalan: Nil Interface Panics</a:t>
+              <a:t>SLIDE 7: Service Locator Menyembunyikan Dependency</a:t>
             </a:r>
           </a:p>
           <a:p/>
           <a:p>
             <a:r>
-              <a:t>Mental Model: Interface types permit nil values: constructors still require explicit nil guards.</a:t>
+              <a:t>Mental Model: Hiding dependencies behind a locator increases cognitive load and makes mocking harder.</a:t>
             </a:r>
           </a:p>
           <a:p/>
           <a:p>
             <a:r>
-              <a:t>[]</a:t>
-            </a:r>
-          </a:p>
-          <a:p>
-            <a:r>
-              <a:t>- Caller Passes Nil | NewProcessor(nil) lolos kompilasi</a:t>
-            </a:r>
-          </a:p>
-          <a:p>
-            <a:r>
-              <a:t>- Constructor Unchecked | Struct menyimpan pointer gateway nil</a:t>
-            </a:r>
-          </a:p>
-          <a:p>
-            <a:r>
-              <a:t>- ProcessPayment Invoked | Logika bisnis lolos validasi amount</a:t>
-            </a:r>
-          </a:p>
-          <a:p>
-            <a:r>
-              <a:t>- Runtime Nil Panic | p.gateway.Charge(m) memicu panic nil pointer</a:t>
+              <a:t>[ANTI-PATTERN]</a:t>
+            </a:r>
+          </a:p>
+          <a:p>
+            <a:r>
+              <a:t>- NewBadProcessor(c Container) menerima abstraksi yang lebih tinggi.</a:t>
+            </a:r>
+          </a:p>
+          <a:p>
+            <a:r>
+              <a:t>- ProcessPayment memanggil container.GetPaymentGateway() secara internal.</a:t>
+            </a:r>
+          </a:p>
+          <a:p>
+            <a:r>
+              <a:t>- Dependensi nyata PaymentGateway tersembunyi dari signature constructor.</a:t>
+            </a:r>
+          </a:p>
+          <a:p>
+            <a:r>
+              <a:t>- Test harus mock Container, bukan gateway — tambahan indirection.</a:t>
             </a:r>
           </a:p>
           <a:p/>
@@ -2890,13 +2945,13 @@
           <a:lstStyle/>
           <a:p>
             <a:r>
-              <a:t>SLIDE 8: Biaya Tersembunyi: Wiring Boilerplate</a:t>
+              <a:t>SLIDE 8: Biaya Tersembunyi: Indirection vs Eksplisitas</a:t>
             </a:r>
           </a:p>
           <a:p/>
           <a:p>
             <a:r>
-              <a:t>Mental Model: Boilerplate in the composition root is the explicit cost of architectural transparency.</a:t>
+              <a:t>Mental Model: The hidden cost of a pattern is often measured in maintenance time, not execution time.</a:t>
             </a:r>
           </a:p>
           <a:p/>
@@ -2907,22 +2962,27 @@
           </a:p>
           <a:p>
             <a:r>
-              <a:t>- Aspek | Manual Wiring (Lab Ini) | DI Framework (Wire/Dig)</a:t>
-            </a:r>
-          </a:p>
-          <a:p>
-            <a:r>
-              <a:t>- Dependency Graph | Terbaca di main.go | Tersembunyi di reflection / gen</a:t>
-            </a:r>
-          </a:p>
-          <a:p>
-            <a:r>
-              <a:t>- Compile Overhead | Zero overhead | Code-gen build step tambahan</a:t>
-            </a:r>
-          </a:p>
-          <a:p>
-            <a:r>
-              <a:t>- Refactoring Safety | Compiler menangkap perubahan | Bergantung pada framework container</a:t>
+              <a:t>- Aspek | Constructor | Service Locator</a:t>
+            </a:r>
+          </a:p>
+          <a:p>
+            <a:r>
+              <a:t>- Testability | Mock langsung | Mock container + gateway</a:t>
+            </a:r>
+          </a:p>
+          <a:p>
+            <a:r>
+              <a:t>- Readability | Signature jelas | Butuh telusuri container</a:t>
+            </a:r>
+          </a:p>
+          <a:p>
+            <a:r>
+              <a:t>- Swap provider | Satu baris di root | Satu baris di root</a:t>
+            </a:r>
+          </a:p>
+          <a:p>
+            <a:r>
+              <a:t>- Risk nil | Panic jika tanpa guard | Panic jika Get returns nil</a:t>
             </a:r>
           </a:p>
           <a:p/>
@@ -2993,34 +3053,39 @@
           <a:lstStyle/>
           <a:p>
             <a:r>
-              <a:t>SLIDE 9: Setup Uji: Isolasi Dua Jalur Arsitektur</a:t>
+              <a:t>SLIDE 9: Setup Pengujian: Mock Isolasi Gateway</a:t>
             </a:r>
           </a:p>
           <a:p/>
           <a:p>
             <a:r>
-              <a:t>Mental Model: Symmetric test coverage isolates architectural trade-offs under identical conditions.</a:t>
+              <a:t>Mental Model: A focused test harness isolates one behavior at a time; it proves the path, not the whole system.</a:t>
             </a:r>
           </a:p>
           <a:p/>
           <a:p>
             <a:r>
-              <a:t>[]</a:t>
-            </a:r>
-          </a:p>
-          <a:p>
-            <a:r>
-              <a:t>- 6 Test Cases: Unit Suite</a:t>
-            </a:r>
-          </a:p>
-          <a:p>
-            <a:r>
-              <a:t>- MockGateway: Test Double</a:t>
-            </a:r>
-          </a:p>
-          <a:p>
-            <a:r>
-              <a:t>- Go 1.22: Race Detector</a:t>
+              <a:t>[TEST HARNESS]</a:t>
+            </a:r>
+          </a:p>
+          <a:p>
+            <a:r>
+              <a:t>- MockGateway menyimpan ChargedMoney dan toggle ShouldFail.</a:t>
+            </a:r>
+          </a:p>
+          <a:p>
+            <a:r>
+              <a:t>- 6 test cases: 3 untuk Processor (success, error, invalid), 3 untuk BadProcessor.</a:t>
+            </a:r>
+          </a:p>
+          <a:p>
+            <a:r>
+              <a:t>- go test -race ./... dijalankan pada semua test sequential.</a:t>
+            </a:r>
+          </a:p>
+          <a:p>
+            <a:r>
+              <a:t>- Tidak ada test concurrent atau benchmark throughput.</a:t>
             </a:r>
           </a:p>
           <a:p/>
@@ -6135,7 +6200,7 @@
               </a:defRPr>
             </a:pPr>
             <a:r>
-              <a:t>Dependency Injection &amp; IoC</a:t>
+              <a:t>Dependency Injection di Go</a:t>
             </a:r>
           </a:p>
         </p:txBody>
@@ -6170,70 +6235,42 @@
               </a:defRPr>
             </a:pPr>
             <a:r>
-              <a:t>Constructor Injection vs Service Locator dalam Arsitektur Go</a:t>
-            </a:r>
-          </a:p>
-        </p:txBody>
-      </p:sp>
-      <p:sp>
-        <p:nvSpPr>
-          <p:cNvPr id="6" name="Rounded Rectangle 5"/>
-          <p:cNvSpPr/>
-          <p:nvPr/>
-        </p:nvSpPr>
-        <p:spPr>
-          <a:xfrm>
-            <a:off x="914400" y="4389120"/>
-            <a:ext cx="10362895" cy="1645920"/>
-          </a:xfrm>
-          <a:prstGeom prst="roundRect">
-            <a:avLst/>
-          </a:prstGeom>
-          <a:solidFill>
-            <a:srgbClr val="1E293B"/>
-          </a:solidFill>
-          <a:ln>
-            <a:solidFill>
-              <a:srgbClr val="087F76"/>
-            </a:solidFill>
-          </a:ln>
-        </p:spPr>
-        <p:style>
-          <a:lnRef idx="1">
-            <a:schemeClr val="accent1"/>
-          </a:lnRef>
-          <a:fillRef idx="3">
-            <a:schemeClr val="accent1"/>
-          </a:fillRef>
-          <a:effectRef idx="2">
-            <a:schemeClr val="accent1"/>
-          </a:effectRef>
-          <a:fontRef idx="minor">
-            <a:schemeClr val="lt1"/>
-          </a:fontRef>
-        </p:style>
-        <p:txBody>
-          <a:bodyPr rtlCol="0" anchor="ctr" wrap="square"/>
-          <a:lstStyle/>
-          <a:p>
-            <a:pPr algn="ctr">
-              <a:defRPr sz="1500">
-                <a:solidFill>
-                  <a:srgbClr val="087F76"/>
-                </a:solidFill>
-                <a:latin typeface="Courier New"/>
-              </a:defRPr>
-            </a:pPr>
-            <a:r>
-              <a:t>&gt; system_check --lab 16 --topic 'dependency-injection'</a:t>
-            </a:r>
-            <a:br/>
-            <a:r>
-              <a:t>&gt; author: Lukman / lukman-ss | status: PRODUCTION VERIFIED</a:t>
-            </a:r>
-            <a:br/>
-            <a:r>
-              <a:t>&gt; commit: 76f0059 | tests: PASS</a:t>
+              <a:t>Constructor Injection vs Service Locator: Trade-off Konkret untuk Testability</a:t>
+            </a:r>
+          </a:p>
+        </p:txBody>
+      </p:sp>
+      <p:sp>
+        <p:nvSpPr>
+          <p:cNvPr id="6" name="TextBox 5"/>
+          <p:cNvSpPr txBox="1"/>
+          <p:nvPr/>
+        </p:nvSpPr>
+        <p:spPr>
+          <a:xfrm>
+            <a:off x="914400" y="5303520"/>
+            <a:ext cx="5486400" cy="548640"/>
+          </a:xfrm>
+          <a:prstGeom prst="rect">
+            <a:avLst/>
+          </a:prstGeom>
+          <a:noFill/>
+        </p:spPr>
+        <p:txBody>
+          <a:bodyPr wrap="none">
+            <a:spAutoFit/>
+          </a:bodyPr>
+          <a:lstStyle/>
+          <a:p>
+            <a:pPr>
+              <a:defRPr sz="1800" b="1">
+                <a:solidFill>
+                  <a:srgbClr val="D97706"/>
+                </a:solidFill>
+              </a:defRPr>
+            </a:pPr>
+            <a:r>
+              <a:t>Lukman / lukman-ss</a:t>
             </a:r>
           </a:p>
         </p:txBody>
@@ -6364,7 +6401,7 @@
               </a:defRPr>
             </a:pPr>
             <a:r>
-              <a:t>Output Demo: Verifikasi Eksekusi Terpisah</a:t>
+              <a:t>Semua 6 Test Pass, Race Detector Clean</a:t>
             </a:r>
           </a:p>
         </p:txBody>
@@ -6399,7 +6436,7 @@
               </a:defRPr>
             </a:pPr>
             <a:r>
-              <a:t>Kedua pola memproses pembayaran dengan implementasi RealGateway yang sama.</a:t>
+              <a:t>Output lokal: PASS 6/6, 0.00s per test case.</a:t>
             </a:r>
           </a:p>
         </p:txBody>
@@ -6452,23 +6489,59 @@
               </a:defRPr>
             </a:pPr>
             <a:r>
-              <a:t>$ go run ./cmd/demo</a:t>
+              <a:t>$ go test -race -v ./tests/</a:t>
             </a:r>
             <a:br/>
             <a:r>
-              <a:t>--- Running Constructor Injection ---</a:t>
+              <a:t>=== RUN   TestProcessor_Success</a:t>
             </a:r>
             <a:br/>
             <a:r>
-              <a:t>RealGateway charging 100 USD</a:t>
+              <a:t>--- PASS: TestProcessor_Success (0.00s)</a:t>
             </a:r>
             <a:br/>
             <a:r>
-              <a:t>--- Running Service Locator ---</a:t>
+              <a:t>=== RUN   TestProcessor_GatewayError</a:t>
             </a:r>
             <a:br/>
             <a:r>
-              <a:t>RealGateway charging 200 USD</a:t>
+              <a:t>--- PASS: TestProcessor_GatewayError (0.00s)</a:t>
+            </a:r>
+            <a:br/>
+            <a:r>
+              <a:t>=== RUN   TestProcessor_InvalidAmount</a:t>
+            </a:r>
+            <a:br/>
+            <a:r>
+              <a:t>--- PASS: TestProcessor_InvalidAmount (0.00s)</a:t>
+            </a:r>
+            <a:br/>
+            <a:r>
+              <a:t>=== RUN   TestBadProcessor_Success</a:t>
+            </a:r>
+            <a:br/>
+            <a:r>
+              <a:t>--- PASS: TestBadProcessor_Success (0.00s)</a:t>
+            </a:r>
+            <a:br/>
+            <a:r>
+              <a:t>=== RUN   TestBadProcessor_GatewayError</a:t>
+            </a:r>
+            <a:br/>
+            <a:r>
+              <a:t>--- PASS: TestBadProcessor_GatewayError (0.00s)</a:t>
+            </a:r>
+            <a:br/>
+            <a:r>
+              <a:t>=== RUN   TestBadProcessor_InvalidAmount</a:t>
+            </a:r>
+            <a:br/>
+            <a:r>
+              <a:t>--- PASS: TestBadProcessor_InvalidAmount (0.00s)</a:t>
+            </a:r>
+            <a:br/>
+            <a:r>
+              <a:t>PASS: ok lab16/tests (cached)</a:t>
             </a:r>
           </a:p>
         </p:txBody>
@@ -6506,7 +6579,7 @@
               </a:defRPr>
             </a:pPr>
             <a:r>
-              <a:t>Demo membuktikan kedua pola menghasilkan output fungsional yang sama. Perbedaannya bukan pada runtime behavior, melainkan pada kemudahan pengujian.</a:t>
+              <a:t>Enam test case berlari dalam 0.00s per kasus. Race detector tidak melaporkan warning. Ini membuktikan jalur yang diuji aman dari data race pada goroutine tunggal — bukan berarti seluruh lifecycle production bebas race.</a:t>
             </a:r>
           </a:p>
         </p:txBody>
@@ -6558,7 +6631,7 @@
               </a:defRPr>
             </a:pPr>
             <a:r>
-              <a:t>Identical runtime output does not imply identical architectural maintainability.</a:t>
+              <a:t>Zero race warnings on a small sequential suite prove the tested paths; they do not prove the whole runtime safe.</a:t>
             </a:r>
           </a:p>
         </p:txBody>
@@ -6593,7 +6666,7 @@
               </a:defRPr>
             </a:pPr>
             <a:r>
-              <a:t>cmd/demo/main.go</a:t>
+              <a:t>tests/processor_test.go • README.md</a:t>
             </a:r>
           </a:p>
         </p:txBody>
@@ -6759,7 +6832,7 @@
               </a:defRPr>
             </a:pPr>
             <a:r>
-              <a:t>Test Memvalidasi Alur, Bukan Kesiapan Skala</a:t>
+              <a:t>Angka 0.00s Tidak Otomatis Jadi SLO Production</a:t>
             </a:r>
           </a:p>
         </p:txBody>
@@ -6794,148 +6867,509 @@
               </a:defRPr>
             </a:pPr>
             <a:r>
-              <a:t>Keberhasilan mock membuktikan isolasi logika, bukan keandalan jaringan riil.</a:t>
-            </a:r>
-          </a:p>
-        </p:txBody>
-      </p:sp>
-      <p:sp>
-        <p:nvSpPr>
-          <p:cNvPr id="6" name="TextBox 5"/>
-          <p:cNvSpPr txBox="1"/>
-          <p:nvPr/>
-        </p:nvSpPr>
-        <p:spPr>
-          <a:xfrm>
-            <a:off x="731520" y="1828800"/>
-            <a:ext cx="5120640" cy="3383280"/>
-          </a:xfrm>
-          <a:prstGeom prst="rect">
-            <a:avLst/>
-          </a:prstGeom>
-          <a:noFill/>
-        </p:spPr>
-        <p:txBody>
-          <a:bodyPr wrap="square">
-            <a:spAutoFit/>
-          </a:bodyPr>
-          <a:lstStyle/>
-          <a:p>
-            <a:pPr>
-              <a:defRPr sz="1200" b="1">
-                <a:solidFill>
-                  <a:srgbClr val="087F76"/>
-                </a:solidFill>
-              </a:defRPr>
-            </a:pPr>
-            <a:r>
-              <a:t>YANG DIBUKTIKAN TEST</a:t>
-            </a:r>
-          </a:p>
-          <a:p>
-            <a:pPr>
-              <a:spcAft>
-                <a:spcPts val="400"/>
-              </a:spcAft>
-              <a:defRPr sz="1200">
-                <a:solidFill>
-                  <a:srgbClr val="0B1B2D"/>
-                </a:solidFill>
-              </a:defRPr>
-            </a:pPr>
-            <a:r>
-              <a:t>• Processor mendelegasikan pembayaran ke MockGateway tanpa jaringan.</a:t>
-            </a:r>
-          </a:p>
-          <a:p>
-            <a:pPr>
-              <a:spcAft>
-                <a:spcPts val="400"/>
-              </a:spcAft>
-              <a:defRPr sz="1200">
-                <a:solidFill>
-                  <a:srgbClr val="0B1B2D"/>
-                </a:solidFill>
-              </a:defRPr>
-            </a:pPr>
-            <a:r>
-              <a:t>• Validasi amount &lt;= 0 menolak eksekusi sebelum memanggil gateway.</a:t>
-            </a:r>
-          </a:p>
-          <a:p>
-            <a:pPr>
-              <a:spcAft>
-                <a:spcPts val="400"/>
-              </a:spcAft>
-              <a:defRPr sz="1200">
-                <a:solidFill>
-                  <a:srgbClr val="0B1B2D"/>
-                </a:solidFill>
-              </a:defRPr>
-            </a:pPr>
-            <a:r>
-              <a:t>• Race detector bersih pada seluruh skenario pengujian unit.</a:t>
-            </a:r>
-          </a:p>
-          <a:p>
-            <a:pPr>
-              <a:defRPr sz="1200" b="1">
-                <a:solidFill>
-                  <a:srgbClr val="087F76"/>
-                </a:solidFill>
-              </a:defRPr>
-            </a:pPr>
-            <a:r>
-              <a:t>YANG TIDAK DIBUKTIKAN</a:t>
-            </a:r>
-          </a:p>
-          <a:p>
-            <a:pPr>
-              <a:spcAft>
-                <a:spcPts val="400"/>
-              </a:spcAft>
-              <a:defRPr sz="1200">
-                <a:solidFill>
-                  <a:srgbClr val="0B1B2D"/>
-                </a:solidFill>
-              </a:defRPr>
-            </a:pPr>
-            <a:r>
-              <a:t>• Ketahanan koneksi HTTP saat gateway riil mengalami timeout.</a:t>
-            </a:r>
-          </a:p>
-          <a:p>
-            <a:pPr>
-              <a:spcAft>
-                <a:spcPts val="400"/>
-              </a:spcAft>
-              <a:defRPr sz="1200">
-                <a:solidFill>
-                  <a:srgbClr val="0B1B2D"/>
-                </a:solidFill>
-              </a:defRPr>
-            </a:pPr>
-            <a:r>
-              <a:t>• Manajemen connection pool dan lifecycle pada beban production.</a:t>
-            </a:r>
-          </a:p>
-          <a:p>
-            <a:pPr>
-              <a:spcAft>
-                <a:spcPts val="400"/>
-              </a:spcAft>
-              <a:defRPr sz="1200">
-                <a:solidFill>
-                  <a:srgbClr val="0B1B2D"/>
-                </a:solidFill>
-              </a:defRPr>
-            </a:pPr>
-            <a:r>
-              <a:t>• Keamanan race condition pada shared state antar-goroutine.</a:t>
-            </a:r>
-          </a:p>
-        </p:txBody>
-      </p:sp>
+              <a:t>Waktu eksekusi test ≠ latency gateway nyata; mereka diukur di kondisi berbeda.</a:t>
+            </a:r>
+          </a:p>
+        </p:txBody>
+      </p:sp>
+      <p:graphicFrame>
+        <p:nvGraphicFramePr>
+          <p:cNvPr id="6" name="Table 5"/>
+          <p:cNvGraphicFramePr>
+            <a:graphicFrameLocks noGrp="1"/>
+          </p:cNvGraphicFramePr>
+          <p:nvPr/>
+        </p:nvGraphicFramePr>
+        <p:xfrm>
+          <a:off x="731520" y="1828800"/>
+          <a:ext cx="5120640" cy="2286000"/>
+        </p:xfrm>
+        <a:graphic>
+          <a:graphicData uri="http://schemas.openxmlformats.org/drawingml/2006/table">
+            <a:tbl>
+              <a:tblPr firstRow="1" bandRow="1">
+                <a:tableStyleId>{5C22544A-7EE6-4342-B048-85BDC9FD1C3A}</a:tableStyleId>
+              </a:tblPr>
+              <a:tblGrid>
+                <a:gridCol w="1280160"/>
+                <a:gridCol w="1280160"/>
+                <a:gridCol w="1280160"/>
+                <a:gridCol w="1280160"/>
+              </a:tblGrid>
+              <a:tr h="457200">
+                <a:tc>
+                  <a:txBody>
+                    <a:bodyPr/>
+                    <a:lstStyle/>
+                    <a:p>
+                      <a:pPr>
+                        <a:defRPr b="1" sz="1100">
+                          <a:solidFill>
+                            <a:srgbClr val="FFFFFF"/>
+                          </a:solidFill>
+                        </a:defRPr>
+                      </a:pPr>
+                      <a:r>
+                        <a:t>Metric</a:t>
+                      </a:r>
+                    </a:p>
+                  </a:txBody>
+                  <a:tcPr>
+                    <a:solidFill>
+                      <a:srgbClr val="0B1B2D"/>
+                    </a:solidFill>
+                  </a:tcPr>
+                </a:tc>
+                <a:tc>
+                  <a:txBody>
+                    <a:bodyPr/>
+                    <a:lstStyle/>
+                    <a:p>
+                      <a:pPr>
+                        <a:defRPr b="1" sz="1100">
+                          <a:solidFill>
+                            <a:srgbClr val="FFFFFF"/>
+                          </a:solidFill>
+                        </a:defRPr>
+                      </a:pPr>
+                      <a:r>
+                        <a:t>Nilai</a:t>
+                      </a:r>
+                    </a:p>
+                  </a:txBody>
+                  <a:tcPr>
+                    <a:solidFill>
+                      <a:srgbClr val="0B1B2D"/>
+                    </a:solidFill>
+                  </a:tcPr>
+                </a:tc>
+                <a:tc>
+                  <a:txBody>
+                    <a:bodyPr/>
+                    <a:lstStyle/>
+                    <a:p>
+                      <a:pPr>
+                        <a:defRPr b="1" sz="1100">
+                          <a:solidFill>
+                            <a:srgbClr val="FFFFFF"/>
+                          </a:solidFill>
+                        </a:defRPr>
+                      </a:pPr>
+                      <a:r>
+                        <a:t>Makna</a:t>
+                      </a:r>
+                    </a:p>
+                  </a:txBody>
+                  <a:tcPr>
+                    <a:solidFill>
+                      <a:srgbClr val="0B1B2D"/>
+                    </a:solidFill>
+                  </a:tcPr>
+                </a:tc>
+                <a:tc>
+                  <a:txBody>
+                    <a:bodyPr/>
+                    <a:lstStyle/>
+                    <a:p>
+                      <a:pPr>
+                        <a:defRPr b="1" sz="1100">
+                          <a:solidFill>
+                            <a:srgbClr val="FFFFFF"/>
+                          </a:solidFill>
+                        </a:defRPr>
+                      </a:pPr>
+                      <a:r>
+                        <a:t>Batas</a:t>
+                      </a:r>
+                    </a:p>
+                  </a:txBody>
+                  <a:tcPr>
+                    <a:solidFill>
+                      <a:srgbClr val="0B1B2D"/>
+                    </a:solidFill>
+                  </a:tcPr>
+                </a:tc>
+              </a:tr>
+              <a:tr h="457200">
+                <a:tc>
+                  <a:txBody>
+                    <a:bodyPr/>
+                    <a:lstStyle/>
+                    <a:p>
+                      <a:pPr>
+                        <a:defRPr sz="1000">
+                          <a:solidFill>
+                            <a:srgbClr val="0B1B2D"/>
+                          </a:solidFill>
+                        </a:defRPr>
+                      </a:pPr>
+                      <a:r>
+                        <a:t>Test duration</a:t>
+                      </a:r>
+                    </a:p>
+                  </a:txBody>
+                  <a:tcPr>
+                    <a:solidFill>
+                      <a:srgbClr val="FFFFFF"/>
+                    </a:solidFill>
+                  </a:tcPr>
+                </a:tc>
+                <a:tc>
+                  <a:txBody>
+                    <a:bodyPr/>
+                    <a:lstStyle/>
+                    <a:p>
+                      <a:pPr>
+                        <a:defRPr sz="1000">
+                          <a:solidFill>
+                            <a:srgbClr val="0B1B2D"/>
+                          </a:solidFill>
+                        </a:defRPr>
+                      </a:pPr>
+                      <a:r>
+                        <a:t>0.00s/case</a:t>
+                      </a:r>
+                    </a:p>
+                  </a:txBody>
+                  <a:tcPr>
+                    <a:solidFill>
+                      <a:srgbClr val="FFFFFF"/>
+                    </a:solidFill>
+                  </a:tcPr>
+                </a:tc>
+                <a:tc>
+                  <a:txBody>
+                    <a:bodyPr/>
+                    <a:lstStyle/>
+                    <a:p>
+                      <a:pPr>
+                        <a:defRPr sz="1000">
+                          <a:solidFill>
+                            <a:srgbClr val="0B1B2D"/>
+                          </a:solidFill>
+                        </a:defRPr>
+                      </a:pPr>
+                      <a:r>
+                        <a:t>Unit test in-memory</a:t>
+                      </a:r>
+                    </a:p>
+                  </a:txBody>
+                  <a:tcPr>
+                    <a:solidFill>
+                      <a:srgbClr val="FFFFFF"/>
+                    </a:solidFill>
+                  </a:tcPr>
+                </a:tc>
+                <a:tc>
+                  <a:txBody>
+                    <a:bodyPr/>
+                    <a:lstStyle/>
+                    <a:p>
+                      <a:pPr>
+                        <a:defRPr sz="1000">
+                          <a:solidFill>
+                            <a:srgbClr val="0B1B2D"/>
+                          </a:solidFill>
+                        </a:defRPr>
+                      </a:pPr>
+                      <a:r>
+                        <a:t>Bukan network latency</a:t>
+                      </a:r>
+                    </a:p>
+                  </a:txBody>
+                  <a:tcPr>
+                    <a:solidFill>
+                      <a:srgbClr val="FFFFFF"/>
+                    </a:solidFill>
+                  </a:tcPr>
+                </a:tc>
+              </a:tr>
+              <a:tr h="457200">
+                <a:tc>
+                  <a:txBody>
+                    <a:bodyPr/>
+                    <a:lstStyle/>
+                    <a:p>
+                      <a:pPr>
+                        <a:defRPr sz="1000">
+                          <a:solidFill>
+                            <a:srgbClr val="0B1B2D"/>
+                          </a:solidFill>
+                        </a:defRPr>
+                      </a:pPr>
+                      <a:r>
+                        <a:t>Race warnings</a:t>
+                      </a:r>
+                    </a:p>
+                  </a:txBody>
+                  <a:tcPr>
+                    <a:solidFill>
+                      <a:srgbClr val="FFFFFF"/>
+                    </a:solidFill>
+                  </a:tcPr>
+                </a:tc>
+                <a:tc>
+                  <a:txBody>
+                    <a:bodyPr/>
+                    <a:lstStyle/>
+                    <a:p>
+                      <a:pPr>
+                        <a:defRPr sz="1000">
+                          <a:solidFill>
+                            <a:srgbClr val="0B1B2D"/>
+                          </a:solidFill>
+                        </a:defRPr>
+                      </a:pPr>
+                      <a:r>
+                        <a:t>0</a:t>
+                      </a:r>
+                    </a:p>
+                  </a:txBody>
+                  <a:tcPr>
+                    <a:solidFill>
+                      <a:srgbClr val="FFFFFF"/>
+                    </a:solidFill>
+                  </a:tcPr>
+                </a:tc>
+                <a:tc>
+                  <a:txBody>
+                    <a:bodyPr/>
+                    <a:lstStyle/>
+                    <a:p>
+                      <a:pPr>
+                        <a:defRPr sz="1000">
+                          <a:solidFill>
+                            <a:srgbClr val="0B1B2D"/>
+                          </a:solidFill>
+                        </a:defRPr>
+                      </a:pPr>
+                      <a:r>
+                        <a:t>Sequential test clean</a:t>
+                      </a:r>
+                    </a:p>
+                  </a:txBody>
+                  <a:tcPr>
+                    <a:solidFill>
+                      <a:srgbClr val="FFFFFF"/>
+                    </a:solidFill>
+                  </a:tcPr>
+                </a:tc>
+                <a:tc>
+                  <a:txBody>
+                    <a:bodyPr/>
+                    <a:lstStyle/>
+                    <a:p>
+                      <a:pPr>
+                        <a:defRPr sz="1000">
+                          <a:solidFill>
+                            <a:srgbClr val="0B1B2D"/>
+                          </a:solidFill>
+                        </a:defRPr>
+                      </a:pPr>
+                      <a:r>
+                        <a:t>Belum concurrent test</a:t>
+                      </a:r>
+                    </a:p>
+                  </a:txBody>
+                  <a:tcPr>
+                    <a:solidFill>
+                      <a:srgbClr val="FFFFFF"/>
+                    </a:solidFill>
+                  </a:tcPr>
+                </a:tc>
+              </a:tr>
+              <a:tr h="457200">
+                <a:tc>
+                  <a:txBody>
+                    <a:bodyPr/>
+                    <a:lstStyle/>
+                    <a:p>
+                      <a:pPr>
+                        <a:defRPr sz="1000">
+                          <a:solidFill>
+                            <a:srgbClr val="0B1B2D"/>
+                          </a:solidFill>
+                        </a:defRPr>
+                      </a:pPr>
+                      <a:r>
+                        <a:t>Mock coverage</a:t>
+                      </a:r>
+                    </a:p>
+                  </a:txBody>
+                  <a:tcPr>
+                    <a:solidFill>
+                      <a:srgbClr val="FFFFFF"/>
+                    </a:solidFill>
+                  </a:tcPr>
+                </a:tc>
+                <a:tc>
+                  <a:txBody>
+                    <a:bodyPr/>
+                    <a:lstStyle/>
+                    <a:p>
+                      <a:pPr>
+                        <a:defRPr sz="1000">
+                          <a:solidFill>
+                            <a:srgbClr val="0B1B2D"/>
+                          </a:solidFill>
+                        </a:defRPr>
+                      </a:pPr>
+                      <a:r>
+                        <a:t>Charge captured</a:t>
+                      </a:r>
+                    </a:p>
+                  </a:txBody>
+                  <a:tcPr>
+                    <a:solidFill>
+                      <a:srgbClr val="FFFFFF"/>
+                    </a:solidFill>
+                  </a:tcPr>
+                </a:tc>
+                <a:tc>
+                  <a:txBody>
+                    <a:bodyPr/>
+                    <a:lstStyle/>
+                    <a:p>
+                      <a:pPr>
+                        <a:defRPr sz="1000">
+                          <a:solidFill>
+                            <a:srgbClr val="0B1B2D"/>
+                          </a:solidFill>
+                        </a:defRPr>
+                      </a:pPr>
+                      <a:r>
+                        <a:t>Path: valid+error+invalid</a:t>
+                      </a:r>
+                    </a:p>
+                  </a:txBody>
+                  <a:tcPr>
+                    <a:solidFill>
+                      <a:srgbClr val="FFFFFF"/>
+                    </a:solidFill>
+                  </a:tcPr>
+                </a:tc>
+                <a:tc>
+                  <a:txBody>
+                    <a:bodyPr/>
+                    <a:lstStyle/>
+                    <a:p>
+                      <a:pPr>
+                        <a:defRPr sz="1000">
+                          <a:solidFill>
+                            <a:srgbClr val="0B1B2D"/>
+                          </a:solidFill>
+                        </a:defRPr>
+                      </a:pPr>
+                      <a:r>
+                        <a:t>Belum edge: timeout</a:t>
+                      </a:r>
+                    </a:p>
+                  </a:txBody>
+                  <a:tcPr>
+                    <a:solidFill>
+                      <a:srgbClr val="FFFFFF"/>
+                    </a:solidFill>
+                  </a:tcPr>
+                </a:tc>
+              </a:tr>
+              <a:tr h="457200">
+                <a:tc>
+                  <a:txBody>
+                    <a:bodyPr/>
+                    <a:lstStyle/>
+                    <a:p>
+                      <a:pPr>
+                        <a:defRPr sz="1000">
+                          <a:solidFill>
+                            <a:srgbClr val="0B1B2D"/>
+                          </a:solidFill>
+                        </a:defRPr>
+                      </a:pPr>
+                      <a:r>
+                        <a:t>Demo output</a:t>
+                      </a:r>
+                    </a:p>
+                  </a:txBody>
+                  <a:tcPr>
+                    <a:solidFill>
+                      <a:srgbClr val="FFFFFF"/>
+                    </a:solidFill>
+                  </a:tcPr>
+                </a:tc>
+                <a:tc>
+                  <a:txBody>
+                    <a:bodyPr/>
+                    <a:lstStyle/>
+                    <a:p>
+                      <a:pPr>
+                        <a:defRPr sz="1000">
+                          <a:solidFill>
+                            <a:srgbClr val="0B1B2D"/>
+                          </a:solidFill>
+                        </a:defRPr>
+                      </a:pPr>
+                      <a:r>
+                        <a:t>RealGateway charging</a:t>
+                      </a:r>
+                    </a:p>
+                  </a:txBody>
+                  <a:tcPr>
+                    <a:solidFill>
+                      <a:srgbClr val="FFFFFF"/>
+                    </a:solidFill>
+                  </a:tcPr>
+                </a:tc>
+                <a:tc>
+                  <a:txBody>
+                    <a:bodyPr/>
+                    <a:lstStyle/>
+                    <a:p>
+                      <a:pPr>
+                        <a:defRPr sz="1000">
+                          <a:solidFill>
+                            <a:srgbClr val="0B1B2D"/>
+                          </a:solidFill>
+                        </a:defRPr>
+                      </a:pPr>
+                      <a:r>
+                        <a:t>Integration manual verified</a:t>
+                      </a:r>
+                    </a:p>
+                  </a:txBody>
+                  <a:tcPr>
+                    <a:solidFill>
+                      <a:srgbClr val="FFFFFF"/>
+                    </a:solidFill>
+                  </a:tcPr>
+                </a:tc>
+                <a:tc>
+                  <a:txBody>
+                    <a:bodyPr/>
+                    <a:lstStyle/>
+                    <a:p>
+                      <a:pPr>
+                        <a:defRPr sz="1000">
+                          <a:solidFill>
+                            <a:srgbClr val="0B1B2D"/>
+                          </a:solidFill>
+                        </a:defRPr>
+                      </a:pPr>
+                      <a:r>
+                        <a:t>Bukan automated claim</a:t>
+                      </a:r>
+                    </a:p>
+                  </a:txBody>
+                  <a:tcPr>
+                    <a:solidFill>
+                      <a:srgbClr val="FFFFFF"/>
+                    </a:solidFill>
+                  </a:tcPr>
+                </a:tc>
+              </a:tr>
+            </a:tbl>
+          </a:graphicData>
+        </a:graphic>
+      </p:graphicFrame>
       <p:sp>
         <p:nvSpPr>
           <p:cNvPr id="7" name="TextBox 6"/>
@@ -6969,12 +7403,7 @@
               </a:defRPr>
             </a:pPr>
             <a:r>
-              <a:t>Processor mendelegasikan pembayaran ke MockGateway tanpa jaringan. Validasi amount &lt;= 0 menolak eksekusi sebelum memanggil gateway. Race detector bersih pada seluruh skenario pengujian unit.</a:t>
-            </a:r>
-            <a:br/>
-            <a:br/>
-            <a:r>
-              <a:t>Ketahanan koneksi HTTP saat gateway riil mengalami timeout. Manajemen connection pool dan lifecycle pada beban production. Keamanan race condition pada shared state antar-goroutine.</a:t>
+              <a:t>Tabel ini memetakan setiap angka ke interpretasi yang benar dan batasannya. Test duration 0.00s berarti operasi in-memory cepat, bukan gateway berlatensi nol. Race warnings nol berarti jalur sequential aman, bukan berarti konkurensi production aman. Cakupannya mengikuti test.</a:t>
             </a:r>
           </a:p>
         </p:txBody>
@@ -7026,7 +7455,7 @@
               </a:defRPr>
             </a:pPr>
             <a:r>
-              <a:t>Passing mock tests prove logic isolation; production still requires resilience tests.</a:t>
+              <a:t>Benchmark numbers are context-bound; they measure what the harness measures, nothing more.</a:t>
             </a:r>
           </a:p>
         </p:txBody>
@@ -7061,7 +7490,7 @@
               </a:defRPr>
             </a:pPr>
             <a:r>
-              <a:t>tests/processor_test.go</a:t>
+              <a:t>tests/processor_test.go • cmd/demo/main.go</a:t>
             </a:r>
           </a:p>
         </p:txBody>
@@ -7227,7 +7656,7 @@
               </a:defRPr>
             </a:pPr>
             <a:r>
-              <a:t>Trade-off: Fleksibilitas vs Kejelasan Kontrak</a:t>
+              <a:t>Trade-off: Boilerplate Konstruksi vs Kemampuan Uji</a:t>
             </a:r>
           </a:p>
         </p:txBody>
@@ -7262,7 +7691,7 @@
               </a:defRPr>
             </a:pPr>
             <a:r>
-              <a:t>Service locator memudahkan penambahan service baru tetapi menutupi kontrak.</a:t>
+              <a:t>Menambah satu parameter constructor membuka jalan untuk mock isolation.</a:t>
             </a:r>
           </a:p>
         </p:txBody>
@@ -7297,7 +7726,7 @@
               </a:defRPr>
             </a:pPr>
             <a:r>
-              <a:t>CONSTRUCTOR INJECTION</a:t>
+              <a:t>BIAYA &amp; MANFAAT</a:t>
             </a:r>
           </a:p>
           <a:p>
@@ -7312,7 +7741,7 @@
               </a:defRPr>
             </a:pPr>
             <a:r>
-              <a:t>• Kontrak terlihat jelas pada signature konstruktor.</a:t>
+              <a:t>• Biaya: Tambah 1 parameter di constructor</a:t>
             </a:r>
           </a:p>
           <a:p>
@@ -7327,7 +7756,7 @@
               </a:defRPr>
             </a:pPr>
             <a:r>
-              <a:t>• Compiler menolak caller jika argumen kurang.</a:t>
+              <a:t>• Manfaat: Mocking tanpa network call di unit test</a:t>
             </a:r>
           </a:p>
           <a:p>
@@ -7342,19 +7771,7 @@
               </a:defRPr>
             </a:pPr>
             <a:r>
-              <a:t>• Constructor berisiko panjang jika kelas terlalu sibuk.</a:t>
-            </a:r>
-          </a:p>
-          <a:p>
-            <a:pPr>
-              <a:defRPr sz="1200" b="1">
-                <a:solidFill>
-                  <a:srgbClr val="087F76"/>
-                </a:solidFill>
-              </a:defRPr>
-            </a:pPr>
-            <a:r>
-              <a:t>SERVICE LOCATOR</a:t>
+              <a:t>• Biaya: Composition root perlu tahu concrete type</a:t>
             </a:r>
           </a:p>
           <a:p>
@@ -7369,37 +7786,7 @@
               </a:defRPr>
             </a:pPr>
             <a:r>
-              <a:t>• Signature konstruktor tetap ringkas menerima Container tunggal.</a:t>
-            </a:r>
-          </a:p>
-          <a:p>
-            <a:pPr>
-              <a:spcAft>
-                <a:spcPts val="400"/>
-              </a:spcAft>
-              <a:defRPr sz="1200">
-                <a:solidFill>
-                  <a:srgbClr val="0B1B2D"/>
-                </a:solidFill>
-              </a:defRPr>
-            </a:pPr>
-            <a:r>
-              <a:t>• Kebutuhan dependensi tersembunyi di dalam implementasi method.</a:t>
-            </a:r>
-          </a:p>
-          <a:p>
-            <a:pPr>
-              <a:spcAft>
-                <a:spcPts val="400"/>
-              </a:spcAft>
-              <a:defRPr sz="1200">
-                <a:solidFill>
-                  <a:srgbClr val="0B1B2D"/>
-                </a:solidFill>
-              </a:defRPr>
-            </a:pPr>
-            <a:r>
-              <a:t>• Kompilasi lolos meski service belum terdaftar di container.</a:t>
+              <a:t>• Manfaat: Error propagation tetap terverifikasi rapi</a:t>
             </a:r>
           </a:p>
         </p:txBody>
@@ -7437,12 +7824,7 @@
               </a:defRPr>
             </a:pPr>
             <a:r>
-              <a:t>Kontrak terlihat jelas pada signature konstruktor. Compiler menolak caller jika argumen kurang. Constructor berisiko panjang jika kelas terlalu sibuk.</a:t>
-            </a:r>
-            <a:br/>
-            <a:br/>
-            <a:r>
-              <a:t>Signature konstruktor tetap ringkas menerima Container tunggal. Kebutuhan dependensi tersembunyi di dalam implementasi method. Kompilasi lolos meski service belum terdaftar di container.</a:t>
+              <a:t>Trade-off ini sebanding: satu baris boilerplate di constructor mendapatkannya isolated testing. Namun mock isolation bukan berarti production safety — ia hanya menghilangkan dependency eksternal dari test. Validasi amount dan error wrapping masih membutuhkan test terpisah.</a:t>
             </a:r>
           </a:p>
         </p:txBody>
@@ -7494,7 +7876,7 @@
               </a:defRPr>
             </a:pPr>
             <a:r>
-              <a:t>Explicit constructor parameters protect architectural clarity at the cost of signature length.</a:t>
+              <a:t>DI trades a small construction cost for isolation gains; it does not buy production safety.</a:t>
             </a:r>
           </a:p>
         </p:txBody>
@@ -7529,7 +7911,7 @@
               </a:defRPr>
             </a:pPr>
             <a:r>
-              <a:t>content/02-master-draft.md</a:t>
+              <a:t>internal/di/processor.go • tests/processor_test.go</a:t>
             </a:r>
           </a:p>
         </p:txBody>
@@ -7695,7 +8077,7 @@
               </a:defRPr>
             </a:pPr>
             <a:r>
-              <a:t>Value Object Tidak Memerlukan Injeksi</a:t>
+              <a:t>Nil Guard Menutupi Runtime Risk</a:t>
             </a:r>
           </a:p>
         </p:txBody>
@@ -7730,7 +8112,7 @@
               </a:defRPr>
             </a:pPr>
             <a:r>
-              <a:t>Struktur data tanpa dependensi infrastruktur cukup diinstansiasi langsung.</a:t>
+              <a:t>Menambahkan pengecekan nil pada constructor membuat dependency wajib terlihat.</a:t>
             </a:r>
           </a:p>
         </p:txBody>
@@ -7783,15 +8165,15 @@
               </a:defRPr>
             </a:pPr>
             <a:r>
-              <a:t>func (p *Processor) ProcessPayment(amount int) error {</a:t>
+              <a:t>func NewProcessor(g PaymentGateway) *Processor {</a:t>
             </a:r>
             <a:br/>
             <a:r>
-              <a:t>    if amount &lt;= 0 {</a:t>
+              <a:t>    if g == nil {</a:t>
             </a:r>
             <a:br/>
             <a:r>
-              <a:t>        return errors.New("invalid amount")</a:t>
+              <a:t>        return nil // atau panic, tergantung kebijakan tim</a:t>
             </a:r>
             <a:br/>
             <a:r>
@@ -7799,11 +8181,7 @@
             </a:r>
             <a:br/>
             <a:r>
-              <a:t>    m := Money{Amount: amount, Currency: "USD"}</a:t>
-            </a:r>
-            <a:br/>
-            <a:r>
-              <a:t>    return p.gateway.Charge(m)</a:t>
+              <a:t>    return &amp;Processor{gateway: g}</a:t>
             </a:r>
             <a:br/>
             <a:r>
@@ -7845,7 +8223,7 @@
               </a:defRPr>
             </a:pPr>
             <a:r>
-              <a:t>Money adalah value object murni tanpa efek samping. Menyuntikkan factory untuk struct sederhana seperti Money adalah over-engineering yang tidak perlu.</a:t>
+              <a:t>Menambahkan nil check pada constructor merupakan langkah selanjutnya yang disarankan. Saat ini, constructor menerima nil tanpa peringatan — caller akan menghadapi nil pointer panic saat gateway.Charge dipanggil. Lab ini belum menerapkan guard tersebut; ia sengaja mempertahankan pola minimal untuk fokus pada kontras DI vs Service Locator.</a:t>
             </a:r>
           </a:p>
         </p:txBody>
@@ -7897,7 +8275,7 @@
               </a:defRPr>
             </a:pPr>
             <a:r>
-              <a:t>Reserve dependency injection for behavioral services, not pure value objects.</a:t>
+              <a:t>Explicit nil checks convert runtime surprises into compile-time or call-site failures.</a:t>
             </a:r>
           </a:p>
         </p:txBody>
@@ -7932,7 +8310,7 @@
               </a:defRPr>
             </a:pPr>
             <a:r>
-              <a:t>internal/di/processor.go:15-21</a:t>
+              <a:t>internal/di/processor.go</a:t>
             </a:r>
           </a:p>
         </p:txBody>
@@ -8098,7 +8476,7 @@
               </a:defRPr>
             </a:pPr>
             <a:r>
-              <a:t>Sebelum vs Sesudah Constructor Injection</a:t>
+              <a:t>Sebelum vs Sesudah: Konstruktor Injection</a:t>
             </a:r>
           </a:p>
         </p:txBody>
@@ -8133,7 +8511,7 @@
               </a:defRPr>
             </a:pPr>
             <a:r>
-              <a:t>Mengubah instansiasi internal menjadi penyuntikan kontrak eksternal.</a:t>
+              <a:t>Perubahan hanya di signature; domain logic tetap identik.</a:t>
             </a:r>
           </a:p>
         </p:txBody>
@@ -8168,7 +8546,7 @@
               </a:defRPr>
             </a:pPr>
             <a:r>
-              <a:t>HARDCODED REAL GATEWAY</a:t>
+              <a:t>BEFORE (TIGHT COUPLING)</a:t>
             </a:r>
           </a:p>
           <a:p>
@@ -8183,7 +8561,7 @@
               </a:defRPr>
             </a:pPr>
             <a:r>
-              <a:t>• Processor membuat new RealGateway() di method.</a:t>
+              <a:t>• Processor { gateway RealGateway }</a:t>
             </a:r>
           </a:p>
           <a:p>
@@ -8198,7 +8576,7 @@
               </a:defRPr>
             </a:pPr>
             <a:r>
-              <a:t>• Test terpaksa memanggil network eksternal.</a:t>
+              <a:t>NewProcessor() → &amp;Processor{gateway: &amp;RealGateway{}}</a:t>
             </a:r>
           </a:p>
           <a:p>
@@ -8213,19 +8591,7 @@
               </a:defRPr>
             </a:pPr>
             <a:r>
-              <a:t>• Gagal ganti provider tanpa mengubah domain code.</a:t>
-            </a:r>
-          </a:p>
-          <a:p>
-            <a:pPr>
-              <a:defRPr sz="1200" b="1">
-                <a:solidFill>
-                  <a:srgbClr val="087F76"/>
-                </a:solidFill>
-              </a:defRPr>
-            </a:pPr>
-            <a:r>
-              <a:t>CONSTRUCTOR INJECTION</a:t>
+              <a:t>• Test: harus pakai RealGateway atau setup mocking kompleks</a:t>
             </a:r>
           </a:p>
           <a:p>
@@ -8240,7 +8606,19 @@
               </a:defRPr>
             </a:pPr>
             <a:r>
-              <a:t>• Processor menerima interface PaymentGateway.</a:t>
+              <a:t>• Swap: edit seluruh call site</a:t>
+            </a:r>
+          </a:p>
+          <a:p>
+            <a:pPr>
+              <a:defRPr sz="1200" b="1">
+                <a:solidFill>
+                  <a:srgbClr val="087F76"/>
+                </a:solidFill>
+              </a:defRPr>
+            </a:pPr>
+            <a:r>
+              <a:t>AFTER (CONSTRUCTOR INJECTION)</a:t>
             </a:r>
           </a:p>
           <a:p>
@@ -8255,7 +8633,7 @@
               </a:defRPr>
             </a:pPr>
             <a:r>
-              <a:t>• Test menyuntikkan MockGateway in-memory seketika.</a:t>
+              <a:t>• Processor { gateway PaymentGateway }</a:t>
             </a:r>
           </a:p>
           <a:p>
@@ -8270,7 +8648,37 @@
               </a:defRPr>
             </a:pPr>
             <a:r>
-              <a:t>• Caller bebas menukar provider di composition root.</a:t>
+              <a:t>NewProcessor(g PaymentGateway) → &amp;Processor{gateway: g}</a:t>
+            </a:r>
+          </a:p>
+          <a:p>
+            <a:pPr>
+              <a:spcAft>
+                <a:spcPts val="400"/>
+              </a:spcAft>
+              <a:defRPr sz="1200">
+                <a:solidFill>
+                  <a:srgbClr val="0B1B2D"/>
+                </a:solidFill>
+              </a:defRPr>
+            </a:pPr>
+            <a:r>
+              <a:t>• Test: cukup passed MockGateway{}</a:t>
+            </a:r>
+          </a:p>
+          <a:p>
+            <a:pPr>
+              <a:spcAft>
+                <a:spcPts val="400"/>
+              </a:spcAft>
+              <a:defRPr sz="1200">
+                <a:solidFill>
+                  <a:srgbClr val="0B1B2D"/>
+                </a:solidFill>
+              </a:defRPr>
+            </a:pPr>
+            <a:r>
+              <a:t>• Swap: satu baris di main.go</a:t>
             </a:r>
           </a:p>
         </p:txBody>
@@ -8308,12 +8716,7 @@
               </a:defRPr>
             </a:pPr>
             <a:r>
-              <a:t>Processor membuat new RealGateway() di method. Test terpaksa memanggil network eksternal. Gagal ganti provider tanpa mengubah domain code.</a:t>
-            </a:r>
-            <a:br/>
-            <a:br/>
-            <a:r>
-              <a:t>Processor menerima interface PaymentGateway. Test menyuntikkan MockGateway in-memory seketika. Caller bebas menukar provider di composition root.</a:t>
+              <a:t>Perbandingan struktural ini menunjukkan bahwa perubahan terbesar bukan di dalam Processor, melainkan di titik komposisinya. Domain logic tetap sama; yang berubah adalah siapa yang bertanggung jawab atas concrete type. Ini bukan berarti semua sistem harus melalui transformasi serupa — ia hanya menunjukkan trade-off yang diambil lab ini.</a:t>
             </a:r>
           </a:p>
         </p:txBody>
@@ -8365,7 +8768,7 @@
               </a:defRPr>
             </a:pPr>
             <a:r>
-              <a:t>Externalizing construction decouples business logic from concrete infrastructure.</a:t>
+              <a:t>The biggest change is at the composition boundary, not inside the domain logic.</a:t>
             </a:r>
           </a:p>
         </p:txBody>
@@ -8566,7 +8969,7 @@
               </a:defRPr>
             </a:pPr>
             <a:r>
-              <a:t>Batasan Lab: Manual Wiring In-Memory</a:t>
+              <a:t>Apa yang Tidak Dicakup oleh Lab Ini</a:t>
             </a:r>
           </a:p>
         </p:txBody>
@@ -8601,7 +9004,7 @@
               </a:defRPr>
             </a:pPr>
             <a:r>
-              <a:t>Lab ini membuktikan struktur injeksi murni tanpa framework otomatis.</a:t>
+              <a:t>Laboratorium ini hanya membuktikan pola struktural, bukan skalabilitas production.</a:t>
             </a:r>
           </a:p>
         </p:txBody>
@@ -8636,7 +9039,7 @@
               </a:defRPr>
             </a:pPr>
             <a:r>
-              <a:t>CAKUPAN IMPLEMENTASI</a:t>
+              <a:t>YANG DILAB</a:t>
             </a:r>
           </a:p>
           <a:p>
@@ -8651,7 +9054,7 @@
               </a:defRPr>
             </a:pPr>
             <a:r>
-              <a:t>• Manual composition root di cmd/demo/main.go.</a:t>
+              <a:t>• Kontras struktural antara Constructor Injection dan Service Locator.</a:t>
             </a:r>
           </a:p>
           <a:p>
@@ -8666,7 +9069,7 @@
               </a:defRPr>
             </a:pPr>
             <a:r>
-              <a:t>• Single interface PaymentGateway dan implementasi mock.</a:t>
+              <a:t>• Verifikasi mock substitution bekerja pada test sequential.</a:t>
             </a:r>
           </a:p>
           <a:p>
@@ -8681,7 +9084,7 @@
               </a:defRPr>
             </a:pPr>
             <a:r>
-              <a:t>• Validasi domain sebelum delegasi ke infrastruktur.</a:t>
+              <a:t>• Race detector bersih pada test suite saat ini.</a:t>
             </a:r>
           </a:p>
           <a:p>
@@ -8693,7 +9096,7 @@
               </a:defRPr>
             </a:pPr>
             <a:r>
-              <a:t>TIDAK TERCAKUP DALAM LAB</a:t>
+              <a:t>YANG TIDAK DILAB</a:t>
             </a:r>
           </a:p>
           <a:p>
@@ -8708,7 +9111,7 @@
               </a:defRPr>
             </a:pPr>
             <a:r>
-              <a:t>• DI framework otomatis seperti Wire, Dig, atau Fx.</a:t>
+              <a:t>• Lifecycle management (singleton, scoped, transient).</a:t>
             </a:r>
           </a:p>
           <a:p>
@@ -8723,7 +9126,7 @@
               </a:defRPr>
             </a:pPr>
             <a:r>
-              <a:t>• Lifecycle management: Singleton, Scoped, dan Transient.</a:t>
+              <a:t>• Performance overhead reflection-based DI frameworks.</a:t>
             </a:r>
           </a:p>
           <a:p>
@@ -8738,7 +9141,22 @@
               </a:defRPr>
             </a:pPr>
             <a:r>
-              <a:t>• Scope validation untuk mencegah memory leak antar-request.</a:t>
+              <a:t>• Concurrent access patterns pada shared dependencies.</a:t>
+            </a:r>
+          </a:p>
+          <a:p>
+            <a:pPr>
+              <a:spcAft>
+                <a:spcPts val="400"/>
+              </a:spcAft>
+              <a:defRPr sz="1200">
+                <a:solidFill>
+                  <a:srgbClr val="0B1B2D"/>
+                </a:solidFill>
+              </a:defRPr>
+            </a:pPr>
+            <a:r>
+              <a:t>• Production defect rate reduction claim.</a:t>
             </a:r>
           </a:p>
         </p:txBody>
@@ -8776,12 +9194,7 @@
               </a:defRPr>
             </a:pPr>
             <a:r>
-              <a:t>Manual composition root di cmd/demo/main.go. Single interface PaymentGateway dan implementasi mock. Validasi domain sebelum delegasi ke infrastruktur.</a:t>
-            </a:r>
-            <a:br/>
-            <a:br/>
-            <a:r>
-              <a:t>DI framework otomatis seperti Wire, Dig, atau Fx. Lifecycle management: Singleton, Scoped, dan Transient. Scope validation untuk mencegah memory leak antar-request.</a:t>
+              <a:t>Lab ini sengaja membatasi diri pada pola struktural dasar. Ia tidak mengklaim bahwa constructor injection menghasilkan production-ready code tanpa pertimbangan lebih lanjut. Lifecycle management, concurrency safety, dan framework integration adalah topik yang masih perlu penyelidikan terpisah.</a:t>
             </a:r>
           </a:p>
         </p:txBody>
@@ -8833,7 +9246,7 @@
               </a:defRPr>
             </a:pPr>
             <a:r>
-              <a:t>Manual wiring demonstrates the core principle without the complexity of automated frameworks.</a:t>
+              <a:t>A lab proves what it designs to prove; it does not absolve you from production considerations.</a:t>
             </a:r>
           </a:p>
         </p:txBody>
@@ -8868,7 +9281,7 @@
               </a:defRPr>
             </a:pPr>
             <a:r>
-              <a:t>engineering-audit/05-gaps.md</a:t>
+              <a:t>content/02-master-draft.md • README.md</a:t>
             </a:r>
           </a:p>
         </p:txBody>
@@ -9034,7 +9447,7 @@
               </a:defRPr>
             </a:pPr>
             <a:r>
-              <a:t>Kasus Batas: Penanganan Parameter Tidak Valid</a:t>
+              <a:t>Edge Case: Nil Dependency Menghasilkan Panic</a:t>
             </a:r>
           </a:p>
         </p:txBody>
@@ -9069,15 +9482,15 @@
               </a:defRPr>
             </a:pPr>
             <a:r>
-              <a:t>Validasi domain wajib memblokir eksekusi sebelum menyentuh gateway.</a:t>
-            </a:r>
-          </a:p>
-        </p:txBody>
-      </p:sp>
-      <p:sp>
-        <p:nvSpPr>
-          <p:cNvPr id="6" name="Rounded Rectangle 5"/>
-          <p:cNvSpPr/>
+              <a:t>NewProcessor(nil) lulus konstrutor; panic terjadi saat Charge dipanggil.</a:t>
+            </a:r>
+          </a:p>
+        </p:txBody>
+      </p:sp>
+      <p:sp>
+        <p:nvSpPr>
+          <p:cNvPr id="6" name="TextBox 5"/>
+          <p:cNvSpPr txBox="1"/>
           <p:nvPr/>
         </p:nvSpPr>
         <p:spPr>
@@ -9085,11 +9498,144 @@
             <a:off x="731520" y="1828800"/>
             <a:ext cx="5120640" cy="3383280"/>
           </a:xfrm>
-          <a:prstGeom prst="roundRect">
+          <a:prstGeom prst="rect">
+            <a:avLst/>
+          </a:prstGeom>
+          <a:noFill/>
+        </p:spPr>
+        <p:txBody>
+          <a:bodyPr wrap="square">
+            <a:spAutoFit/>
+          </a:bodyPr>
+          <a:lstStyle/>
+          <a:p>
+            <a:pPr>
+              <a:defRPr sz="1200" b="1">
+                <a:solidFill>
+                  <a:srgbClr val="087F76"/>
+                </a:solidFill>
+              </a:defRPr>
+            </a:pPr>
+            <a:r>
+              <a:t>SKENARIO EDGE</a:t>
+            </a:r>
+          </a:p>
+          <a:p>
+            <a:pPr>
+              <a:spcAft>
+                <a:spcPts val="400"/>
+              </a:spcAft>
+              <a:defRPr sz="1200">
+                <a:solidFill>
+                  <a:srgbClr val="0B1B2D"/>
+                </a:solidFill>
+              </a:defRPr>
+            </a:pPr>
+            <a:r>
+              <a:t>• Caller mengoper nil sebagai PaymentGateway.</a:t>
+            </a:r>
+          </a:p>
+          <a:p>
+            <a:pPr>
+              <a:spcAft>
+                <a:spcPts val="400"/>
+              </a:spcAft>
+              <a:defRPr sz="1200">
+                <a:solidFill>
+                  <a:srgbClr val="0B1B2D"/>
+                </a:solidFill>
+              </a:defRPr>
+            </a:pPr>
+            <a:r>
+              <a:t>• Constructor tidak menolak; Processor tetap terbuat.</a:t>
+            </a:r>
+          </a:p>
+          <a:p>
+            <a:pPr>
+              <a:spcAft>
+                <a:spcPts val="400"/>
+              </a:spcAft>
+              <a:defRPr sz="1200">
+                <a:solidFill>
+                  <a:srgbClr val="0B1B2D"/>
+                </a:solidFill>
+              </a:defRPr>
+            </a:pPr>
+            <a:r>
+              <a:t>ProcessPayment(100) → gateway.Charge(m) → nil pointer panic.</a:t>
+            </a:r>
+          </a:p>
+          <a:p>
+            <a:pPr>
+              <a:spcAft>
+                <a:spcPts val="400"/>
+              </a:spcAft>
+              <a:defRPr sz="1200">
+                <a:solidFill>
+                  <a:srgbClr val="0B1B2D"/>
+                </a:solidFill>
+              </a:defRPr>
+            </a:pPr>
+            <a:r>
+              <a:t>• Error tidak ter-catch; crash terjadi di runtime.</a:t>
+            </a:r>
+          </a:p>
+        </p:txBody>
+      </p:sp>
+      <p:sp>
+        <p:nvSpPr>
+          <p:cNvPr id="7" name="TextBox 6"/>
+          <p:cNvSpPr txBox="1"/>
+          <p:nvPr/>
+        </p:nvSpPr>
+        <p:spPr>
+          <a:xfrm>
+            <a:off x="6217920" y="1828800"/>
+            <a:ext cx="5303520" cy="3383280"/>
+          </a:xfrm>
+          <a:prstGeom prst="rect">
+            <a:avLst/>
+          </a:prstGeom>
+          <a:noFill/>
+        </p:spPr>
+        <p:txBody>
+          <a:bodyPr wrap="square">
+            <a:spAutoFit/>
+          </a:bodyPr>
+          <a:lstStyle/>
+          <a:p>
+            <a:pPr>
+              <a:lnSpc>
+                <a:spcPct val="135000"/>
+              </a:lnSpc>
+              <a:defRPr sz="1300">
+                <a:solidFill>
+                  <a:srgbClr val="0B1B2D"/>
+                </a:solidFill>
+              </a:defRPr>
+            </a:pPr>
+            <a:r>
+              <a:t>Nil dependency adalah edge case yang belum ditangani oleh constructor saat ini. Ia bukan kelemahan DI secara prinsip, melainkan konsekuensi dari ketiadaan explicit guard. Dalam production, caller yang bertanggung jawab memastikan non-nil; namun test suite saat ini tidak memiliki case untuk nil input.</a:t>
+            </a:r>
+          </a:p>
+        </p:txBody>
+      </p:sp>
+      <p:sp>
+        <p:nvSpPr>
+          <p:cNvPr id="8" name="Rectangle 7"/>
+          <p:cNvSpPr/>
+          <p:nvPr/>
+        </p:nvSpPr>
+        <p:spPr>
+          <a:xfrm>
+            <a:off x="731520" y="5394960"/>
+            <a:ext cx="10728655" cy="594360"/>
+          </a:xfrm>
+          <a:prstGeom prst="rect">
             <a:avLst/>
           </a:prstGeom>
           <a:solidFill>
-            <a:srgbClr val="0B1B2D"/>
+            <a:srgbClr val="087F76"/>
           </a:solidFill>
           <a:ln>
             <a:noFill/>
@@ -9110,125 +9656,6 @@
           </a:fontRef>
         </p:style>
         <p:txBody>
-          <a:bodyPr rtlCol="0" anchor="ctr" wrap="square"/>
-          <a:lstStyle/>
-          <a:p>
-            <a:pPr algn="ctr">
-              <a:defRPr sz="1100">
-                <a:solidFill>
-                  <a:srgbClr val="E2E8F0"/>
-                </a:solidFill>
-                <a:latin typeface="Courier New"/>
-              </a:defRPr>
-            </a:pPr>
-            <a:r>
-              <a:t>proc := di.NewProcessor(mock)</a:t>
-            </a:r>
-            <a:br/>
-            <a:r>
-              <a:t>err := proc.ProcessPayment(-10)</a:t>
-            </a:r>
-            <a:br/>
-            <a:r>
-              <a:t>if err == nil {</a:t>
-            </a:r>
-            <a:br/>
-            <a:r>
-              <a:t>    t.Fatalf("expected error for negative amount")</a:t>
-            </a:r>
-            <a:br/>
-            <a:r>
-              <a:t>}</a:t>
-            </a:r>
-            <a:br/>
-            <a:r>
-              <a:t>if mock.ChargedMoney.Amount != 0 {</a:t>
-            </a:r>
-            <a:br/>
-            <a:r>
-              <a:t>    t.Errorf("gateway should not have been called")</a:t>
-            </a:r>
-            <a:br/>
-            <a:r>
-              <a:t>}</a:t>
-            </a:r>
-          </a:p>
-        </p:txBody>
-      </p:sp>
-      <p:sp>
-        <p:nvSpPr>
-          <p:cNvPr id="7" name="TextBox 6"/>
-          <p:cNvSpPr txBox="1"/>
-          <p:nvPr/>
-        </p:nvSpPr>
-        <p:spPr>
-          <a:xfrm>
-            <a:off x="6217920" y="1828800"/>
-            <a:ext cx="5303520" cy="3383280"/>
-          </a:xfrm>
-          <a:prstGeom prst="rect">
-            <a:avLst/>
-          </a:prstGeom>
-          <a:noFill/>
-        </p:spPr>
-        <p:txBody>
-          <a:bodyPr wrap="square">
-            <a:spAutoFit/>
-          </a:bodyPr>
-          <a:lstStyle/>
-          <a:p>
-            <a:pPr>
-              <a:lnSpc>
-                <a:spcPct val="135000"/>
-              </a:lnSpc>
-              <a:defRPr sz="1300">
-                <a:solidFill>
-                  <a:srgbClr val="0B1B2D"/>
-                </a:solidFill>
-              </a:defRPr>
-            </a:pPr>
-            <a:r>
-              <a:t>Test memastikan ProcessPayment(-10) gagal seketika dan ChargedMoney.Amount tetap 0. DI tidak meniadakan validasi input di trust boundary.</a:t>
-            </a:r>
-          </a:p>
-        </p:txBody>
-      </p:sp>
-      <p:sp>
-        <p:nvSpPr>
-          <p:cNvPr id="8" name="Rectangle 7"/>
-          <p:cNvSpPr/>
-          <p:nvPr/>
-        </p:nvSpPr>
-        <p:spPr>
-          <a:xfrm>
-            <a:off x="731520" y="5394960"/>
-            <a:ext cx="10728655" cy="594360"/>
-          </a:xfrm>
-          <a:prstGeom prst="rect">
-            <a:avLst/>
-          </a:prstGeom>
-          <a:solidFill>
-            <a:srgbClr val="087F76"/>
-          </a:solidFill>
-          <a:ln>
-            <a:noFill/>
-          </a:ln>
-        </p:spPr>
-        <p:style>
-          <a:lnRef idx="1">
-            <a:schemeClr val="accent1"/>
-          </a:lnRef>
-          <a:fillRef idx="3">
-            <a:schemeClr val="accent1"/>
-          </a:fillRef>
-          <a:effectRef idx="2">
-            <a:schemeClr val="accent1"/>
-          </a:effectRef>
-          <a:fontRef idx="minor">
-            <a:schemeClr val="lt1"/>
-          </a:fontRef>
-        </p:style>
-        <p:txBody>
           <a:bodyPr rtlCol="0" anchor="ctr"/>
           <a:lstStyle/>
           <a:p>
@@ -9240,7 +9667,7 @@
               </a:defRPr>
             </a:pPr>
             <a:r>
-              <a:t>Validate input at domain boundaries before delegating to injected infrastructure.</a:t>
+              <a:t>Absence of a guard is not a DI flaw; it is a defensive programming gap that any pattern must address.</a:t>
             </a:r>
           </a:p>
         </p:txBody>
@@ -9275,7 +9702,7 @@
               </a:defRPr>
             </a:pPr>
             <a:r>
-              <a:t>tests/processor_test.go:47-59</a:t>
+              <a:t>internal/di/processor.go</a:t>
             </a:r>
           </a:p>
         </p:txBody>
@@ -9441,7 +9868,7 @@
               </a:defRPr>
             </a:pPr>
             <a:r>
-              <a:t>Fakta yang Dibuktikan Suite Pengujian</a:t>
+              <a:t>Test Suite Membuktikan Tiga Jalur Saja</a:t>
             </a:r>
           </a:p>
         </p:txBody>
@@ -9476,7 +9903,7 @@
               </a:defRPr>
             </a:pPr>
             <a:r>
-              <a:t>Enam test case memverifikasi perilaku terisolasi pada kedua pola arsitektur.</a:t>
+              <a:t>Happy path, gateway error, dan invalid amount — tidak lebih.</a:t>
             </a:r>
           </a:p>
         </p:txBody>
@@ -9511,7 +9938,7 @@
               </a:defRPr>
             </a:pPr>
             <a:r>
-              <a:t>FAKTA TERVERIFIKASI</a:t>
+              <a:t>YANG DIBUKTIKAN</a:t>
             </a:r>
           </a:p>
           <a:p>
@@ -9526,7 +9953,7 @@
               </a:defRPr>
             </a:pPr>
             <a:r>
-              <a:t>• Processor dan BadProcessor sukses mendelegasikan transaksi valid.</a:t>
+              <a:t>• MockGateway berhasil menangkap panggilan Charge dengan amount dan currency benar.</a:t>
             </a:r>
           </a:p>
           <a:p>
@@ -9541,7 +9968,7 @@
               </a:defRPr>
             </a:pPr>
             <a:r>
-              <a:t>• Error dari PaymentGateway dipropagasikan utuh ke caller.</a:t>
+              <a:t>• Error dari gateway dipropagasikan ke caller tanpa di-suppress.</a:t>
             </a:r>
           </a:p>
           <a:p>
@@ -9556,22 +9983,7 @@
               </a:defRPr>
             </a:pPr>
             <a:r>
-              <a:t>• Input negatif ditolak tanpa memanggil gateway eksternal.</a:t>
-            </a:r>
-          </a:p>
-          <a:p>
-            <a:pPr>
-              <a:spcAft>
-                <a:spcPts val="400"/>
-              </a:spcAft>
-              <a:defRPr sz="1200">
-                <a:solidFill>
-                  <a:srgbClr val="0B1B2D"/>
-                </a:solidFill>
-              </a:defRPr>
-            </a:pPr>
-            <a:r>
-              <a:t>• go test -race tidak mendeteksi data race pada skenario uji.</a:t>
+              <a:t>• Pre-check amount &lt;= 0 mencegah panggilan gateway (ChargedMoney tetap 0).</a:t>
             </a:r>
           </a:p>
         </p:txBody>
@@ -9609,7 +10021,7 @@
               </a:defRPr>
             </a:pPr>
             <a:r>
-              <a:t>Suite pengujian membuktikan bahwa dependency mocking berhasil memisahkan logika domain dari efek samping jaringan pada semua kasus yang diuji.</a:t>
+              <a:t>Ketiga jalur ini membentuk inti verifikasi behavior Processor. Namun test ini membuktikan jalur A, bukan klaim production B. Misalnya, concurrency safety, memory leak, atau integration dengan payment provider sungguhan tidak tercover oleh test suite yang ada.</a:t>
             </a:r>
           </a:p>
         </p:txBody>
@@ -9661,7 +10073,7 @@
               </a:defRPr>
             </a:pPr>
             <a:r>
-              <a:t>Clean unit tests confirm structural wiring under specified test fixtures.</a:t>
+              <a:t>Tests prove the paths they cover; they do not prove the paths they do not traverse.</a:t>
             </a:r>
           </a:p>
         </p:txBody>
@@ -9862,7 +10274,7 @@
               </a:defRPr>
             </a:pPr>
             <a:r>
-              <a:t>Batas Integritas: Apa yang Tidak Diuji</a:t>
+              <a:t>Yang Belum Dibuktikan oleh Test Suite</a:t>
             </a:r>
           </a:p>
         </p:txBody>
@@ -9897,7 +10309,7 @@
               </a:defRPr>
             </a:pPr>
             <a:r>
-              <a:t>Hasil unit test bersih bukan jaminan arsitektur concurrency production aman.</a:t>
+              <a:t>Test sequential tidak menjamin behavior pada konkurensi atau skala besar.</a:t>
             </a:r>
           </a:p>
         </p:txBody>
@@ -9932,7 +10344,7 @@
               </a:defRPr>
             </a:pPr>
             <a:r>
-              <a:t>DI LUAR BUKTI LAB</a:t>
+              <a:t>YANG TIDAK DIBUKTIKAN</a:t>
             </a:r>
           </a:p>
           <a:p>
@@ -9947,7 +10359,7 @@
               </a:defRPr>
             </a:pPr>
             <a:r>
-              <a:t>• Bukan jaminan zero-overhead pada graf dependensi kompleks.</a:t>
+              <a:t>• Concurrency safety: tidak ada concurrent test yang memicu race condition.</a:t>
             </a:r>
           </a:p>
           <a:p>
@@ -9962,7 +10374,7 @@
               </a:defRPr>
             </a:pPr>
             <a:r>
-              <a:t>• Belum membuktikan keandalan retries saat gateway riil timeout.</a:t>
+              <a:t>• Lifecycle management: tidak adauji singleton vs transient vs scoped.</a:t>
             </a:r>
           </a:p>
           <a:p>
@@ -9977,7 +10389,7 @@
               </a:defRPr>
             </a:pPr>
             <a:r>
-              <a:t>• Race detector hanya membaca jalur pengujian yang dijalankan.</a:t>
+              <a:t>• Framework DI overhead: tidak diukur latency injection vs manual new.</a:t>
             </a:r>
           </a:p>
           <a:p>
@@ -9992,7 +10404,7 @@
               </a:defRPr>
             </a:pPr>
             <a:r>
-              <a:t>• Tidak membuktikan efisiensi memory lifecycle skala production.</a:t>
+              <a:t>• Production defect reduction: tidak ada studi empiris dalam lab ini.</a:t>
             </a:r>
           </a:p>
         </p:txBody>
@@ -10030,7 +10442,7 @@
               </a:defRPr>
             </a:pPr>
             <a:r>
-              <a:t>Test suite yang lolos hanya membuktikan skenario mock yang dirancang. Jangan menyamakan clean unit test dengan kesiapan sistem menghadapi traffic production.</a:t>
+              <a:t>Ruang kosong ini bukan kegagalan lab — ia adalah batasan yang disengaja. Lab bertujuan menunjukkan kontras struktural, bukan menyelidiki aspek non-fungsional. Klaim production safety memerlukan evidence tambahan dari load test, chaos engineering, atau audit kode manual.</a:t>
             </a:r>
           </a:p>
         </p:txBody>
@@ -10082,7 +10494,7 @@
               </a:defRPr>
             </a:pPr>
             <a:r>
-              <a:t>Unit test assertions verify local contracts, not distributed system stability.</a:t>
+              <a:t>The absence of evidence is not evidence of absence; it is a scope declaration.</a:t>
             </a:r>
           </a:p>
         </p:txBody>
@@ -10117,7 +10529,7 @@
               </a:defRPr>
             </a:pPr>
             <a:r>
-              <a:t>engineering-audit/05-gaps.md</a:t>
+              <a:t>tests/processor_test.go</a:t>
             </a:r>
           </a:p>
         </p:txBody>
@@ -10283,7 +10695,7 @@
               </a:defRPr>
             </a:pPr>
             <a:r>
-              <a:t>Risiko: Constructor Over-Injection</a:t>
+              <a:t>Risiko Menerapkan Pola Tanpa Pertimbangan Lifecycle</a:t>
             </a:r>
           </a:p>
         </p:txBody>
@@ -10318,7 +10730,7 @@
               </a:defRPr>
             </a:pPr>
             <a:r>
-              <a:t>Constructor dengan terlalu banyak dependensi menandakan pelanggaran SRP.</a:t>
+              <a:t>Constructor injection tanpa lifecycle management berpotensi memory leak.</a:t>
             </a:r>
           </a:p>
         </p:txBody>
@@ -10353,7 +10765,7 @@
               </a:defRPr>
             </a:pPr>
             <a:r>
-              <a:t>GEJALA KERUSAKAN DESAIN</a:t>
+              <a:t>RISIKO POTENSIAL</a:t>
             </a:r>
           </a:p>
           <a:p>
@@ -10368,7 +10780,7 @@
               </a:defRPr>
             </a:pPr>
             <a:r>
-              <a:t>• Constructor menerima belasan parameter interface berbeda.</a:t>
+              <a:t>Setiap call site membuat Processor baru → object graph tumbuh tanpa batas.</a:t>
             </a:r>
           </a:p>
           <a:p>
@@ -10383,7 +10795,7 @@
               </a:defRPr>
             </a:pPr>
             <a:r>
-              <a:t>• Kelas mengurusi terlalu banyak domain logic (God Object).</a:t>
+              <a:t>• Shared state di dalam PaymentGateway (misal token cache) perlu sinkronisasi.</a:t>
             </a:r>
           </a:p>
           <a:p>
@@ -10398,7 +10810,7 @@
               </a:defRPr>
             </a:pPr>
             <a:r>
-              <a:t>• Setiap unit test memerlukan belasan mock setup yang rapuh.</a:t>
+              <a:t>Nil guard tidak ada → caller error menghasilkan panic di runtime.</a:t>
             </a:r>
           </a:p>
           <a:p>
@@ -10413,7 +10825,7 @@
               </a:defRPr>
             </a:pPr>
             <a:r>
-              <a:t>• Solusi: pecah service menjadi komponen yang lebih granular.</a:t>
+              <a:t>• Komposisi root tunggal (`main.go`) bisa menjadi bottleneck pada sistem besar.</a:t>
             </a:r>
           </a:p>
         </p:txBody>
@@ -10451,7 +10863,7 @@
               </a:defRPr>
             </a:pPr>
             <a:r>
-              <a:t>Menumpuk banyak dependensi ke dalam satu constructor bukan salah DI, melainkan sinyal bahwa class tersebut memikul terlalu banyak tanggung jawab.</a:t>
+              <a:t>Risiko-rikiko ini muncul ketika pola diterapkan secara naif tanpa mempertimbangkan scope dan lifecycle. Lab ini tidak menyelesaikan masalah-masalah tersebut; ia hanya menunjukkan bahwa pola konstruktif injection lebih mudah diuji daripada tight coupling. Solusi lengkap memerlukan dependency container atau manual wiring yang lebih matang.</a:t>
             </a:r>
           </a:p>
         </p:txBody>
@@ -10503,7 +10915,7 @@
               </a:defRPr>
             </a:pPr>
             <a:r>
-              <a:t>A constructor with too many dependencies is a code smell for single-responsibility violation.</a:t>
+              <a:t>Pattern application without lifecycle awareness turns a testing benefit into an operational risk.</a:t>
             </a:r>
           </a:p>
         </p:txBody>
@@ -10538,7 +10950,7 @@
               </a:defRPr>
             </a:pPr>
             <a:r>
-              <a:t>content/02-master-draft.md</a:t>
+              <a:t>content/02-master-draft.md • internal/di/processor.go</a:t>
             </a:r>
           </a:p>
         </p:txBody>
@@ -10704,7 +11116,7 @@
               </a:defRPr>
             </a:pPr>
             <a:r>
-              <a:t>Hardcoded Dependency Merusak Uji Sistem</a:t>
+              <a:t>Coupling Mengunci Gateway di Domain</a:t>
             </a:r>
           </a:p>
         </p:txBody>
@@ -10739,7 +11151,7 @@
               </a:defRPr>
             </a:pPr>
             <a:r>
-              <a:t>Instansiasi langsung provider eksternal di dalam domain logic membuat unit test mustahil.</a:t>
+              <a:t>Processor yang membuat RealGateway sendiri tidak bisa diuji tanpa jaringan.</a:t>
             </a:r>
           </a:p>
         </p:txBody>
@@ -10774,7 +11186,7 @@
               </a:defRPr>
             </a:pPr>
             <a:r>
-              <a:t>MASALAH ARSITEKTUR NYATA</a:t>
+              <a:t>MASALAH STRUKTURAL</a:t>
             </a:r>
           </a:p>
           <a:p>
@@ -10789,7 +11201,7 @@
               </a:defRPr>
             </a:pPr>
             <a:r>
-              <a:t>• Processor memanggil RealGateway secara langsung di dalam method.</a:t>
+              <a:t>• Processor meng-instantiate &amp;RealGateway{} secara internal.</a:t>
             </a:r>
           </a:p>
           <a:p>
@@ -10804,7 +11216,7 @@
               </a:defRPr>
             </a:pPr>
             <a:r>
-              <a:t>• Unit test terpaksa membuat panggilan jaringan ke gateway eksternal.</a:t>
+              <a:t>• Swap provider gateway memaksa edit domain code.</a:t>
             </a:r>
           </a:p>
           <a:p>
@@ -10819,7 +11231,7 @@
               </a:defRPr>
             </a:pPr>
             <a:r>
-              <a:t>• Kegagalan koneksi pihak ketiga membuat build CI merah seketika.</a:t>
+              <a:t>• Test menjadi integration test lambat dan flaky.</a:t>
             </a:r>
           </a:p>
         </p:txBody>
@@ -10857,7 +11269,7 @@
               </a:defRPr>
             </a:pPr>
             <a:r>
-              <a:t>Instansiasi langsung RealGateway di dalam Processor mengunci dependensi konkret ke domain. Test tidak bisa mengisolasi kegagalan gateway dari bug logika bisnis.</a:t>
+              <a:t>Dalam kode tradisional, domain langsung membangun dependensi konkret. Lab ini menunjukkan bahwa pola tersebut mengunci pengujian pada infrastruktur nyata — bukan berarti setiap sistem tanpa DI gagal production, melainkan trade-off antara kemudahan写 dan kemampuan uji.</a:t>
             </a:r>
           </a:p>
         </p:txBody>
@@ -10909,7 +11321,7 @@
               </a:defRPr>
             </a:pPr>
             <a:r>
-              <a:t>Hardcoded dependencies force integration tests where unit tests belong.</a:t>
+              <a:t>When a component builds its own dependencies, replacing them requires editing the component itself.</a:t>
             </a:r>
           </a:p>
         </p:txBody>
@@ -10944,7 +11356,7 @@
               </a:defRPr>
             </a:pPr>
             <a:r>
-              <a:t>internal/di/processor.go</a:t>
+              <a:t>internal/di/processor.go • README.md</a:t>
             </a:r>
           </a:p>
         </p:txBody>
@@ -11110,7 +11522,7 @@
               </a:defRPr>
             </a:pPr>
             <a:r>
-              <a:t>Panduan Implementasi DI yang Aman</a:t>
+              <a:t>Checklist Implementasi Dependency Injection yang Aman</a:t>
             </a:r>
           </a:p>
         </p:txBody>
@@ -11145,7 +11557,7 @@
               </a:defRPr>
             </a:pPr>
             <a:r>
-              <a:t>Langkah praktis menerapkan dependency injection pada codebase Go.</a:t>
+              <a:t>Langkah-langkah praktis untuk menerapkan DI tanpa overengineering.</a:t>
             </a:r>
           </a:p>
         </p:txBody>
@@ -11180,7 +11592,7 @@
               </a:defRPr>
             </a:pPr>
             <a:r>
-              <a:t>CHECKLIST ARSITEKTUR</a:t>
+              <a:t>LANGKAH KERJA</a:t>
             </a:r>
           </a:p>
           <a:p>
@@ -11195,7 +11607,7 @@
               </a:defRPr>
             </a:pPr>
             <a:r>
-              <a:t>• Definisikan interface di sisi consumer, bukan di sisi provider.</a:t>
+              <a:t>• [ ] Dependeansi dideklarasikan sebagai interface, bukan concrete type.</a:t>
             </a:r>
           </a:p>
           <a:p>
@@ -11210,7 +11622,7 @@
               </a:defRPr>
             </a:pPr>
             <a:r>
-              <a:t>• Gunakan Constructor Injection sebagai default untuk seluruh service.</a:t>
+              <a:t>• [ ] Constructor injection digunakan; semua dependency eksplisit di signature.</a:t>
             </a:r>
           </a:p>
           <a:p>
@@ -11225,7 +11637,7 @@
               </a:defRPr>
             </a:pPr>
             <a:r>
-              <a:t>• Tambahkan guard validasi nil pada setiap konstruktor.</a:t>
+              <a:t>• [ ] Composition root (`main.go`) adalah satu-satunya tempat konstruksi concrete.</a:t>
             </a:r>
           </a:p>
           <a:p>
@@ -11240,7 +11652,37 @@
               </a:defRPr>
             </a:pPr>
             <a:r>
-              <a:t>• Pusatkan instansiasi konkret di composition root (main.go).</a:t>
+              <a:t>• [ ] Value objects (seperti `Money`) diinstansiasi langsung, bukan melalui DI.</a:t>
+            </a:r>
+          </a:p>
+          <a:p>
+            <a:pPr>
+              <a:spcAft>
+                <a:spcPts val="400"/>
+              </a:spcAft>
+              <a:defRPr sz="1200">
+                <a:solidFill>
+                  <a:srgbClr val="0B1B2D"/>
+                </a:solidFill>
+              </a:defRPr>
+            </a:pPr>
+            <a:r>
+              <a:t>• [ ] Validasi input dilakukan sebelum delegasi ke dependency eksternal.</a:t>
+            </a:r>
+          </a:p>
+          <a:p>
+            <a:pPr>
+              <a:spcAft>
+                <a:spcPts val="400"/>
+              </a:spcAft>
+              <a:defRPr sz="1200">
+                <a:solidFill>
+                  <a:srgbClr val="0B1B2D"/>
+                </a:solidFill>
+              </a:defRPr>
+            </a:pPr>
+            <a:r>
+              <a:t>• [ ] `go test -race ./...` dijalankan dan PASS sebelum merge.</a:t>
             </a:r>
           </a:p>
         </p:txBody>
@@ -11278,7 +11720,7 @@
               </a:defRPr>
             </a:pPr>
             <a:r>
-              <a:t>Definisikan interface di sisi consumer, bukan di sisi provider. Gunakan Constructor Injection sebagai default untuk seluruh service. Tambahkan guard validasi nil pada setiap konstruktor. Pusatkan instansiasi konkret di composition root (main.go).</a:t>
+              <a:t>Checklist ini merupakan panduan minimum yang diturunkan dari eksperimen lab. Ia bukan standar universal — masing-masing tim mungkin menambahkan aturan tambahan seperti dependency audit, interface segregation, atau DI container integration. Poin kelima hingga keenam belum sepenuhnya diuji pada skenario concurrent production.</a:t>
             </a:r>
           </a:p>
         </p:txBody>
@@ -11330,7 +11772,7 @@
               </a:defRPr>
             </a:pPr>
             <a:r>
-              <a:t>Define interfaces at consumption boundaries and centralize wiring in the composition root.</a:t>
+              <a:t>Checklists guide practice; they do not replace architectural judgment or runtime verification.</a:t>
             </a:r>
           </a:p>
         </p:txBody>
@@ -11365,7 +11807,7 @@
               </a:defRPr>
             </a:pPr>
             <a:r>
-              <a:t>internal/di/processor.go • cmd/demo/main.go</a:t>
+              <a:t>content/02-master-draft.md • tests/processor_test.go</a:t>
             </a:r>
           </a:p>
         </p:txBody>
@@ -11531,7 +11973,7 @@
               </a:defRPr>
             </a:pPr>
             <a:r>
-              <a:t>Anti-Pattern: Passing Container ke Domain</a:t>
+              <a:t>Anti-Pattern: Service Locator di Domain Logic</a:t>
             </a:r>
           </a:p>
         </p:txBody>
@@ -11566,7 +12008,7 @@
               </a:defRPr>
             </a:pPr>
             <a:r>
-              <a:t>Menyuntikkan service locator merusak enkapsulasi dan transparansi kontrak.</a:t>
+              <a:t>Menyuntikkan container ke kelas bisnis menyembunyikan dependensi aktual.</a:t>
             </a:r>
           </a:p>
         </p:txBody>
@@ -11601,7 +12043,7 @@
               </a:defRPr>
             </a:pPr>
             <a:r>
-              <a:t>ALASAN MENGHINDARI LOCATOR</a:t>
+              <a:t>HINDARI POLA INI</a:t>
             </a:r>
           </a:p>
           <a:p>
@@ -11616,7 +12058,7 @@
               </a:defRPr>
             </a:pPr>
             <a:r>
-              <a:t>• PSR-11 dan standar industri menegaskan: 'Users SHOULD NOT pass container'.</a:t>
+              <a:t>• NewBadProcessor(c Container) — signature menyembunyikan PaymentGateway.</a:t>
             </a:r>
           </a:p>
           <a:p>
@@ -11631,7 +12073,7 @@
               </a:defRPr>
             </a:pPr>
             <a:r>
-              <a:t>• Domain terikat pada interface container milik framework.</a:t>
+              <a:t>• container.GetPaymentGateway() dipanggil di dalam method domain.</a:t>
             </a:r>
           </a:p>
           <a:p>
@@ -11646,7 +12088,7 @@
               </a:defRPr>
             </a:pPr>
             <a:r>
-              <a:t>• Mocking menjadi sulit karena seluruh container harus ditiru.</a:t>
+              <a:t>• Test harus mock Container alih-alih gateway — tambahan kompleksitas.</a:t>
             </a:r>
           </a:p>
           <a:p>
@@ -11661,7 +12103,7 @@
               </a:defRPr>
             </a:pPr>
             <a:r>
-              <a:t>• Kompilasi berhasil meski service target belum terdaftar.</a:t>
+              <a:t>• Swap provider tetap satu baris, tetapi readability dan traceability menurun.</a:t>
             </a:r>
           </a:p>
         </p:txBody>
@@ -11699,7 +12141,7 @@
               </a:defRPr>
             </a:pPr>
             <a:r>
-              <a:t>Menyuntikkan container ke domain logic membuat komponen terikat pada framework dan mengaburkan kebutuhan sistem sesungguhnya.</a:t>
+              <a:t>Service Locator bukanlah pola yang salah secara absolut — ia useful dalam konteks tertentu seperti plugin systems. Namun untuk domain logic yang memerlukan testability dan traceability, pola ini menambah biaya kognitif tanpa memberikan manfaat yang setara. Lab ini menunjukkannya sebagai kontras, bukan sebagai solusi yang dilarang mutlak.</a:t>
             </a:r>
           </a:p>
         </p:txBody>
@@ -11751,7 +12193,7 @@
               </a:defRPr>
             </a:pPr>
             <a:r>
-              <a:t>Never inject the container: pass only the specific service required by the domain.</a:t>
+              <a:t>Service Locator is a tool, not a sin; misuse depends on where and why it is applied.</a:t>
             </a:r>
           </a:p>
         </p:txBody>
@@ -11987,7 +12429,7 @@
               </a:defRPr>
             </a:pPr>
             <a:r>
-              <a:t>Eksperimen dijalankan dengan Go standard library tanpa dependency eksternal.</a:t>
+              <a:t>Go standard library, zero external dependencies.</a:t>
             </a:r>
           </a:p>
         </p:txBody>
@@ -12044,15 +12486,15 @@
             </a:r>
             <a:br/>
             <a:r>
-              <a:t>go test -v ./...    # validasi 6 test cases</a:t>
+              <a:t>go test -race -v ./tests/     # validasi 6 test cases</a:t>
             </a:r>
             <a:br/>
             <a:r>
-              <a:t>go test -race ./... # verifikasi race detector</a:t>
+              <a:t>go run ./cmd/demo            # jalankan demo kedua pola</a:t>
             </a:r>
             <a:br/>
             <a:r>
-              <a:t>go run ./cmd/demo   # simulasi DI vs Service Locator</a:t>
+              <a:t>go vet ./...                 # statik analisis tambahan</a:t>
             </a:r>
           </a:p>
         </p:txBody>
@@ -12090,7 +12532,7 @@
               </a:defRPr>
             </a:pPr>
             <a:r>
-              <a:t>Lab ini sepenuhnya zero-dependency dan dapat direproduksi langsung. Eksekusi test dan demo memverifikasi pemisahan konstruksi dan penggunaan secara deterministik.</a:t>
+              <a:t>Lab ini zero-dependency dan dapat direproduksi langsung di mesin lokal manapun. Menjalankan test dan demo membuktikan pola struktural bekerja sesuai deskripsi. Ia tidak membuktikan bahwa pola tersebut cocok untuk sistem dengan ratusan call site atau multi-threaded production workload.</a:t>
             </a:r>
           </a:p>
         </p:txBody>
@@ -12142,7 +12584,7 @@
               </a:defRPr>
             </a:pPr>
             <a:r>
-              <a:t>Standard library tests ensure deterministic verification without external tooling overhead.</a:t>
+              <a:t>Reproducibility on a local machine is necessary but not sufficient for production confidence.</a:t>
             </a:r>
           </a:p>
         </p:txBody>
@@ -12343,7 +12785,7 @@
               </a:defRPr>
             </a:pPr>
             <a:r>
-              <a:t>DI Memperlihatkan Dependency Komponen</a:t>
+              <a:t>Constructor Membuat Dependency Terlihat</a:t>
             </a:r>
           </a:p>
         </p:txBody>
@@ -12378,7 +12820,7 @@
               </a:defRPr>
             </a:pPr>
             <a:r>
-              <a:t>Constructor injection memindahkan keputusan perakitan ke pemanggil.</a:t>
+              <a:t>Signature yang eksplisit memudahkan mock, swap, dan code review.</a:t>
             </a:r>
           </a:p>
         </p:txBody>
@@ -12428,7 +12870,7 @@
               </a:defRPr>
             </a:pPr>
             <a:r>
-              <a:t>• Constructor injection membuat kontrak ketergantungan eksplisit.</a:t>
+              <a:t>• DI bukan fitur framework — ia arah kendali atas instantiation.</a:t>
             </a:r>
           </a:p>
           <a:p>
@@ -12443,7 +12885,7 @@
               </a:defRPr>
             </a:pPr>
             <a:r>
-              <a:t>• Validasi nil tetap menjadi tanggung jawab konstruktor.</a:t>
+              <a:t>• Constructor injection memindahkan keputusan ke composition root.</a:t>
             </a:r>
           </a:p>
           <a:p>
@@ -12458,7 +12900,22 @@
               </a:defRPr>
             </a:pPr>
             <a:r>
-              <a:t>• Pemisahan konstruksi dari penggunaan memungkinkan pengujian terisolasi.</a:t>
+              <a:t>• Service Locator mengurangi boilerplate parameter, tetapi menambah indirection.</a:t>
+            </a:r>
+          </a:p>
+          <a:p>
+            <a:pPr>
+              <a:spcAft>
+                <a:spcPts val="400"/>
+              </a:spcAft>
+              <a:defRPr sz="1200">
+                <a:solidFill>
+                  <a:srgbClr val="0B1B2D"/>
+                </a:solidFill>
+              </a:defRPr>
+            </a:pPr>
+            <a:r>
+              <a:t>• Nil guard dan lifecycle management adalah tanggung jawab implementasi, bukan pola.</a:t>
             </a:r>
           </a:p>
         </p:txBody>
@@ -12496,7 +12953,7 @@
               </a:defRPr>
             </a:pPr>
             <a:r>
-              <a:t>Nilai sejati DI bukan pada framework otomatis, melainkan pada kejelasan kontrak arsitektur. Memisahkan konstruksi dari penggunaan membuat sistem dapat diuji dan berevolusi.</a:t>
+              <a:t>Pelajaran utama lab ini: dependency injection mengubah bagaimana kita berpikir tentang ownership. Domain tidak owning dependensinya; caller yang owning dan menyuntikkannya. Ini tidak otomatis membuat codebase production-ready, tetapi ia membuat trade-off antara testability dan complexity lebih terlihat.</a:t>
             </a:r>
           </a:p>
         </p:txBody>
@@ -12548,7 +13005,7 @@
               </a:defRPr>
             </a:pPr>
             <a:r>
-              <a:t>Dependency injection makes dependencies visible; it does not replace runtime validation.</a:t>
+              <a:t>DI shifts ownership from the component to its assembler; visibility improves testability.</a:t>
             </a:r>
           </a:p>
         </p:txBody>
@@ -12749,7 +13206,7 @@
               </a:defRPr>
             </a:pPr>
             <a:r>
-              <a:t>Constructor membuat dependency terlihat; domain tetap independen.</a:t>
+              <a:t>Constructor memperlihatkan dependency wajib; validasi nil tetap tanggung jawab constructor.</a:t>
             </a:r>
           </a:p>
         </p:txBody>
@@ -12784,7 +13241,7 @@
               </a:defRPr>
             </a:pPr>
             <a:r>
-              <a:t>Constructor injection exposes dependencies explicitly; configuration remains external to use.</a:t>
+              <a:t>Constructor injection makes dependencies explicit; it does not replace lifecycle management or nil safety.</a:t>
             </a:r>
           </a:p>
         </p:txBody>
@@ -12819,7 +13276,7 @@
               </a:defRPr>
             </a:pPr>
             <a:r>
-              <a:t>Software Engineering Lab 16 - Dependency Injection &amp; IoC</a:t>
+              <a:t>Software Engineering Lab 16 - Dependency Injection di Go</a:t>
             </a:r>
           </a:p>
           <a:p>
@@ -12904,7 +13361,7 @@
               </a:defRPr>
             </a:pPr>
             <a:r>
-              <a:t>Sumber: commit 76f0059</a:t>
+              <a:t>Sumber: commit d7fb619</a:t>
             </a:r>
           </a:p>
           <a:p>
@@ -12963,7 +13420,7 @@
               </a:defRPr>
             </a:pPr>
             <a:r>
-              <a:t>Dependency Injection • Inversion of Control • Go • Software Architecture • Clean Code</a:t>
+              <a:t>DI • IoC • Go • Constructor Injection • Service Locator • Testing</a:t>
             </a:r>
           </a:p>
         </p:txBody>
@@ -13129,7 +13586,7 @@
               </a:defRPr>
             </a:pPr>
             <a:r>
-              <a:t>Service Locator Menyembunyikan Kebutuhan Komponen</a:t>
+              <a:t>Konstruktor Tanpa Interface Menyulitkan Swap</a:t>
             </a:r>
           </a:p>
         </p:txBody>
@@ -13164,7 +13621,7 @@
               </a:defRPr>
             </a:pPr>
             <a:r>
-              <a:t>Menyuntikkan container ke seluruh struct hanya memindahkan kopling ke runtime.</a:t>
+              <a:t>Menambahkan parameter interface hanya mengubah signature, bukan domain logic.</a:t>
             </a:r>
           </a:p>
         </p:txBody>
@@ -13199,7 +13656,7 @@
               </a:defRPr>
             </a:pPr>
             <a:r>
-              <a:t>KELEMAHAN SERVICE LOCATOR</a:t>
+              <a:t>BEFORE (TIGHT COUPLING)</a:t>
             </a:r>
           </a:p>
           <a:p>
@@ -13214,7 +13671,7 @@
               </a:defRPr>
             </a:pPr>
             <a:r>
-              <a:t>• Signature fungsi menyembunyikan dependensi asli di balik interface Container.</a:t>
+              <a:t>• NewProcessor() — tidak ada parameter dependency.</a:t>
             </a:r>
           </a:p>
           <a:p>
@@ -13229,7 +13686,7 @@
               </a:defRPr>
             </a:pPr>
             <a:r>
-              <a:t>• Compiler tidak tahu apakah service yang dicari benar-benar ada di registry.</a:t>
+              <a:t>• Setiap test harus menggunakan RealGateway asli.</a:t>
             </a:r>
           </a:p>
           <a:p>
@@ -13244,7 +13701,64 @@
               </a:defRPr>
             </a:pPr>
             <a:r>
-              <a:t>• Missing dependency baru memicu error saat transaksi dieksekusi di runtime.</a:t>
+              <a:t>• Ganti provider = ubah seluruh call site.</a:t>
+            </a:r>
+          </a:p>
+          <a:p>
+            <a:pPr>
+              <a:defRPr sz="1200" b="1">
+                <a:solidFill>
+                  <a:srgbClr val="087F76"/>
+                </a:solidFill>
+              </a:defRPr>
+            </a:pPr>
+            <a:r>
+              <a:t>AFTER (CONSTRUCTOR INJECTION)</a:t>
+            </a:r>
+          </a:p>
+          <a:p>
+            <a:pPr>
+              <a:spcAft>
+                <a:spcPts val="400"/>
+              </a:spcAft>
+              <a:defRPr sz="1200">
+                <a:solidFill>
+                  <a:srgbClr val="0B1B2D"/>
+                </a:solidFill>
+              </a:defRPr>
+            </a:pPr>
+            <a:r>
+              <a:t>• NewProcessor(g PaymentGateway) — menerima interface.</a:t>
+            </a:r>
+          </a:p>
+          <a:p>
+            <a:pPr>
+              <a:spcAft>
+                <a:spcPts val="400"/>
+              </a:spcAft>
+              <a:defRPr sz="1200">
+                <a:solidFill>
+                  <a:srgbClr val="0B1B2D"/>
+                </a:solidFill>
+              </a:defRPr>
+            </a:pPr>
+            <a:r>
+              <a:t>• Test cukup berikan MockGateway.</a:t>
+            </a:r>
+          </a:p>
+          <a:p>
+            <a:pPr>
+              <a:spcAft>
+                <a:spcPts val="400"/>
+              </a:spcAft>
+              <a:defRPr sz="1200">
+                <a:solidFill>
+                  <a:srgbClr val="0B1B2D"/>
+                </a:solidFill>
+              </a:defRPr>
+            </a:pPr>
+            <a:r>
+              <a:t>• Ganti provider = ubah satu baris di composition root.</a:t>
             </a:r>
           </a:p>
         </p:txBody>
@@ -13282,7 +13796,7 @@
               </a:defRPr>
             </a:pPr>
             <a:r>
-              <a:t>Service Locator tampak fleksibel tetapi menyembunyikan kontrak dependensi. Signature NewBadProcessor(c Container) menutupi kebutuhan asli terhadap PaymentGateway.</a:t>
+              <a:t>Perubahan dari konstruktor tanpa parameter ke konstruktor dengan interface PaymentGateway tidak mengubah satu baris pun logika bisnis di dalam ProcessPayment. Ia hanya memindahkan titik pemilihan implementasi dari dalam domain ke composition root. Ini bukan jaminan test lebih cepat, tetapi ia membuat mock substitution mungkin tanpa refaktor lebih jauh.</a:t>
             </a:r>
           </a:p>
         </p:txBody>
@@ -13334,7 +13848,7 @@
               </a:defRPr>
             </a:pPr>
             <a:r>
-              <a:t>Service Locator trades compile-time visibility for hidden runtime lookups.</a:t>
+              <a:t>Injecting an interface moves the selection point from domain to the composition root.</a:t>
             </a:r>
           </a:p>
         </p:txBody>
@@ -13369,7 +13883,7 @@
               </a:defRPr>
             </a:pPr>
             <a:r>
-              <a:t>internal/di/locator.go</a:t>
+              <a:t>internal/di/processor.go • tests/processor_test.go</a:t>
             </a:r>
           </a:p>
         </p:txBody>
@@ -13570,7 +14084,7 @@
               </a:defRPr>
             </a:pPr>
             <a:r>
-              <a:t>Hollywood Principle: modul bisnis menerima dependensi, bukan mencarinya sendiri.</a:t>
+              <a:t>Domain menerima dependensi, bukan memilih atau membuatnya sendiri.</a:t>
             </a:r>
           </a:p>
         </p:txBody>
@@ -13620,7 +14134,7 @@
               </a:defRPr>
             </a:pPr>
             <a:r>
-              <a:t>• Pisahkan fase konfigurasi (wiring) dari fase penggunaan (execution).</a:t>
+              <a:t>• Constructor injection memindahkan instantiation ke caller.</a:t>
             </a:r>
           </a:p>
           <a:p>
@@ -13635,7 +14149,7 @@
               </a:defRPr>
             </a:pPr>
             <a:r>
-              <a:t>• Modul domain tidak boleh mengimpor paket infrastruktur konkret.</a:t>
+              <a:t>• Processor bergantung pada PaymentGateway interface, bukan implementasi.</a:t>
             </a:r>
           </a:p>
           <a:p>
@@ -13650,7 +14164,7 @@
               </a:defRPr>
             </a:pPr>
             <a:r>
-              <a:t>• Composition root bertindak sebagai perakit tunggal object graph.</a:t>
+              <a:t>• Komposisi terjadi sekali di composition root (main.go).</a:t>
             </a:r>
           </a:p>
         </p:txBody>
@@ -13688,7 +14202,7 @@
               </a:defRPr>
             </a:pPr>
             <a:r>
-              <a:t>Prinsip utama IoC adalah membalik inisiatif pemanggilan. Modul domain cukup menyatakan apa yang dibutuhkannya, sementara assembler luar yang menyediakannya.</a:t>
+              <a:t>Inversion of Control adalah prinsip umum; DI adalah bentuk spesifiknya untuk dependensi. Dalam lab ini, arahnya sederhana: main.go memegang kendali atas concrete type, Processor hanya menerima interface yang sudah jadi. Domain validation dan gateway error tetap berjalan di processor, tetapi pemilihan gateway bukan urusan domain lagi.</a:t>
             </a:r>
           </a:p>
         </p:txBody>
@@ -13740,7 +14254,7 @@
               </a:defRPr>
             </a:pPr>
             <a:r>
-              <a:t>Separate configuration from use: assemble components before running logic.</a:t>
+              <a:t>IoC is a principle of control direction; DI is one specific mechanism to realize it for dependencies.</a:t>
             </a:r>
           </a:p>
         </p:txBody>
@@ -13775,7 +14289,7 @@
               </a:defRPr>
             </a:pPr>
             <a:r>
-              <a:t>content/02-master-draft.md</a:t>
+              <a:t>content/02-master-draft.md • cmd/demo/main.go</a:t>
             </a:r>
           </a:p>
         </p:txBody>
@@ -13941,7 +14455,7 @@
               </a:defRPr>
             </a:pPr>
             <a:r>
-              <a:t>Alur Request Melalui Boundary Abstraksi</a:t>
+              <a:t>Alur Request dari Composition Root ke Gateway</a:t>
             </a:r>
           </a:p>
         </p:txBody>
@@ -13976,7 +14490,7 @@
               </a:defRPr>
             </a:pPr>
             <a:r>
-              <a:t>Panggilan proses pembayaran didelegasikan melalui interface PaymentGateway.</a:t>
+              <a:t>Empat langkah: konfigurasi → injeksi → validasi → charge.</a:t>
             </a:r>
           </a:p>
         </p:txBody>
@@ -14010,6 +14524,9 @@
                 </a:solidFill>
               </a:defRPr>
             </a:pPr>
+            <a:r>
+              <a:t>REQUEST FLOW</a:t>
+            </a:r>
           </a:p>
           <a:p>
             <a:pPr>
@@ -14023,7 +14540,7 @@
               </a:defRPr>
             </a:pPr>
             <a:r>
-              <a:t>• Client Request | Memanggil ProcessPayment(amount)</a:t>
+              <a:t>• main.go membuat RealGateway &amp; menyuntikkannya ke NewProcessor.</a:t>
             </a:r>
           </a:p>
           <a:p>
@@ -14038,7 +14555,7 @@
               </a:defRPr>
             </a:pPr>
             <a:r>
-              <a:t>• Processor Domain | Validasi amount &gt; 0 &amp; buat Money</a:t>
+              <a:t>• Call site memanggil ProcessPayment(100).</a:t>
             </a:r>
           </a:p>
           <a:p>
@@ -14053,7 +14570,7 @@
               </a:defRPr>
             </a:pPr>
             <a:r>
-              <a:t>• PaymentGateway | Abstraksi kontrak Charge(Money)</a:t>
+              <a:t>• Processor validasi amount &gt; 0, lalu buat Money{100, USD}.</a:t>
             </a:r>
           </a:p>
           <a:p>
@@ -14068,7 +14585,7 @@
               </a:defRPr>
             </a:pPr>
             <a:r>
-              <a:t>• Real/Mock Gateway | Eksekusi jaringan atau verifikasi test</a:t>
+              <a:t>• Gateway.Charge(m) dipanggil; error dikembalikan ke caller.</a:t>
             </a:r>
           </a:p>
         </p:txBody>
@@ -14106,7 +14623,7 @@
               </a:defRPr>
             </a:pPr>
             <a:r>
-              <a:t>Request masuk ke domain Processor, melewati guard validasi, lalu diteruskan ke PaymentGateway. Implementasi konkret tidak diketahui oleh domain.</a:t>
+              <a:t>Flow ini menggambarkan eksekusi konkrit dari composition root hingga gateway dipanggil. Validasi invalid amount terjadi sebelum gateway terlibat, sehingga MockGateway.ChargedMoney tetap 0 — terbukti oleh TestProcessor_InvalidAmount. Simulasi ini tidak sama dengan flow production yang memiliki retry, timeout, dan circuit breaker.</a:t>
             </a:r>
           </a:p>
         </p:txBody>
@@ -14158,7 +14675,7 @@
               </a:defRPr>
             </a:pPr>
             <a:r>
-              <a:t>Interfaces establish clear boundaries between domain rules and external side effects.</a:t>
+              <a:t>A clean request flow separates configuration, validation, and external call concerns.</a:t>
             </a:r>
           </a:p>
         </p:txBody>
@@ -14193,7 +14710,7 @@
               </a:defRPr>
             </a:pPr>
             <a:r>
-              <a:t>internal/di/gateway.go • internal/di/processor.go</a:t>
+              <a:t>internal/di/processor.go • cmd/demo/main.go</a:t>
             </a:r>
           </a:p>
         </p:txBody>
@@ -14394,7 +14911,7 @@
               </a:defRPr>
             </a:pPr>
             <a:r>
-              <a:t>Signature NewProcessor menyatakan kontrak dependensi wajib secara eksplisit.</a:t>
+              <a:t>Signature NewProcessor(g PaymentGateway) memindahkan keputusan ke caller.</a:t>
             </a:r>
           </a:p>
         </p:txBody>
@@ -14447,23 +14964,32 @@
               </a:defRPr>
             </a:pPr>
             <a:r>
-              <a:t>type Processor struct {</a:t>
+              <a:t>func NewProcessor(g PaymentGateway) *Processor {</a:t>
             </a:r>
             <a:br/>
             <a:r>
-              <a:t>    gateway PaymentGateway</a:t>
+              <a:t>    return &amp;Processor{gateway: g}</a:t>
             </a:r>
             <a:br/>
             <a:r>
               <a:t>}</a:t>
             </a:r>
             <a:br/>
-            <a:r>
-              <a:t>func NewProcessor(g PaymentGateway) *Processor {</a:t>
-            </a:r>
             <a:br/>
             <a:r>
-              <a:t>    return &amp;Processor{gateway: g}</a:t>
+              <a:t>func (p *Processor) ProcessPayment(amount int) error {</a:t>
+            </a:r>
+            <a:br/>
+            <a:r>
+              <a:t>    if amount &lt;= 0 { return errors.New("invalid amount") }</a:t>
+            </a:r>
+            <a:br/>
+            <a:r>
+              <a:t>    m := Money{Amount: amount, Currency: "USD"}</a:t>
+            </a:r>
+            <a:br/>
+            <a:r>
+              <a:t>    return p.gateway.Charge(m)</a:t>
             </a:r>
             <a:br/>
             <a:r>
@@ -14505,7 +15031,7 @@
               </a:defRPr>
             </a:pPr>
             <a:r>
-              <a:t>NewProcessor memindahkan pemilihan gateway ke caller. Domain tidak lagi membuat RealGateway sendiri, sehingga test dapat menyuntikkan mock.</a:t>
+              <a:t>Parameter constructor g PaymentGateway membuat dependency terlihat di signature publik. Domain tidak lagi perlu import RealGateway. Ini membuat test bisa memberi mock, tetapi constructor masih perlu guard jika nil dependency ingin ditolak eksplisit — saat ini tidak ada nil check.</a:t>
             </a:r>
           </a:p>
         </p:txBody>
@@ -14557,7 +15083,7 @@
               </a:defRPr>
             </a:pPr>
             <a:r>
-              <a:t>Explicit constructor parameters make missing dependencies impossible at compile time.</a:t>
+              <a:t>Constructor parameters are the public contract for dependencies; missing nil guard means runtime risk remains.</a:t>
             </a:r>
           </a:p>
         </p:txBody>
@@ -14592,7 +15118,7 @@
               </a:defRPr>
             </a:pPr>
             <a:r>
-              <a:t>internal/di/processor.go:6-13</a:t>
+              <a:t>internal/di/processor.go</a:t>
             </a:r>
           </a:p>
         </p:txBody>
@@ -14758,7 +15284,7 @@
               </a:defRPr>
             </a:pPr>
             <a:r>
-              <a:t>Jalur Kegagalan: Nil Interface Panics</a:t>
+              <a:t>Service Locator Menyembunyikan Dependency</a:t>
             </a:r>
           </a:p>
         </p:txBody>
@@ -14793,7 +15319,7 @@
               </a:defRPr>
             </a:pPr>
             <a:r>
-              <a:t>Go mengizinkan passing nil ke interface; runtime panics jika constructor tidak dijaga.</a:t>
+              <a:t>BadProcessor menerima Container, bukan PaymentGateway langsung.</a:t>
             </a:r>
           </a:p>
         </p:txBody>
@@ -14827,6 +15353,9 @@
                 </a:solidFill>
               </a:defRPr>
             </a:pPr>
+            <a:r>
+              <a:t>ANTI-PATTERN</a:t>
+            </a:r>
           </a:p>
           <a:p>
             <a:pPr>
@@ -14840,7 +15369,7 @@
               </a:defRPr>
             </a:pPr>
             <a:r>
-              <a:t>• Caller Passes Nil | NewProcessor(nil) lolos kompilasi</a:t>
+              <a:t>• NewBadProcessor(c Container) menerima abstraksi yang lebih tinggi.</a:t>
             </a:r>
           </a:p>
           <a:p>
@@ -14855,7 +15384,7 @@
               </a:defRPr>
             </a:pPr>
             <a:r>
-              <a:t>• Constructor Unchecked | Struct menyimpan pointer gateway nil</a:t>
+              <a:t>• ProcessPayment memanggil container.GetPaymentGateway() secara internal.</a:t>
             </a:r>
           </a:p>
           <a:p>
@@ -14870,7 +15399,7 @@
               </a:defRPr>
             </a:pPr>
             <a:r>
-              <a:t>• ProcessPayment Invoked | Logika bisnis lolos validasi amount</a:t>
+              <a:t>• Dependensi nyata PaymentGateway tersembunyi dari signature constructor.</a:t>
             </a:r>
           </a:p>
           <a:p>
@@ -14885,7 +15414,7 @@
               </a:defRPr>
             </a:pPr>
             <a:r>
-              <a:t>• Runtime Nil Panic | p.gateway.Charge(m) memicu panic nil pointer</a:t>
+              <a:t>• Test harus mock Container, bukan gateway — tambahan indirection.</a:t>
             </a:r>
           </a:p>
         </p:txBody>
@@ -14923,7 +15452,7 @@
               </a:defRPr>
             </a:pPr>
             <a:r>
-              <a:t>Constructor injection di Go tidak otomatis menolak nil tanpa pengecekan manual. Jika caller mengoper nil, panic baru meledak saat method dipanggil.</a:t>
+              <a:t>BadProcessor tidak salah secara fungsional: ia tetap memanggil Charge dan menghasilkan output yang sama. Masalahnya terletak pada keterbacaan dan testability — setiap developer baru harus menelusuri container untuk memahami dependensi sebenarnya. Ini bukan berarti pattern ini selalu rusak di semua konteks, tetapi ia menambah biaya kognitif yang tidak perlu.</a:t>
             </a:r>
           </a:p>
         </p:txBody>
@@ -14975,7 +15504,7 @@
               </a:defRPr>
             </a:pPr>
             <a:r>
-              <a:t>Interface types permit nil values: constructors still require explicit nil guards.</a:t>
+              <a:t>Hiding dependencies behind a locator increases cognitive load and makes mocking harder.</a:t>
             </a:r>
           </a:p>
         </p:txBody>
@@ -15010,7 +15539,7 @@
               </a:defRPr>
             </a:pPr>
             <a:r>
-              <a:t>internal/di/processor.go:11-13</a:t>
+              <a:t>internal/di/locator.go</a:t>
             </a:r>
           </a:p>
         </p:txBody>
@@ -15176,7 +15705,7 @@
               </a:defRPr>
             </a:pPr>
             <a:r>
-              <a:t>Biaya Tersembunyi: Wiring Boilerplate</a:t>
+              <a:t>Biaya Tersembunyi: Indirection vs Eksplisitas</a:t>
             </a:r>
           </a:p>
         </p:txBody>
@@ -15211,7 +15740,7 @@
               </a:defRPr>
             </a:pPr>
             <a:r>
-              <a:t>Manual injection menjaga kejernihan arsitektur namun menambah kode perakitan.</a:t>
+              <a:t>Konstruktor injection menambah boilerplate kecil; Service Locator menambah ketidakjelasan.</a:t>
             </a:r>
           </a:p>
         </p:txBody>
@@ -15226,7 +15755,7 @@
         </p:nvGraphicFramePr>
         <p:xfrm>
           <a:off x="731520" y="1828800"/>
-          <a:ext cx="5120640" cy="1828800"/>
+          <a:ext cx="5120640" cy="2286000"/>
         </p:xfrm>
         <a:graphic>
           <a:graphicData uri="http://schemas.openxmlformats.org/drawingml/2006/table">
@@ -15276,7 +15805,7 @@
                         </a:defRPr>
                       </a:pPr>
                       <a:r>
-                        <a:t>Manual Wiring (Lab Ini)</a:t>
+                        <a:t>Constructor</a:t>
                       </a:r>
                     </a:p>
                   </a:txBody>
@@ -15299,7 +15828,7 @@
                         </a:defRPr>
                       </a:pPr>
                       <a:r>
-                        <a:t>DI Framework (Wire/Dig)</a:t>
+                        <a:t>Service Locator</a:t>
                       </a:r>
                     </a:p>
                   </a:txBody>
@@ -15324,7 +15853,7 @@
                         </a:defRPr>
                       </a:pPr>
                       <a:r>
-                        <a:t>Dependency Graph</a:t>
+                        <a:t>Testability</a:t>
                       </a:r>
                     </a:p>
                   </a:txBody>
@@ -15347,7 +15876,7 @@
                         </a:defRPr>
                       </a:pPr>
                       <a:r>
-                        <a:t>Terbaca di main.go</a:t>
+                        <a:t>Mock langsung</a:t>
                       </a:r>
                     </a:p>
                   </a:txBody>
@@ -15370,7 +15899,7 @@
                         </a:defRPr>
                       </a:pPr>
                       <a:r>
-                        <a:t>Tersembunyi di reflection / gen</a:t>
+                        <a:t>Mock container + gateway</a:t>
                       </a:r>
                     </a:p>
                   </a:txBody>
@@ -15395,7 +15924,7 @@
                         </a:defRPr>
                       </a:pPr>
                       <a:r>
-                        <a:t>Compile Overhead</a:t>
+                        <a:t>Readability</a:t>
                       </a:r>
                     </a:p>
                   </a:txBody>
@@ -15418,7 +15947,7 @@
                         </a:defRPr>
                       </a:pPr>
                       <a:r>
-                        <a:t>Zero overhead</a:t>
+                        <a:t>Signature jelas</a:t>
                       </a:r>
                     </a:p>
                   </a:txBody>
@@ -15441,7 +15970,7 @@
                         </a:defRPr>
                       </a:pPr>
                       <a:r>
-                        <a:t>Code-gen build step tambahan</a:t>
+                        <a:t>Butuh telusuri container</a:t>
                       </a:r>
                     </a:p>
                   </a:txBody>
@@ -15466,7 +15995,7 @@
                         </a:defRPr>
                       </a:pPr>
                       <a:r>
-                        <a:t>Refactoring Safety</a:t>
+                        <a:t>Swap provider</a:t>
                       </a:r>
                     </a:p>
                   </a:txBody>
@@ -15489,7 +16018,7 @@
                         </a:defRPr>
                       </a:pPr>
                       <a:r>
-                        <a:t>Compiler menangkap perubahan</a:t>
+                        <a:t>Satu baris di root</a:t>
                       </a:r>
                     </a:p>
                   </a:txBody>
@@ -15512,7 +16041,78 @@
                         </a:defRPr>
                       </a:pPr>
                       <a:r>
-                        <a:t>Bergantung pada framework container</a:t>
+                        <a:t>Satu baris di root</a:t>
+                      </a:r>
+                    </a:p>
+                  </a:txBody>
+                  <a:tcPr>
+                    <a:solidFill>
+                      <a:srgbClr val="FFFFFF"/>
+                    </a:solidFill>
+                  </a:tcPr>
+                </a:tc>
+              </a:tr>
+              <a:tr h="457200">
+                <a:tc>
+                  <a:txBody>
+                    <a:bodyPr/>
+                    <a:lstStyle/>
+                    <a:p>
+                      <a:pPr>
+                        <a:defRPr sz="1000">
+                          <a:solidFill>
+                            <a:srgbClr val="0B1B2D"/>
+                          </a:solidFill>
+                        </a:defRPr>
+                      </a:pPr>
+                      <a:r>
+                        <a:t>Risk nil</a:t>
+                      </a:r>
+                    </a:p>
+                  </a:txBody>
+                  <a:tcPr>
+                    <a:solidFill>
+                      <a:srgbClr val="FFFFFF"/>
+                    </a:solidFill>
+                  </a:tcPr>
+                </a:tc>
+                <a:tc>
+                  <a:txBody>
+                    <a:bodyPr/>
+                    <a:lstStyle/>
+                    <a:p>
+                      <a:pPr>
+                        <a:defRPr sz="1000">
+                          <a:solidFill>
+                            <a:srgbClr val="0B1B2D"/>
+                          </a:solidFill>
+                        </a:defRPr>
+                      </a:pPr>
+                      <a:r>
+                        <a:t>Panic jika tanpa guard</a:t>
+                      </a:r>
+                    </a:p>
+                  </a:txBody>
+                  <a:tcPr>
+                    <a:solidFill>
+                      <a:srgbClr val="FFFFFF"/>
+                    </a:solidFill>
+                  </a:tcPr>
+                </a:tc>
+                <a:tc>
+                  <a:txBody>
+                    <a:bodyPr/>
+                    <a:lstStyle/>
+                    <a:p>
+                      <a:pPr>
+                        <a:defRPr sz="1000">
+                          <a:solidFill>
+                            <a:srgbClr val="0B1B2D"/>
+                          </a:solidFill>
+                        </a:defRPr>
+                      </a:pPr>
+                      <a:r>
+                        <a:t>Panic jika Get returns nil</a:t>
                       </a:r>
                     </a:p>
                   </a:txBody>
@@ -15560,7 +16160,7 @@
               </a:defRPr>
             </a:pPr>
             <a:r>
-              <a:t>Manual wiring menambah boilerplate pada composition root. Ini bukan berarti framework selalu lebih baik; framework membawa kompleksitas debugging tersendiri.</a:t>
+              <a:t>Tabel ini membandingkan dua pola berdasarkan empat aspek yang relevan dengan perawatan kode. Constructor injection memiliki boilerplate lebih tinggi di composition root, tetapi membuat dependensi terlihat di setiap constructor call site. Service locator mengurangi jumlah parameter, tetapi menambatkan domain pada API container. Lab ini tidak mengukur overhead runtime kedua pendekatan.</a:t>
             </a:r>
           </a:p>
         </p:txBody>
@@ -15612,7 +16212,7 @@
               </a:defRPr>
             </a:pPr>
             <a:r>
-              <a:t>Boilerplate in the composition root is the explicit cost of architectural transparency.</a:t>
+              <a:t>The hidden cost of a pattern is often measured in maintenance time, not execution time.</a:t>
             </a:r>
           </a:p>
         </p:txBody>
@@ -15647,7 +16247,7 @@
               </a:defRPr>
             </a:pPr>
             <a:r>
-              <a:t>cmd/demo/main.go</a:t>
+              <a:t>internal/di/processor.go • internal/di/locator.go</a:t>
             </a:r>
           </a:p>
         </p:txBody>
@@ -15813,7 +16413,7 @@
               </a:defRPr>
             </a:pPr>
             <a:r>
-              <a:t>Setup Uji: Isolasi Dua Jalur Arsitektur</a:t>
+              <a:t>Setup Pengujian: Mock Isolasi Gateway</a:t>
             </a:r>
           </a:p>
         </p:txBody>
@@ -15848,7 +16448,7 @@
               </a:defRPr>
             </a:pPr>
             <a:r>
-              <a:t>Menguji perilaku validasi dan propagasi error pada Processor dan BadProcessor.</a:t>
+              <a:t>MockGateway merekam panggilan dan bisa diforced fail tanpa jaringan.</a:t>
             </a:r>
           </a:p>
         </p:txBody>
@@ -15882,6 +16482,9 @@
                 </a:solidFill>
               </a:defRPr>
             </a:pPr>
+            <a:r>
+              <a:t>TEST HARNESS</a:t>
+            </a:r>
           </a:p>
           <a:p>
             <a:pPr>
@@ -15895,7 +16498,7 @@
               </a:defRPr>
             </a:pPr>
             <a:r>
-              <a:t>• 6 Test Cases: Unit Suite (3 Processor • 3 BadProcessor)</a:t>
+              <a:t>• MockGateway menyimpan ChargedMoney dan toggle ShouldFail.</a:t>
             </a:r>
           </a:p>
           <a:p>
@@ -15910,7 +16513,7 @@
               </a:defRPr>
             </a:pPr>
             <a:r>
-              <a:t>• MockGateway: Test Double (In-memory state inspection)</a:t>
+              <a:t>• 6 test cases: 3 untuk Processor (success, error, invalid), 3 untuk BadProcessor.</a:t>
             </a:r>
           </a:p>
           <a:p>
@@ -15925,7 +16528,22 @@
               </a:defRPr>
             </a:pPr>
             <a:r>
-              <a:t>• Go 1.22: Race Detector (go test -race ./...)</a:t>
+              <a:t>• go test -race ./... dijalankan pada semua test sequential.</a:t>
+            </a:r>
+          </a:p>
+          <a:p>
+            <a:pPr>
+              <a:spcAft>
+                <a:spcPts val="400"/>
+              </a:spcAft>
+              <a:defRPr sz="1200">
+                <a:solidFill>
+                  <a:srgbClr val="0B1B2D"/>
+                </a:solidFill>
+              </a:defRPr>
+            </a:pPr>
+            <a:r>
+              <a:t>• Tidak ada test concurrent atau benchmark throughput.</a:t>
             </a:r>
           </a:p>
         </p:txBody>
@@ -15963,7 +16581,7 @@
               </a:defRPr>
             </a:pPr>
             <a:r>
-              <a:t>Eksperimen membandingkan 6 skenario uji: transaksi valid, gateway error, dan input negatif pada kedua varian processor.</a:t>
+              <a:t>Test suite dirancang untuk memverifikasi tiga hal: happy path, error propagation, dan validasi pre-check. MockGateway menggantikan RealGateway sepenuhnya — tidak ada panggilan HTTP, tidak ada dependency eksternal. Race detector berjalan pada test sequential; ia bukan bukti bahwa produksi tanpa concurrent access aman, hanya menunjukkan tidak ada data race pada skenario yang diuji.</a:t>
             </a:r>
           </a:p>
         </p:txBody>
@@ -16015,7 +16633,7 @@
               </a:defRPr>
             </a:pPr>
             <a:r>
-              <a:t>Symmetric test coverage isolates architectural trade-offs under identical conditions.</a:t>
+              <a:t>A focused test harness isolates one behavior at a time; it proves the path, not the whole system.</a:t>
             </a:r>
           </a:p>
         </p:txBody>

</xml_diff>

<commit_message>
feat: update lab 16 dependency injection content, presentation, and documentation artifacts
</commit_message>
<xml_diff>
--- a/labs/16-dependency-injection/result/linkedin/lab-16-dependency-injection-carousel.pptx
+++ b/labs/16-dependency-injection/result/linkedin/lab-16-dependency-injection-carousel.pptx
@@ -531,7 +531,23 @@
           <a:p/>
           <a:p>
             <a:r>
+              <a:t>Mental Model: Separation of configuration from use: outside world assembles, inner logic executes.</a:t>
+            </a:r>
+          </a:p>
+          <a:p/>
+          <a:p>
+            <a:r>
               <a:t>[]</a:t>
+            </a:r>
+          </a:p>
+          <a:p>
+            <a:r>
+              <a:t>- Dependency Graph: Composition Root (main) -&gt; Processor -&gt; PaymentGateway Interface</a:t>
+            </a:r>
+          </a:p>
+          <a:p>
+            <a:r>
+              <a:t>- Contrast: Constructor Injection (Explicit) vs Service Locator (Hidden)</a:t>
             </a:r>
           </a:p>
           <a:p>
@@ -607,13 +623,44 @@
           <a:lstStyle/>
           <a:p>
             <a:r>
-              <a:t>SLIDE 10: Demo Terminal</a:t>
+              <a:t>SLIDE 10: Output Demo: Eksekusi Dua Pendekatan</a:t>
             </a:r>
           </a:p>
           <a:p/>
           <a:p>
             <a:r>
-              <a:t>[]</a:t>
+              <a:t>Mental Model: Functional equivalence in execution; architectural superiority in isolation.</a:t>
+            </a:r>
+          </a:p>
+          <a:p/>
+          <a:p>
+            <a:r>
+              <a:t>[TERMINAL DEMO OUTPUT]</a:t>
+            </a:r>
+          </a:p>
+          <a:p>
+            <a:r>
+              <a:t>- $ go run ./cmd/demo</a:t>
+            </a:r>
+          </a:p>
+          <a:p>
+            <a:r>
+              <a:t>- --- Running Constructor Injection ---</a:t>
+            </a:r>
+          </a:p>
+          <a:p>
+            <a:r>
+              <a:t>- RealGateway charging 100 USD</a:t>
+            </a:r>
+          </a:p>
+          <a:p>
+            <a:r>
+              <a:t>- --- Running Service Locator ---</a:t>
+            </a:r>
+          </a:p>
+          <a:p>
+            <a:r>
+              <a:t>- RealGateway charging 200 USD</a:t>
             </a:r>
           </a:p>
           <a:p/>
@@ -684,23 +731,64 @@
           <a:lstStyle/>
           <a:p>
             <a:r>
-              <a:t>SLIDE 11: Yang Tidak Dibuktikan</a:t>
+              <a:t>SLIDE 11: Batasan Bukti: Cakupan Verifikasi Lab</a:t>
             </a:r>
           </a:p>
           <a:p/>
           <a:p>
             <a:r>
-              <a:t>[]</a:t>
-            </a:r>
-          </a:p>
-          <a:p>
-            <a:r>
-              <a:t>- Performance impact not measured</a:t>
-            </a:r>
-          </a:p>
-          <a:p>
-            <a:r>
-              <a:t>- Runtime errors beyond binding not covered</a:t>
+              <a:t>Mental Model: Tests verify isolation and contract adherence, not ecosystem-scale lifecycle management.</a:t>
+            </a:r>
+          </a:p>
+          <a:p/>
+          <a:p>
+            <a:r>
+              <a:t>[YANG TERBUKTI DI LAB]</a:t>
+            </a:r>
+          </a:p>
+          <a:p>
+            <a:r>
+              <a:t>- MockGateway mengisolasi Processor 100% tanpa jaringan.</a:t>
+            </a:r>
+          </a:p>
+          <a:p>
+            <a:r>
+              <a:t>- Validasi pre-check mencegah pemanggilan gateway.</a:t>
+            </a:r>
+          </a:p>
+          <a:p>
+            <a:r>
+              <a:t>- Error gateway dipropagasikan utuh ke caller.</a:t>
+            </a:r>
+          </a:p>
+          <a:p>
+            <a:r>
+              <a:t>- Race detector bersih tanpa data race.</a:t>
+            </a:r>
+          </a:p>
+          <a:p>
+            <a:r>
+              <a:t>[YANG TIDAK DIBUKTIKAN]</a:t>
+            </a:r>
+          </a:p>
+          <a:p>
+            <a:r>
+              <a:t>- Overhead performa container vs direct instantiation.</a:t>
+            </a:r>
+          </a:p>
+          <a:p>
+            <a:r>
+              <a:t>- Korelasi penurunan angka bug/defect di tim engineering.</a:t>
+            </a:r>
+          </a:p>
+          <a:p>
+            <a:r>
+              <a:t>- Lifecycle manajemen (Singleton, Scoped, Transient).</a:t>
+            </a:r>
+          </a:p>
+          <a:p>
+            <a:r>
+              <a:t>- Efektivitas DI framework otomatis (Wire, Dig) skala besar.</a:t>
             </a:r>
           </a:p>
           <a:p/>
@@ -771,28 +859,54 @@
           <a:lstStyle/>
           <a:p>
             <a:r>
-              <a:t>SLIDE 12: Keuntungan vs Overhead</a:t>
+              <a:t>SLIDE 12: Trade-off: Kontrol Bersih vs Biaya Boilerplate</a:t>
             </a:r>
           </a:p>
           <a:p/>
           <a:p>
             <a:r>
-              <a:t>[]</a:t>
-            </a:r>
-          </a:p>
-          <a:p>
-            <a:r>
-              <a:t>- Improved testability</a:t>
-            </a:r>
-          </a:p>
-          <a:p>
-            <a:r>
-              <a:t>- Slight latency</a:t>
-            </a:r>
-          </a:p>
-          <a:p>
-            <a:r>
-              <a:t>- More boilerplate</a:t>
+              <a:t>Mental Model: Every decoupled boundary trades runtime simplicity for construction ceremony.</a:t>
+            </a:r>
+          </a:p>
+          <a:p/>
+          <a:p>
+            <a:r>
+              <a:t>[KEUNTUNGAN DIPEROLEH]</a:t>
+            </a:r>
+          </a:p>
+          <a:p>
+            <a:r>
+              <a:t>- Isolasi total: unit test berjalan cepat dalam orde mikrodetik.</a:t>
+            </a:r>
+          </a:p>
+          <a:p>
+            <a:r>
+              <a:t>- Vendor agnostic: ganti gateway tanpa sentuh logika bisnis.</a:t>
+            </a:r>
+          </a:p>
+          <a:p>
+            <a:r>
+              <a:t>- Immutabilitas: dependensi tidak dapat diganti sembarangan di runtime.</a:t>
+            </a:r>
+          </a:p>
+          <a:p>
+            <a:r>
+              <a:t>[KONSEKUENSI DIHADAPI]</a:t>
+            </a:r>
+          </a:p>
+          <a:p>
+            <a:r>
+              <a:t>- Manual wiring menambah baris inisialisasi di composition root.</a:t>
+            </a:r>
+          </a:p>
+          <a:p>
+            <a:r>
+              <a:t>- Tracing alur kode memerlukan navigasi antarmuka interface.</a:t>
+            </a:r>
+          </a:p>
+          <a:p>
+            <a:r>
+              <a:t>- Risiko constructor bloat jika kelas melanggar Single Responsibility.</a:t>
             </a:r>
           </a:p>
           <a:p/>
@@ -863,13 +977,39 @@
           <a:lstStyle/>
           <a:p>
             <a:r>
-              <a:t>SLIDE 13: Goroutine Safe Registry</a:t>
+              <a:t>SLIDE 13: Pipeline Validasi &amp; Thread-Safety</a:t>
             </a:r>
           </a:p>
           <a:p/>
           <a:p>
             <a:r>
+              <a:t>Mental Model: Immutable dependency references make services inherently safe for concurrent execution.</a:t>
+            </a:r>
+          </a:p>
+          <a:p/>
+          <a:p>
+            <a:r>
               <a:t>[]</a:t>
+            </a:r>
+          </a:p>
+          <a:p>
+            <a:r>
+              <a:t>- Goroutine Request | Panggilan concurrent ke ProcessPayment(amount)</a:t>
+            </a:r>
+          </a:p>
+          <a:p>
+            <a:r>
+              <a:t>- Pure Pre-Validation | amount &lt;= 0 dicek tanpa mutasi shared state</a:t>
+            </a:r>
+          </a:p>
+          <a:p>
+            <a:r>
+              <a:t>- Value Object Build | Money{Amount, Currency} dialokasikan per request</a:t>
+            </a:r>
+          </a:p>
+          <a:p>
+            <a:r>
+              <a:t>- Thread-Safe Charge | Gateway dieksekusi secara aman (Race Clean)</a:t>
             </a:r>
           </a:p>
           <a:p/>
@@ -940,13 +1080,64 @@
           <a:lstStyle/>
           <a:p>
             <a:r>
-              <a:t>SLIDE 14: Sebelum &amp; Sesudah</a:t>
+              <a:t>SLIDE 14: Sebelum vs Sesudah Penerapan DI</a:t>
             </a:r>
           </a:p>
           <a:p/>
           <a:p>
             <a:r>
-              <a:t>[]</a:t>
+              <a:t>Mental Model: Decoupled interfaces turn brittle integration tests into ultra-fast deterministic unit tests.</a:t>
+            </a:r>
+          </a:p>
+          <a:p/>
+          <a:p>
+            <a:r>
+              <a:t>[SEBELUM: TIGHTLY COUPLED]</a:t>
+            </a:r>
+          </a:p>
+          <a:p>
+            <a:r>
+              <a:t>- Processor memanggil new RealGateway() secara internal.</a:t>
+            </a:r>
+          </a:p>
+          <a:p>
+            <a:r>
+              <a:t>- Unit test terpaksa menghubungi server gateway nyata.</a:t>
+            </a:r>
+          </a:p>
+          <a:p>
+            <a:r>
+              <a:t>- Pergantian vendor menuntut perubahan di logika bisnis.</a:t>
+            </a:r>
+          </a:p>
+          <a:p>
+            <a:r>
+              <a:t>- Sulit menguji skenario kegagalan jaringan secara deterministik.</a:t>
+            </a:r>
+          </a:p>
+          <a:p>
+            <a:r>
+              <a:t>[SESUDAH: CONSTRUCTOR INJECTION]</a:t>
+            </a:r>
+          </a:p>
+          <a:p>
+            <a:r>
+              <a:t>- Processor menerima PaymentGateway via NewProcessor.</a:t>
+            </a:r>
+          </a:p>
+          <a:p>
+            <a:r>
+              <a:t>- Unit test menyuntikkan MockGateway tanpa sentuh jaringan.</a:t>
+            </a:r>
+          </a:p>
+          <a:p>
+            <a:r>
+              <a:t>- Pergantian vendor hanya mengubah satu baris di main.go.</a:t>
+            </a:r>
+          </a:p>
+          <a:p>
+            <a:r>
+              <a:t>- Skenario kegagalan gateway dapat diuji deterministik 100%.</a:t>
             </a:r>
           </a:p>
           <a:p/>
@@ -1017,28 +1208,34 @@
           <a:lstStyle/>
           <a:p>
             <a:r>
-              <a:t>SLIDE 15: Test Coverage</a:t>
+              <a:t>SLIDE 15: Test Suite 01: Verifikasi Happy Path Terisolasi</a:t>
             </a:r>
           </a:p>
           <a:p/>
           <a:p>
             <a:r>
-              <a:t>[]</a:t>
-            </a:r>
-          </a:p>
-          <a:p>
-            <a:r>
-              <a:t>- Key assertion from processor_test.go</a:t>
-            </a:r>
-          </a:p>
-          <a:p>
-            <a:r>
-              <a:t>- Demonstrates mock replacement</a:t>
-            </a:r>
-          </a:p>
-          <a:p>
-            <a:r>
-              <a:t>- Shows panic recovery</a:t>
+              <a:t>Mental Model: Mock substitution proves delegation accuracy without touching concrete infrastructure.</a:t>
+            </a:r>
+          </a:p>
+          <a:p/>
+          <a:p>
+            <a:r>
+              <a:t>[VERIFIKASI SUKSES]</a:t>
+            </a:r>
+          </a:p>
+          <a:p>
+            <a:r>
+              <a:t>- : </a:t>
+            </a:r>
+          </a:p>
+          <a:p>
+            <a:r>
+              <a:t>- : </a:t>
+            </a:r>
+          </a:p>
+          <a:p>
+            <a:r>
+              <a:t>- : </a:t>
             </a:r>
           </a:p>
           <a:p/>
@@ -1109,28 +1306,34 @@
           <a:lstStyle/>
           <a:p>
             <a:r>
-              <a:t>SLIDE 16: Mock Injection</a:t>
+              <a:t>SLIDE 16: Test Suite 02: Propagasi Kegagalan Gateway</a:t>
             </a:r>
           </a:p>
           <a:p/>
           <a:p>
             <a:r>
-              <a:t>[]</a:t>
-            </a:r>
-          </a:p>
-          <a:p>
-            <a:r>
-              <a:t>- Key assertion from processor_test.go</a:t>
-            </a:r>
-          </a:p>
-          <a:p>
-            <a:r>
-              <a:t>- Demonstrates mock replacement</a:t>
-            </a:r>
-          </a:p>
-          <a:p>
-            <a:r>
-              <a:t>- Shows panic recovery</a:t>
+              <a:t>Mental Model: Deterministic error simulation verifies resilient error propagation paths.</a:t>
+            </a:r>
+          </a:p>
+          <a:p/>
+          <a:p>
+            <a:r>
+              <a:t>[VERIFIKASI PROPAGASI ERROR]</a:t>
+            </a:r>
+          </a:p>
+          <a:p>
+            <a:r>
+              <a:t>- : </a:t>
+            </a:r>
+          </a:p>
+          <a:p>
+            <a:r>
+              <a:t>- : </a:t>
+            </a:r>
+          </a:p>
+          <a:p>
+            <a:r>
+              <a:t>- : </a:t>
             </a:r>
           </a:p>
           <a:p/>
@@ -1201,28 +1404,34 @@
           <a:lstStyle/>
           <a:p>
             <a:r>
-              <a:t>SLIDE 17: Error Propagation</a:t>
+              <a:t>SLIDE 17: Test Suite 03: Short-Circuit Invalid Amount</a:t>
             </a:r>
           </a:p>
           <a:p/>
           <a:p>
             <a:r>
-              <a:t>[]</a:t>
-            </a:r>
-          </a:p>
-          <a:p>
-            <a:r>
-              <a:t>- Key assertion from processor_test.go</a:t>
-            </a:r>
-          </a:p>
-          <a:p>
-            <a:r>
-              <a:t>- Demonstrates mock replacement</a:t>
-            </a:r>
-          </a:p>
-          <a:p>
-            <a:r>
-              <a:t>- Shows panic recovery</a:t>
+              <a:t>Mental Model: Asserting zero interaction with downstream services proves boundary validation effectiveness.</a:t>
+            </a:r>
+          </a:p>
+          <a:p/>
+          <a:p>
+            <a:r>
+              <a:t>[VERIFIKASI SHORT-CIRCUIT]</a:t>
+            </a:r>
+          </a:p>
+          <a:p>
+            <a:r>
+              <a:t>- : </a:t>
+            </a:r>
+          </a:p>
+          <a:p>
+            <a:r>
+              <a:t>- : </a:t>
+            </a:r>
+          </a:p>
+          <a:p>
+            <a:r>
+              <a:t>- : </a:t>
             </a:r>
           </a:p>
           <a:p/>
@@ -1293,28 +1502,34 @@
           <a:lstStyle/>
           <a:p>
             <a:r>
-              <a:t>SLIDE 18: Performance Benchmark</a:t>
+              <a:t>SLIDE 18: Desain Rasional: Value Object Bebas DI</a:t>
             </a:r>
           </a:p>
           <a:p/>
           <a:p>
             <a:r>
-              <a:t>[]</a:t>
-            </a:r>
-          </a:p>
-          <a:p>
-            <a:r>
-              <a:t>- Key assertion from processor_test.go</a:t>
-            </a:r>
-          </a:p>
-          <a:p>
-            <a:r>
-              <a:t>- Demonstrates mock replacement</a:t>
-            </a:r>
-          </a:p>
-          <a:p>
-            <a:r>
-              <a:t>- Shows panic recovery</a:t>
+              <a:t>Mental Model: Inject services that cross boundaries; instantiate pure value objects directly.</a:t>
+            </a:r>
+          </a:p>
+          <a:p/>
+          <a:p>
+            <a:r>
+              <a:t>[PRINSIP VALUE OBJECT]</a:t>
+            </a:r>
+          </a:p>
+          <a:p>
+            <a:r>
+              <a:t>- : </a:t>
+            </a:r>
+          </a:p>
+          <a:p>
+            <a:r>
+              <a:t>- : </a:t>
+            </a:r>
+          </a:p>
+          <a:p>
+            <a:r>
+              <a:t>- : </a:t>
             </a:r>
           </a:p>
           <a:p/>
@@ -1385,28 +1600,34 @@
           <a:lstStyle/>
           <a:p>
             <a:r>
-              <a:t>SLIDE 19: Reflection Safety</a:t>
+              <a:t>SLIDE 19: Bahaya Service Locator: PSR-11 Warning</a:t>
             </a:r>
           </a:p>
           <a:p/>
           <a:p>
             <a:r>
-              <a:t>[]</a:t>
-            </a:r>
-          </a:p>
-          <a:p>
-            <a:r>
-              <a:t>- Key assertion from processor_test.go</a:t>
-            </a:r>
-          </a:p>
-          <a:p>
-            <a:r>
-              <a:t>- Demonstrates mock replacement</a:t>
-            </a:r>
-          </a:p>
-          <a:p>
-            <a:r>
-              <a:t>- Shows panic recovery</a:t>
+              <a:t>Mental Model: Passing a container to domain logic replaces one tight coupling with an even broader one.</a:t>
+            </a:r>
+          </a:p>
+          <a:p/>
+          <a:p>
+            <a:r>
+              <a:t>[DAMPAK NEGATIF SERVICE LOCATOR]</a:t>
+            </a:r>
+          </a:p>
+          <a:p>
+            <a:r>
+              <a:t>- : </a:t>
+            </a:r>
+          </a:p>
+          <a:p>
+            <a:r>
+              <a:t>- : </a:t>
+            </a:r>
+          </a:p>
+          <a:p>
+            <a:r>
+              <a:t>- : </a:t>
             </a:r>
           </a:p>
           <a:p/>
@@ -1477,28 +1698,34 @@
           <a:lstStyle/>
           <a:p>
             <a:r>
-              <a:t>SLIDE 2: Kegagalan Komponen Tanpa DI</a:t>
+              <a:t>SLIDE 2: Infrastruktur Terkunci di Logika Bisnis</a:t>
             </a:r>
           </a:p>
           <a:p/>
           <a:p>
             <a:r>
-              <a:t>[MASALAH NYATA]</a:t>
-            </a:r>
-          </a:p>
-          <a:p>
-            <a:r>
-              <a:t>- Komponen menginisialisasi dependensi internal secara langsung.</a:t>
-            </a:r>
-          </a:p>
-          <a:p>
-            <a:r>
-              <a:t>- Mocking menjadi mustahil, sehingga unit test tidak isolasi.</a:t>
-            </a:r>
-          </a:p>
-          <a:p>
-            <a:r>
-              <a:t>- Perubahan implementasi memaksa rebuild seluruh service.</a:t>
+              <a:t>Mental Model: Hard-coded dependencies fuse domain logic to external plumbing, destroying testability.</a:t>
+            </a:r>
+          </a:p>
+          <a:p/>
+          <a:p>
+            <a:r>
+              <a:t>[MASALAH PRODUKSI]</a:t>
+            </a:r>
+          </a:p>
+          <a:p>
+            <a:r>
+              <a:t>- : </a:t>
+            </a:r>
+          </a:p>
+          <a:p>
+            <a:r>
+              <a:t>- : </a:t>
+            </a:r>
+          </a:p>
+          <a:p>
+            <a:r>
+              <a:t>- : </a:t>
             </a:r>
           </a:p>
           <a:p/>
@@ -1569,33 +1796,49 @@
           <a:lstStyle/>
           <a:p>
             <a:r>
-              <a:t>SLIDE 20: Implementasi DI</a:t>
+              <a:t>SLIDE 20: Checklist Adopsi Dependency Injection</a:t>
             </a:r>
           </a:p>
           <a:p/>
           <a:p>
             <a:r>
-              <a:t>[]</a:t>
-            </a:r>
-          </a:p>
-          <a:p>
-            <a:r>
-              <a:t>- Define interfaces</a:t>
-            </a:r>
-          </a:p>
-          <a:p>
-            <a:r>
-              <a:t>- Create providers</a:t>
-            </a:r>
-          </a:p>
-          <a:p>
-            <a:r>
-              <a:t>- Register in Registry</a:t>
-            </a:r>
-          </a:p>
-          <a:p>
-            <a:r>
-              <a:t>- Resolve in consumers</a:t>
+              <a:t>Mental Model: Follow a disciplined checklist to keep architectural boundaries clean and tests fast.</a:t>
+            </a:r>
+          </a:p>
+          <a:p/>
+          <a:p>
+            <a:r>
+              <a:t>[CHECKLIST ARSITEKTUR]</a:t>
+            </a:r>
+          </a:p>
+          <a:p>
+            <a:r>
+              <a:t>- Deklarasikan dependensi sebagai interface, bukan tipe struct konkret.</a:t>
+            </a:r>
+          </a:p>
+          <a:p>
+            <a:r>
+              <a:t>- Gunakan Constructor Injection sebagai standar default; tolak setter opsional.</a:t>
+            </a:r>
+          </a:p>
+          <a:p>
+            <a:r>
+              <a:t>- Pusatkan instansiasi objek konkret hanya pada Composition Root (main.go).</a:t>
+            </a:r>
+          </a:p>
+          <a:p>
+            <a:r>
+              <a:t>- Jangan pernah mengoper Container atau Service Locator ke dalam domain logic.</a:t>
+            </a:r>
+          </a:p>
+          <a:p>
+            <a:r>
+              <a:t>- Instansiasi struct data murni (Value Objects) langsung tanpa melalui DI.</a:t>
+            </a:r>
+          </a:p>
+          <a:p>
+            <a:r>
+              <a:t>- Pastikan setiap method bisnis memiliki unit test dengan test double terisolasi.</a:t>
             </a:r>
           </a:p>
           <a:p/>
@@ -1666,28 +1909,34 @@
           <a:lstStyle/>
           <a:p>
             <a:r>
-              <a:t>SLIDE 21: Service Locator Abuse</a:t>
+              <a:t>SLIDE 21: Tiga Anti-Pattern Umum Seputar DI</a:t>
             </a:r>
           </a:p>
           <a:p/>
           <a:p>
             <a:r>
-              <a:t>[]</a:t>
-            </a:r>
-          </a:p>
-          <a:p>
-            <a:r>
-              <a:t>- Hard to track actual wiring</a:t>
-            </a:r>
-          </a:p>
-          <a:p>
-            <a:r>
-              <a:t>- Testing suffers</a:t>
-            </a:r>
-          </a:p>
-          <a:p>
-            <a:r>
-              <a:t>- Prefer constructor injection</a:t>
+              <a:t>Mental Model: Constructor bloat is a design warning: split the class, don't hide the bloat in a container.</a:t>
+            </a:r>
+          </a:p>
+          <a:p/>
+          <a:p>
+            <a:r>
+              <a:t>[ANTI-PATTERN UTAMA]</a:t>
+            </a:r>
+          </a:p>
+          <a:p>
+            <a:r>
+              <a:t>- : </a:t>
+            </a:r>
+          </a:p>
+          <a:p>
+            <a:r>
+              <a:t>- : </a:t>
+            </a:r>
+          </a:p>
+          <a:p>
+            <a:r>
+              <a:t>- : </a:t>
             </a:r>
           </a:p>
           <a:p/>
@@ -1758,13 +2007,39 @@
           <a:lstStyle/>
           <a:p>
             <a:r>
-              <a:t>SLIDE 22: Perintah Utama</a:t>
+              <a:t>SLIDE 22: Reproduksi Mandiri Suite Pengujian</a:t>
             </a:r>
           </a:p>
           <a:p/>
           <a:p>
             <a:r>
-              <a:t>[]</a:t>
+              <a:t>Mental Model: Zero-dependency standard tests guarantee instant, reproducible verification anywhere.</a:t>
+            </a:r>
+          </a:p>
+          <a:p/>
+          <a:p>
+            <a:r>
+              <a:t>[COMMAND RUNNER (GO 1.22+)]</a:t>
+            </a:r>
+          </a:p>
+          <a:p>
+            <a:r>
+              <a:t>- cd labs/16-dependency-injection</a:t>
+            </a:r>
+          </a:p>
+          <a:p>
+            <a:r>
+              <a:t>- go test -v ./...       # Verifikasi 6 skenario test suite</a:t>
+            </a:r>
+          </a:p>
+          <a:p>
+            <a:r>
+              <a:t>- go test -race ./...    # Verifikasi thread-safety zero data race</a:t>
+            </a:r>
+          </a:p>
+          <a:p>
+            <a:r>
+              <a:t>- go run ./cmd/demo      # Eksekusi demo komparasi Ctor vs Locator</a:t>
             </a:r>
           </a:p>
           <a:p/>
@@ -1835,13 +2110,34 @@
           <a:lstStyle/>
           <a:p>
             <a:r>
-              <a:t>SLIDE 23: Inversi Dependensi Sepanjang Siklus Hidup</a:t>
+              <a:t>SLIDE 23: Prinsip Arsitektur: Hollywood Principle</a:t>
             </a:r>
           </a:p>
           <a:p/>
           <a:p>
             <a:r>
-              <a:t>[]</a:t>
+              <a:t>Mental Model: Invert the control of construction to protect domain logic from infrastructure churn.</a:t>
+            </a:r>
+          </a:p>
+          <a:p/>
+          <a:p>
+            <a:r>
+              <a:t>[PRINSIP REKAYASA PERANGKAT LUNAK]</a:t>
+            </a:r>
+          </a:p>
+          <a:p>
+            <a:r>
+              <a:t>- Inversion of Control: Logika bisnis fokus mengeksekusi use case; framework/assembler yang menyediakan instrumen.</a:t>
+            </a:r>
+          </a:p>
+          <a:p>
+            <a:r>
+              <a:t>- Program to Interfaces: Modul tingkat tinggi tidak boleh bergantung pada modul tingkat rendah.</a:t>
+            </a:r>
+          </a:p>
+          <a:p>
+            <a:r>
+              <a:t>- Evolvability: Kemampuan menukar provider atau infrastruktur tanpa memicu modifikasi pada logika inti domain.</a:t>
             </a:r>
           </a:p>
           <a:p/>
@@ -1912,23 +2208,54 @@
           <a:lstStyle/>
           <a:p>
             <a:r>
-              <a:t>SLIDE 24: Terima Kasih</a:t>
+              <a:t>SLIDE 24: Pisahkan perakitan dari pemakaian; isolasi logika dari infrastruktur.</a:t>
             </a:r>
           </a:p>
           <a:p/>
           <a:p>
             <a:r>
-              <a:t>[]</a:t>
-            </a:r>
-          </a:p>
-          <a:p>
-            <a:r>
-              <a:t>- Commit: $(git rev-parse --short HEAD)</a:t>
-            </a:r>
-          </a:p>
-          <a:p>
-            <a:r>
-              <a:t>- © Lukman</a:t>
+              <a:t>Mental Model: Separate configuration from use: outside world assembles, inner logic executes.</a:t>
+            </a:r>
+          </a:p>
+          <a:p/>
+          <a:p>
+            <a:r>
+              <a:t>[MODUL LAB 16]</a:t>
+            </a:r>
+          </a:p>
+          <a:p>
+            <a:r>
+              <a:t>- internal/di/processor.go • internal/di/gateway.go • internal/di/locator.go</a:t>
+            </a:r>
+          </a:p>
+          <a:p>
+            <a:r>
+              <a:t>- cmd/demo/main.go • tests/processor_test.go • content/02-master-draft.md</a:t>
+            </a:r>
+          </a:p>
+          <a:p>
+            <a:r>
+              <a:t>[VERIFIKASI &amp; STATUS]</a:t>
+            </a:r>
+          </a:p>
+          <a:p>
+            <a:r>
+              <a:t>- Commit: 8678a90 | Go 1.22 Standard Library</a:t>
+            </a:r>
+          </a:p>
+          <a:p>
+            <a:r>
+              <a:t>- Test Suite: 6 cases passing, 0 failures, 100% deterministic.</a:t>
+            </a:r>
+          </a:p>
+          <a:p>
+            <a:r>
+              <a:t>- Race Detector: Clean pass (go test -race ./...)</a:t>
+            </a:r>
+          </a:p>
+          <a:p>
+            <a:r>
+              <a:t>- Repository: https://github.com/lukman-ss/software-engineering-lab/tree/main/labs/16-dependency-injection</a:t>
             </a:r>
           </a:p>
           <a:p/>
@@ -1999,28 +2326,34 @@
           <a:lstStyle/>
           <a:p>
             <a:r>
-              <a:t>SLIDE 3: Refactor Manual Cepat Menyisakan Leak</a:t>
+              <a:t>SLIDE 3: Review Manual Melewatkan Hidden Dependencies</a:t>
             </a:r>
           </a:p>
           <a:p/>
           <a:p>
             <a:r>
-              <a:t>[KEGAGALAN]</a:t>
-            </a:r>
-          </a:p>
-          <a:p>
-            <a:r>
-              <a:t>- Instansi tetap dibuat di tempat lama.</a:t>
-            </a:r>
-          </a:p>
-          <a:p>
-            <a:r>
-              <a:t>- Provider tidak di‑update, menyebabkan nil panic.</a:t>
-            </a:r>
-          </a:p>
-          <a:p>
-            <a:r>
-              <a:t>- Tidak ada compile‑time guard untuk missing bindings.</a:t>
+              <a:t>Mental Model: Service Locator hides dependencies inside methods; constructor injection makes them explicit at creation.</a:t>
+            </a:r>
+          </a:p>
+          <a:p/>
+          <a:p>
+            <a:r>
+              <a:t>[KELEMAHAN PENDEKATAN NAIF]</a:t>
+            </a:r>
+          </a:p>
+          <a:p>
+            <a:r>
+              <a:t>- : </a:t>
+            </a:r>
+          </a:p>
+          <a:p>
+            <a:r>
+              <a:t>- : </a:t>
+            </a:r>
+          </a:p>
+          <a:p>
+            <a:r>
+              <a:t>- : </a:t>
             </a:r>
           </a:p>
           <a:p/>
@@ -2091,13 +2424,29 @@
           <a:lstStyle/>
           <a:p>
             <a:r>
-              <a:t>SLIDE 4: Graf DI sebagai DAG</a:t>
+              <a:t>SLIDE 4: Separation of Configuration from Use</a:t>
             </a:r>
           </a:p>
           <a:p/>
           <a:p>
             <a:r>
-              <a:t>[DI Graph]</a:t>
+              <a:t>Mental Model: Assemble the graph once at startup; execute pure business logic during runtime.</a:t>
+            </a:r>
+          </a:p>
+          <a:p/>
+          <a:p>
+            <a:r>
+              <a:t>[DUA FASE TERISOLASI]</a:t>
+            </a:r>
+          </a:p>
+          <a:p>
+            <a:r>
+              <a:t>- : </a:t>
+            </a:r>
+          </a:p>
+          <a:p>
+            <a:r>
+              <a:t>- : </a:t>
             </a:r>
           </a:p>
           <a:p/>
@@ -2168,13 +2517,39 @@
           <a:lstStyle/>
           <a:p>
             <a:r>
-              <a:t>SLIDE 5: Alur Injeksi</a:t>
+              <a:t>SLIDE 5: Pipeline Alur Eksekusi Dependency Injection</a:t>
             </a:r>
           </a:p>
           <a:p/>
           <a:p>
             <a:r>
+              <a:t>Mental Model: Separate configuration from use: simple linear stages create decoupled architecture.</a:t>
+            </a:r>
+          </a:p>
+          <a:p/>
+          <a:p>
+            <a:r>
               <a:t>[]</a:t>
+            </a:r>
+          </a:p>
+          <a:p>
+            <a:r>
+              <a:t>- cmd/demo/main.go | Composition Root inisialisasi RealGateway</a:t>
+            </a:r>
+          </a:p>
+          <a:p>
+            <a:r>
+              <a:t>- di.NewProcessor(gateway) | Konstruktor menerima kontrak PaymentGateway</a:t>
+            </a:r>
+          </a:p>
+          <a:p>
+            <a:r>
+              <a:t>- processor.ProcessPayment(100) | Validasi input amount &lt;= 0 &amp; buat Money</a:t>
+            </a:r>
+          </a:p>
+          <a:p>
+            <a:r>
+              <a:t>- gateway.Charge(Money) | Delegasi eksekusi ke implementasi konkret</a:t>
             </a:r>
           </a:p>
           <a:p/>
@@ -2245,13 +2620,54 @@
           <a:lstStyle/>
           <a:p>
             <a:r>
-              <a:t>SLIDE 6: Contoh Provider</a:t>
+              <a:t>SLIDE 6: Constructor Injection: Valid State at Birth</a:t>
             </a:r>
           </a:p>
           <a:p/>
           <a:p>
             <a:r>
-              <a:t>[]</a:t>
+              <a:t>Mental Model: Explicit constructor parameters enforce immutable, valid instances at creation time.</a:t>
+            </a:r>
+          </a:p>
+          <a:p/>
+          <a:p>
+            <a:r>
+              <a:t>[INTERNAL/DI/PROCESSOR.GO]</a:t>
+            </a:r>
+          </a:p>
+          <a:p>
+            <a:r>
+              <a:t>- type Processor struct {</a:t>
+            </a:r>
+          </a:p>
+          <a:p>
+            <a:r>
+              <a:t>-     gateway PaymentGateway</a:t>
+            </a:r>
+          </a:p>
+          <a:p>
+            <a:r>
+              <a:t>- }</a:t>
+            </a:r>
+          </a:p>
+          <a:p>
+            <a:r>
+              <a:t>- </a:t>
+            </a:r>
+          </a:p>
+          <a:p>
+            <a:r>
+              <a:t>- func NewProcessor(g PaymentGateway) *Processor {</a:t>
+            </a:r>
+          </a:p>
+          <a:p>
+            <a:r>
+              <a:t>-     return &amp;Processor{gateway: g}</a:t>
+            </a:r>
+          </a:p>
+          <a:p>
+            <a:r>
+              <a:t>- }</a:t>
             </a:r>
           </a:p>
           <a:p/>
@@ -2322,28 +2738,39 @@
           <a:lstStyle/>
           <a:p>
             <a:r>
-              <a:t>SLIDE 7: Path Failure: Missing Binding</a:t>
+              <a:t>SLIDE 7: Failure Path: Pencegahan Eksekusi I/O Sia-sia</a:t>
             </a:r>
           </a:p>
           <a:p/>
           <a:p>
             <a:r>
-              <a:t>[Alur]</a:t>
-            </a:r>
-          </a:p>
-          <a:p>
-            <a:r>
-              <a:t>- Consumer requests InterfaceX.</a:t>
-            </a:r>
-          </a:p>
-          <a:p>
-            <a:r>
-              <a:t>- Resolver looks up binding → not found.</a:t>
-            </a:r>
-          </a:p>
-          <a:p>
-            <a:r>
-              <a:t>- panic: no provider for InterfaceX.</a:t>
+              <a:t>Mental Model: Validate at domain boundary; never leak invalid data into infrastructure calls.</a:t>
+            </a:r>
+          </a:p>
+          <a:p/>
+          <a:p>
+            <a:r>
+              <a:t>[]</a:t>
+            </a:r>
+          </a:p>
+          <a:p>
+            <a:r>
+              <a:t>- Input Transaksi | amount = -10 (invalid input)</a:t>
+            </a:r>
+          </a:p>
+          <a:p>
+            <a:r>
+              <a:t>- Processor Pre-check | if amount &lt;= 0 { return error }</a:t>
+            </a:r>
+          </a:p>
+          <a:p>
+            <a:r>
+              <a:t>- Short-Circuit Exit | Return errors.New("invalid amount")</a:t>
+            </a:r>
+          </a:p>
+          <a:p>
+            <a:r>
+              <a:t>- Infrastruktur Aman | gateway.Charge() tidak pernah dipanggil (Amount = 0)</a:t>
             </a:r>
           </a:p>
           <a:p/>
@@ -2414,13 +2841,44 @@
           <a:lstStyle/>
           <a:p>
             <a:r>
-              <a:t>SLIDE 8: DI vs Tanpa DI</a:t>
+              <a:t>SLIDE 8: Tabel Evaluasi Mekanisme Dependensi</a:t>
             </a:r>
           </a:p>
           <a:p/>
           <a:p>
             <a:r>
-              <a:t>[]</a:t>
+              <a:t>Mental Model: Constructor injection provides compiler-enforced transparency; service locator delays failures to runtime.</a:t>
+            </a:r>
+          </a:p>
+          <a:p/>
+          <a:p>
+            <a:r>
+              <a:t>[MATRIKS ARSITEKTUR DEPENDENSI]</a:t>
+            </a:r>
+          </a:p>
+          <a:p>
+            <a:r>
+              <a:t>- Kriteria | Hard-Coded New | Service Locator | Constructor Injection</a:t>
+            </a:r>
+          </a:p>
+          <a:p>
+            <a:r>
+              <a:t>- Transparansi Kontrak | Tertutup di method | Tertutup di container | Terbuka di constructor</a:t>
+            </a:r>
+          </a:p>
+          <a:p>
+            <a:r>
+              <a:t>- Validasi Compiler | Kuat (tipe konkret) | Lemah (runtime get) | Sangat Kuat (interface)</a:t>
+            </a:r>
+          </a:p>
+          <a:p>
+            <a:r>
+              <a:t>- Kompleksitas Test | Sangat tinggi (mock I/O) | Sedang (mock container) | Minimal (mock interface)</a:t>
+            </a:r>
+          </a:p>
+          <a:p>
+            <a:r>
+              <a:t>- Standar Industri | Anti-pattern monolit | PSR-11: SHOULD NOT | Rekomendasi Fowler / Default</a:t>
             </a:r>
           </a:p>
           <a:p/>
@@ -2491,28 +2949,34 @@
           <a:lstStyle/>
           <a:p>
             <a:r>
-              <a:t>SLIDE 9: 3 Keputusan Kunci</a:t>
+              <a:t>SLIDE 9: Tiga Keputusan Desain Dependensi</a:t>
             </a:r>
           </a:p>
           <a:p/>
           <a:p>
             <a:r>
-              <a:t>[]</a:t>
-            </a:r>
-          </a:p>
-          <a:p>
-            <a:r>
-              <a:t>- Bind per request vs singleton.</a:t>
-            </a:r>
-          </a:p>
-          <a:p>
-            <a:r>
-              <a:t>- Prefer interface over concrete.</a:t>
-            </a:r>
-          </a:p>
-          <a:p>
-            <a:r>
-              <a:t>- Use lazy provider for heavy deps.</a:t>
+              <a:t>Mental Model: Interface external boundaries, inject at constructors, instantiate value objects directly.</a:t>
+            </a:r>
+          </a:p>
+          <a:p/>
+          <a:p>
+            <a:r>
+              <a:t>[DECISION SEQUENCE]</a:t>
+            </a:r>
+          </a:p>
+          <a:p>
+            <a:r>
+              <a:t>- : </a:t>
+            </a:r>
+          </a:p>
+          <a:p>
+            <a:r>
+              <a:t>- : </a:t>
+            </a:r>
+          </a:p>
+          <a:p>
+            <a:r>
+              <a:t>- : </a:t>
             </a:r>
           </a:p>
           <a:p/>
@@ -5662,7 +6126,7 @@
               </a:defRPr>
             </a:pPr>
             <a:r>
-              <a:t>Injeksi Dependensi dengan Go Interfaces &amp; Provider</a:t>
+              <a:t>Memisahkan Konfigurasi dari Penggunaan untuk Testability &amp; Evolvability</a:t>
             </a:r>
           </a:p>
         </p:txBody>
@@ -5828,7 +6292,7 @@
               </a:defRPr>
             </a:pPr>
             <a:r>
-              <a:t>Demo Terminal</a:t>
+              <a:t>Output Demo: Eksekusi Dua Pendekatan</a:t>
             </a:r>
           </a:p>
         </p:txBody>
@@ -5863,15 +6327,15 @@
               </a:defRPr>
             </a:pPr>
             <a:r>
-              <a:t>Running demo shows injected service prints OK.</a:t>
-            </a:r>
-          </a:p>
-        </p:txBody>
-      </p:sp>
-      <p:sp>
-        <p:nvSpPr>
-          <p:cNvPr id="6" name="TextBox 5"/>
-          <p:cNvSpPr txBox="1"/>
+              <a:t>Hasil run membuktikan kesamaan fungsional dengan perbedaan struktural total.</a:t>
+            </a:r>
+          </a:p>
+        </p:txBody>
+      </p:sp>
+      <p:sp>
+        <p:nvSpPr>
+          <p:cNvPr id="6" name="Rounded Rectangle 5"/>
+          <p:cNvSpPr/>
           <p:nvPr/>
         </p:nvSpPr>
         <p:spPr>
@@ -5879,78 +6343,11 @@
             <a:off x="731520" y="1828800"/>
             <a:ext cx="5120640" cy="3383280"/>
           </a:xfrm>
-          <a:prstGeom prst="rect">
-            <a:avLst/>
-          </a:prstGeom>
-          <a:noFill/>
-        </p:spPr>
-        <p:txBody>
-          <a:bodyPr wrap="square">
-            <a:spAutoFit/>
-          </a:bodyPr>
-          <a:lstStyle/>
-          <a:p>
-            <a:pPr>
-              <a:defRPr sz="1200" b="1">
-                <a:solidFill>
-                  <a:srgbClr val="087F76"/>
-                </a:solidFill>
-              </a:defRPr>
-            </a:pPr>
-          </a:p>
-        </p:txBody>
-      </p:sp>
-      <p:sp>
-        <p:nvSpPr>
-          <p:cNvPr id="7" name="TextBox 6"/>
-          <p:cNvSpPr txBox="1"/>
-          <p:nvPr/>
-        </p:nvSpPr>
-        <p:spPr>
-          <a:xfrm>
-            <a:off x="6217920" y="1828800"/>
-            <a:ext cx="5303520" cy="3383280"/>
-          </a:xfrm>
-          <a:prstGeom prst="rect">
-            <a:avLst/>
-          </a:prstGeom>
-          <a:noFill/>
-        </p:spPr>
-        <p:txBody>
-          <a:bodyPr wrap="square">
-            <a:spAutoFit/>
-          </a:bodyPr>
-          <a:lstStyle/>
-          <a:p>
-            <a:pPr>
-              <a:lnSpc>
-                <a:spcPct val="135000"/>
-              </a:lnSpc>
-              <a:defRPr sz="1300">
-                <a:solidFill>
-                  <a:srgbClr val="0B1B2D"/>
-                </a:solidFill>
-              </a:defRPr>
-            </a:pPr>
-          </a:p>
-        </p:txBody>
-      </p:sp>
-      <p:sp>
-        <p:nvSpPr>
-          <p:cNvPr id="8" name="Rectangle 7"/>
-          <p:cNvSpPr/>
-          <p:nvPr/>
-        </p:nvSpPr>
-        <p:spPr>
-          <a:xfrm>
-            <a:off x="731520" y="5394960"/>
-            <a:ext cx="10728655" cy="594360"/>
-          </a:xfrm>
-          <a:prstGeom prst="rect">
+          <a:prstGeom prst="roundRect">
             <a:avLst/>
           </a:prstGeom>
           <a:solidFill>
-            <a:srgbClr val="087F76"/>
+            <a:srgbClr val="0B1B2D"/>
           </a:solidFill>
           <a:ln>
             <a:noFill/>
@@ -5971,6 +6368,113 @@
           </a:fontRef>
         </p:style>
         <p:txBody>
+          <a:bodyPr rtlCol="0" anchor="ctr" wrap="square"/>
+          <a:lstStyle/>
+          <a:p>
+            <a:pPr algn="ctr">
+              <a:defRPr sz="1100">
+                <a:solidFill>
+                  <a:srgbClr val="E2E8F0"/>
+                </a:solidFill>
+                <a:latin typeface="Courier New"/>
+              </a:defRPr>
+            </a:pPr>
+            <a:r>
+              <a:t>$ go run ./cmd/demo</a:t>
+            </a:r>
+            <a:br/>
+            <a:r>
+              <a:t>--- Running Constructor Injection ---</a:t>
+            </a:r>
+            <a:br/>
+            <a:r>
+              <a:t>RealGateway charging 100 USD</a:t>
+            </a:r>
+            <a:br/>
+            <a:r>
+              <a:t>--- Running Service Locator ---</a:t>
+            </a:r>
+            <a:br/>
+            <a:r>
+              <a:t>RealGateway charging 200 USD</a:t>
+            </a:r>
+          </a:p>
+        </p:txBody>
+      </p:sp>
+      <p:sp>
+        <p:nvSpPr>
+          <p:cNvPr id="7" name="TextBox 6"/>
+          <p:cNvSpPr txBox="1"/>
+          <p:nvPr/>
+        </p:nvSpPr>
+        <p:spPr>
+          <a:xfrm>
+            <a:off x="6217920" y="1828800"/>
+            <a:ext cx="5303520" cy="3383280"/>
+          </a:xfrm>
+          <a:prstGeom prst="rect">
+            <a:avLst/>
+          </a:prstGeom>
+          <a:noFill/>
+        </p:spPr>
+        <p:txBody>
+          <a:bodyPr wrap="square">
+            <a:spAutoFit/>
+          </a:bodyPr>
+          <a:lstStyle/>
+          <a:p>
+            <a:pPr>
+              <a:lnSpc>
+                <a:spcPct val="135000"/>
+              </a:lnSpc>
+              <a:defRPr sz="1300">
+                <a:solidFill>
+                  <a:srgbClr val="0B1B2D"/>
+                </a:solidFill>
+              </a:defRPr>
+            </a:pPr>
+            <a:r>
+              <a:t>Demo membuktikan bahwa kedua pola berhasil mendistribusikan pembayaran ke RealGateway, namun Constructor Injection mencapai hasil ini tanpa keterikatan pada API container.</a:t>
+            </a:r>
+          </a:p>
+        </p:txBody>
+      </p:sp>
+      <p:sp>
+        <p:nvSpPr>
+          <p:cNvPr id="8" name="Rectangle 7"/>
+          <p:cNvSpPr/>
+          <p:nvPr/>
+        </p:nvSpPr>
+        <p:spPr>
+          <a:xfrm>
+            <a:off x="731520" y="5394960"/>
+            <a:ext cx="10728655" cy="594360"/>
+          </a:xfrm>
+          <a:prstGeom prst="rect">
+            <a:avLst/>
+          </a:prstGeom>
+          <a:solidFill>
+            <a:srgbClr val="087F76"/>
+          </a:solidFill>
+          <a:ln>
+            <a:noFill/>
+          </a:ln>
+        </p:spPr>
+        <p:style>
+          <a:lnRef idx="1">
+            <a:schemeClr val="accent1"/>
+          </a:lnRef>
+          <a:fillRef idx="3">
+            <a:schemeClr val="accent1"/>
+          </a:fillRef>
+          <a:effectRef idx="2">
+            <a:schemeClr val="accent1"/>
+          </a:effectRef>
+          <a:fontRef idx="minor">
+            <a:schemeClr val="lt1"/>
+          </a:fontRef>
+        </p:style>
+        <p:txBody>
           <a:bodyPr rtlCol="0" anchor="ctr"/>
           <a:lstStyle/>
           <a:p>
@@ -5981,6 +6485,9 @@
                 </a:solidFill>
               </a:defRPr>
             </a:pPr>
+            <a:r>
+              <a:t>Functional equivalence in execution; architectural superiority in isolation.</a:t>
+            </a:r>
           </a:p>
         </p:txBody>
       </p:sp>
@@ -6013,6 +6520,9 @@
                 </a:solidFill>
               </a:defRPr>
             </a:pPr>
+            <a:r>
+              <a:t>cmd/demo/main.go</a:t>
+            </a:r>
           </a:p>
         </p:txBody>
       </p:sp>
@@ -6177,7 +6687,7 @@
               </a:defRPr>
             </a:pPr>
             <a:r>
-              <a:t>Yang Tidak Dibuktikan</a:t>
+              <a:t>Batasan Bukti: Cakupan Verifikasi Lab</a:t>
             </a:r>
           </a:p>
         </p:txBody>
@@ -6212,7 +6722,7 @@
               </a:defRPr>
             </a:pPr>
             <a:r>
-              <a:t>DI tidak mengatasi network latency.</a:t>
+              <a:t>Memisahkan fakta terverifikasi laboratorium dari asumsi ekosistem produksi.</a:t>
             </a:r>
           </a:p>
         </p:txBody>
@@ -6246,6 +6756,9 @@
                 </a:solidFill>
               </a:defRPr>
             </a:pPr>
+            <a:r>
+              <a:t>YANG TERBUKTI DI LAB</a:t>
+            </a:r>
           </a:p>
           <a:p>
             <a:pPr>
@@ -6259,7 +6772,7 @@
               </a:defRPr>
             </a:pPr>
             <a:r>
-              <a:t>• Performance impact not measured</a:t>
+              <a:t>• MockGateway mengisolasi Processor 100% tanpa jaringan.</a:t>
             </a:r>
           </a:p>
           <a:p>
@@ -6274,7 +6787,109 @@
               </a:defRPr>
             </a:pPr>
             <a:r>
-              <a:t>• Runtime errors beyond binding not covered</a:t>
+              <a:t>• Validasi pre-check mencegah pemanggilan gateway.</a:t>
+            </a:r>
+          </a:p>
+          <a:p>
+            <a:pPr>
+              <a:spcAft>
+                <a:spcPts val="400"/>
+              </a:spcAft>
+              <a:defRPr sz="1200">
+                <a:solidFill>
+                  <a:srgbClr val="0B1B2D"/>
+                </a:solidFill>
+              </a:defRPr>
+            </a:pPr>
+            <a:r>
+              <a:t>• Error gateway dipropagasikan utuh ke caller.</a:t>
+            </a:r>
+          </a:p>
+          <a:p>
+            <a:pPr>
+              <a:spcAft>
+                <a:spcPts val="400"/>
+              </a:spcAft>
+              <a:defRPr sz="1200">
+                <a:solidFill>
+                  <a:srgbClr val="0B1B2D"/>
+                </a:solidFill>
+              </a:defRPr>
+            </a:pPr>
+            <a:r>
+              <a:t>• Race detector bersih tanpa data race.</a:t>
+            </a:r>
+          </a:p>
+          <a:p>
+            <a:pPr>
+              <a:defRPr sz="1200" b="1">
+                <a:solidFill>
+                  <a:srgbClr val="087F76"/>
+                </a:solidFill>
+              </a:defRPr>
+            </a:pPr>
+            <a:r>
+              <a:t>YANG TIDAK DIBUKTIKAN</a:t>
+            </a:r>
+          </a:p>
+          <a:p>
+            <a:pPr>
+              <a:spcAft>
+                <a:spcPts val="400"/>
+              </a:spcAft>
+              <a:defRPr sz="1200">
+                <a:solidFill>
+                  <a:srgbClr val="0B1B2D"/>
+                </a:solidFill>
+              </a:defRPr>
+            </a:pPr>
+            <a:r>
+              <a:t>• Overhead performa container vs direct instantiation.</a:t>
+            </a:r>
+          </a:p>
+          <a:p>
+            <a:pPr>
+              <a:spcAft>
+                <a:spcPts val="400"/>
+              </a:spcAft>
+              <a:defRPr sz="1200">
+                <a:solidFill>
+                  <a:srgbClr val="0B1B2D"/>
+                </a:solidFill>
+              </a:defRPr>
+            </a:pPr>
+            <a:r>
+              <a:t>• Korelasi penurunan angka bug/defect di tim engineering.</a:t>
+            </a:r>
+          </a:p>
+          <a:p>
+            <a:pPr>
+              <a:spcAft>
+                <a:spcPts val="400"/>
+              </a:spcAft>
+              <a:defRPr sz="1200">
+                <a:solidFill>
+                  <a:srgbClr val="0B1B2D"/>
+                </a:solidFill>
+              </a:defRPr>
+            </a:pPr>
+            <a:r>
+              <a:t>• Lifecycle manajemen (Singleton, Scoped, Transient).</a:t>
+            </a:r>
+          </a:p>
+          <a:p>
+            <a:pPr>
+              <a:spcAft>
+                <a:spcPts val="400"/>
+              </a:spcAft>
+              <a:defRPr sz="1200">
+                <a:solidFill>
+                  <a:srgbClr val="0B1B2D"/>
+                </a:solidFill>
+              </a:defRPr>
+            </a:pPr>
+            <a:r>
+              <a:t>• Efektivitas DI framework otomatis (Wire, Dig) skala besar.</a:t>
             </a:r>
           </a:p>
         </p:txBody>
@@ -6312,7 +6927,7 @@
               </a:defRPr>
             </a:pPr>
             <a:r>
-              <a:t>Performance impact not measured Runtime errors beyond binding not covered</a:t>
+              <a:t>Lab membuktikan keunggulan struktural dan kemudahan pengujian unit. Lab tidak mengukur klaim performa runtime microbenchmark atau lifecycle container tingkat lanjut.</a:t>
             </a:r>
           </a:p>
         </p:txBody>
@@ -6363,6 +6978,9 @@
                 </a:solidFill>
               </a:defRPr>
             </a:pPr>
+            <a:r>
+              <a:t>Tests verify isolation and contract adherence, not ecosystem-scale lifecycle management.</a:t>
+            </a:r>
           </a:p>
         </p:txBody>
       </p:sp>
@@ -6395,6 +7013,9 @@
                 </a:solidFill>
               </a:defRPr>
             </a:pPr>
+            <a:r>
+              <a:t>content/01-content-brief.md • engineering-audit/05-gaps.md</a:t>
+            </a:r>
           </a:p>
         </p:txBody>
       </p:sp>
@@ -6559,7 +7180,7 @@
               </a:defRPr>
             </a:pPr>
             <a:r>
-              <a:t>Keuntungan vs Overhead</a:t>
+              <a:t>Trade-off: Kontrol Bersih vs Biaya Boilerplate</a:t>
             </a:r>
           </a:p>
         </p:txBody>
@@ -6594,7 +7215,7 @@
               </a:defRPr>
             </a:pPr>
             <a:r>
-              <a:t>Cleaner code vs extra indirection.</a:t>
+              <a:t>Keuntungan modularitas harus dibayar dengan disiplin perakitan dependensi.</a:t>
             </a:r>
           </a:p>
         </p:txBody>
@@ -6628,6 +7249,9 @@
                 </a:solidFill>
               </a:defRPr>
             </a:pPr>
+            <a:r>
+              <a:t>KEUNTUNGAN DIPEROLEH</a:t>
+            </a:r>
           </a:p>
           <a:p>
             <a:pPr>
@@ -6641,7 +7265,7 @@
               </a:defRPr>
             </a:pPr>
             <a:r>
-              <a:t>• Improved testability</a:t>
+              <a:t>• Isolasi total: unit test berjalan cepat dalam orde mikrodetik.</a:t>
             </a:r>
           </a:p>
           <a:p>
@@ -6656,7 +7280,7 @@
               </a:defRPr>
             </a:pPr>
             <a:r>
-              <a:t>• Slight latency</a:t>
+              <a:t>• Vendor agnostic: ganti gateway tanpa sentuh logika bisnis.</a:t>
             </a:r>
           </a:p>
           <a:p>
@@ -6671,7 +7295,64 @@
               </a:defRPr>
             </a:pPr>
             <a:r>
-              <a:t>• More boilerplate</a:t>
+              <a:t>• Immutabilitas: dependensi tidak dapat diganti sembarangan di runtime.</a:t>
+            </a:r>
+          </a:p>
+          <a:p>
+            <a:pPr>
+              <a:defRPr sz="1200" b="1">
+                <a:solidFill>
+                  <a:srgbClr val="087F76"/>
+                </a:solidFill>
+              </a:defRPr>
+            </a:pPr>
+            <a:r>
+              <a:t>KONSEKUENSI DIHADAPI</a:t>
+            </a:r>
+          </a:p>
+          <a:p>
+            <a:pPr>
+              <a:spcAft>
+                <a:spcPts val="400"/>
+              </a:spcAft>
+              <a:defRPr sz="1200">
+                <a:solidFill>
+                  <a:srgbClr val="0B1B2D"/>
+                </a:solidFill>
+              </a:defRPr>
+            </a:pPr>
+            <a:r>
+              <a:t>• Manual wiring menambah baris inisialisasi di composition root.</a:t>
+            </a:r>
+          </a:p>
+          <a:p>
+            <a:pPr>
+              <a:spcAft>
+                <a:spcPts val="400"/>
+              </a:spcAft>
+              <a:defRPr sz="1200">
+                <a:solidFill>
+                  <a:srgbClr val="0B1B2D"/>
+                </a:solidFill>
+              </a:defRPr>
+            </a:pPr>
+            <a:r>
+              <a:t>• Tracing alur kode memerlukan navigasi antarmuka interface.</a:t>
+            </a:r>
+          </a:p>
+          <a:p>
+            <a:pPr>
+              <a:spcAft>
+                <a:spcPts val="400"/>
+              </a:spcAft>
+              <a:defRPr sz="1200">
+                <a:solidFill>
+                  <a:srgbClr val="0B1B2D"/>
+                </a:solidFill>
+              </a:defRPr>
+            </a:pPr>
+            <a:r>
+              <a:t>• Risiko constructor bloat jika kelas melanggar Single Responsibility.</a:t>
             </a:r>
           </a:p>
         </p:txBody>
@@ -6709,7 +7390,7 @@
               </a:defRPr>
             </a:pPr>
             <a:r>
-              <a:t>Improved testability Slight latency More boilerplate</a:t>
+              <a:t>DI bukan solusi tanpa biaya. Keuntungan testability dan fleksibilitas harus diimbangi dengan kehati-hatian agar constructor tidak membengkak karena service terlalu besar.</a:t>
             </a:r>
           </a:p>
         </p:txBody>
@@ -6760,6 +7441,9 @@
                 </a:solidFill>
               </a:defRPr>
             </a:pPr>
+            <a:r>
+              <a:t>Every decoupled boundary trades runtime simplicity for construction ceremony.</a:t>
+            </a:r>
           </a:p>
         </p:txBody>
       </p:sp>
@@ -6792,6 +7476,9 @@
                 </a:solidFill>
               </a:defRPr>
             </a:pPr>
+            <a:r>
+              <a:t>content/02-master-draft.md</a:t>
+            </a:r>
           </a:p>
         </p:txBody>
       </p:sp>
@@ -6956,7 +7643,7 @@
               </a:defRPr>
             </a:pPr>
             <a:r>
-              <a:t>Goroutine Safe Registry</a:t>
+              <a:t>Pipeline Validasi &amp; Thread-Safety</a:t>
             </a:r>
           </a:p>
         </p:txBody>
@@ -6991,15 +7678,15 @@
               </a:defRPr>
             </a:pPr>
             <a:r>
-              <a:t>Mutex protects binding map.</a:t>
-            </a:r>
-          </a:p>
-        </p:txBody>
-      </p:sp>
-      <p:sp>
-        <p:nvSpPr>
-          <p:cNvPr id="6" name="Rounded Rectangle 5"/>
-          <p:cNvSpPr/>
+              <a:t>Processor berstatus stateless dan aman dieksekusi lintas goroutine paralel.</a:t>
+            </a:r>
+          </a:p>
+        </p:txBody>
+      </p:sp>
+      <p:sp>
+        <p:nvSpPr>
+          <p:cNvPr id="6" name="TextBox 5"/>
+          <p:cNvSpPr txBox="1"/>
           <p:nvPr/>
         </p:nvSpPr>
         <p:spPr>
@@ -7007,11 +7694,141 @@
             <a:off x="731520" y="1828800"/>
             <a:ext cx="5120640" cy="3383280"/>
           </a:xfrm>
-          <a:prstGeom prst="roundRect">
+          <a:prstGeom prst="rect">
+            <a:avLst/>
+          </a:prstGeom>
+          <a:noFill/>
+        </p:spPr>
+        <p:txBody>
+          <a:bodyPr wrap="square">
+            <a:spAutoFit/>
+          </a:bodyPr>
+          <a:lstStyle/>
+          <a:p>
+            <a:pPr>
+              <a:defRPr sz="1200" b="1">
+                <a:solidFill>
+                  <a:srgbClr val="087F76"/>
+                </a:solidFill>
+              </a:defRPr>
+            </a:pPr>
+          </a:p>
+          <a:p>
+            <a:pPr>
+              <a:spcAft>
+                <a:spcPts val="400"/>
+              </a:spcAft>
+              <a:defRPr sz="1200">
+                <a:solidFill>
+                  <a:srgbClr val="0B1B2D"/>
+                </a:solidFill>
+              </a:defRPr>
+            </a:pPr>
+            <a:r>
+              <a:t>• Goroutine Request | Panggilan concurrent ke ProcessPayment(amount)</a:t>
+            </a:r>
+          </a:p>
+          <a:p>
+            <a:pPr>
+              <a:spcAft>
+                <a:spcPts val="400"/>
+              </a:spcAft>
+              <a:defRPr sz="1200">
+                <a:solidFill>
+                  <a:srgbClr val="0B1B2D"/>
+                </a:solidFill>
+              </a:defRPr>
+            </a:pPr>
+            <a:r>
+              <a:t>• Pure Pre-Validation | amount &lt;= 0 dicek tanpa mutasi shared state</a:t>
+            </a:r>
+          </a:p>
+          <a:p>
+            <a:pPr>
+              <a:spcAft>
+                <a:spcPts val="400"/>
+              </a:spcAft>
+              <a:defRPr sz="1200">
+                <a:solidFill>
+                  <a:srgbClr val="0B1B2D"/>
+                </a:solidFill>
+              </a:defRPr>
+            </a:pPr>
+            <a:r>
+              <a:t>• Value Object Build | Money{Amount, Currency} dialokasikan per request</a:t>
+            </a:r>
+          </a:p>
+          <a:p>
+            <a:pPr>
+              <a:spcAft>
+                <a:spcPts val="400"/>
+              </a:spcAft>
+              <a:defRPr sz="1200">
+                <a:solidFill>
+                  <a:srgbClr val="0B1B2D"/>
+                </a:solidFill>
+              </a:defRPr>
+            </a:pPr>
+            <a:r>
+              <a:t>• Thread-Safe Charge | Gateway dieksekusi secara aman (Race Clean)</a:t>
+            </a:r>
+          </a:p>
+        </p:txBody>
+      </p:sp>
+      <p:sp>
+        <p:nvSpPr>
+          <p:cNvPr id="7" name="TextBox 6"/>
+          <p:cNvSpPr txBox="1"/>
+          <p:nvPr/>
+        </p:nvSpPr>
+        <p:spPr>
+          <a:xfrm>
+            <a:off x="6217920" y="1828800"/>
+            <a:ext cx="5303520" cy="3383280"/>
+          </a:xfrm>
+          <a:prstGeom prst="rect">
+            <a:avLst/>
+          </a:prstGeom>
+          <a:noFill/>
+        </p:spPr>
+        <p:txBody>
+          <a:bodyPr wrap="square">
+            <a:spAutoFit/>
+          </a:bodyPr>
+          <a:lstStyle/>
+          <a:p>
+            <a:pPr>
+              <a:lnSpc>
+                <a:spcPct val="135000"/>
+              </a:lnSpc>
+              <a:defRPr sz="1300">
+                <a:solidFill>
+                  <a:srgbClr val="0B1B2D"/>
+                </a:solidFill>
+              </a:defRPr>
+            </a:pPr>
+            <a:r>
+              <a:t>Karena Processor tidak menyimpan state yang dapat dimutasi (hanya menyimpan reference interface gateway yang stateless), pemrosesan pembayaran bebas dari race condition.</a:t>
+            </a:r>
+          </a:p>
+        </p:txBody>
+      </p:sp>
+      <p:sp>
+        <p:nvSpPr>
+          <p:cNvPr id="8" name="Rectangle 7"/>
+          <p:cNvSpPr/>
+          <p:nvPr/>
+        </p:nvSpPr>
+        <p:spPr>
+          <a:xfrm>
+            <a:off x="731520" y="5394960"/>
+            <a:ext cx="10728655" cy="594360"/>
+          </a:xfrm>
+          <a:prstGeom prst="rect">
             <a:avLst/>
           </a:prstGeom>
           <a:solidFill>
-            <a:srgbClr val="0B1B2D"/>
+            <a:srgbClr val="087F76"/>
           </a:solidFill>
           <a:ln>
             <a:noFill/>
@@ -7032,91 +7849,6 @@
           </a:fontRef>
         </p:style>
         <p:txBody>
-          <a:bodyPr rtlCol="0" anchor="ctr" wrap="square"/>
-          <a:lstStyle/>
-          <a:p>
-            <a:pPr algn="ctr">
-              <a:defRPr sz="1100">
-                <a:solidFill>
-                  <a:srgbClr val="E2E8F0"/>
-                </a:solidFill>
-                <a:latin typeface="Courier New"/>
-              </a:defRPr>
-            </a:pPr>
-          </a:p>
-        </p:txBody>
-      </p:sp>
-      <p:sp>
-        <p:nvSpPr>
-          <p:cNvPr id="7" name="TextBox 6"/>
-          <p:cNvSpPr txBox="1"/>
-          <p:nvPr/>
-        </p:nvSpPr>
-        <p:spPr>
-          <a:xfrm>
-            <a:off x="6217920" y="1828800"/>
-            <a:ext cx="5303520" cy="3383280"/>
-          </a:xfrm>
-          <a:prstGeom prst="rect">
-            <a:avLst/>
-          </a:prstGeom>
-          <a:noFill/>
-        </p:spPr>
-        <p:txBody>
-          <a:bodyPr wrap="square">
-            <a:spAutoFit/>
-          </a:bodyPr>
-          <a:lstStyle/>
-          <a:p>
-            <a:pPr>
-              <a:lnSpc>
-                <a:spcPct val="135000"/>
-              </a:lnSpc>
-              <a:defRPr sz="1300">
-                <a:solidFill>
-                  <a:srgbClr val="0B1B2D"/>
-                </a:solidFill>
-              </a:defRPr>
-            </a:pPr>
-          </a:p>
-        </p:txBody>
-      </p:sp>
-      <p:sp>
-        <p:nvSpPr>
-          <p:cNvPr id="8" name="Rectangle 7"/>
-          <p:cNvSpPr/>
-          <p:nvPr/>
-        </p:nvSpPr>
-        <p:spPr>
-          <a:xfrm>
-            <a:off x="731520" y="5394960"/>
-            <a:ext cx="10728655" cy="594360"/>
-          </a:xfrm>
-          <a:prstGeom prst="rect">
-            <a:avLst/>
-          </a:prstGeom>
-          <a:solidFill>
-            <a:srgbClr val="087F76"/>
-          </a:solidFill>
-          <a:ln>
-            <a:noFill/>
-          </a:ln>
-        </p:spPr>
-        <p:style>
-          <a:lnRef idx="1">
-            <a:schemeClr val="accent1"/>
-          </a:lnRef>
-          <a:fillRef idx="3">
-            <a:schemeClr val="accent1"/>
-          </a:fillRef>
-          <a:effectRef idx="2">
-            <a:schemeClr val="accent1"/>
-          </a:effectRef>
-          <a:fontRef idx="minor">
-            <a:schemeClr val="lt1"/>
-          </a:fontRef>
-        </p:style>
-        <p:txBody>
           <a:bodyPr rtlCol="0" anchor="ctr"/>
           <a:lstStyle/>
           <a:p>
@@ -7127,6 +7859,9 @@
                 </a:solidFill>
               </a:defRPr>
             </a:pPr>
+            <a:r>
+              <a:t>Immutable dependency references make services inherently safe for concurrent execution.</a:t>
+            </a:r>
           </a:p>
         </p:txBody>
       </p:sp>
@@ -7159,6 +7894,9 @@
                 </a:solidFill>
               </a:defRPr>
             </a:pPr>
+            <a:r>
+              <a:t>internal/di/processor.go • tests/processor_test.go</a:t>
+            </a:r>
           </a:p>
         </p:txBody>
       </p:sp>
@@ -7323,7 +8061,7 @@
               </a:defRPr>
             </a:pPr>
             <a:r>
-              <a:t>Sebelum &amp; Sesudah</a:t>
+              <a:t>Sebelum vs Sesudah Penerapan DI</a:t>
             </a:r>
           </a:p>
         </p:txBody>
@@ -7358,7 +8096,7 @@
               </a:defRPr>
             </a:pPr>
             <a:r>
-              <a:t>Hard‑coded vs injected.</a:t>
+              <a:t>Transformasi kode rapuh menjadi komponen yang teruji dan adaptif.</a:t>
             </a:r>
           </a:p>
         </p:txBody>
@@ -7392,6 +8130,141 @@
                 </a:solidFill>
               </a:defRPr>
             </a:pPr>
+            <a:r>
+              <a:t>SEBELUM: TIGHTLY COUPLED</a:t>
+            </a:r>
+          </a:p>
+          <a:p>
+            <a:pPr>
+              <a:spcAft>
+                <a:spcPts val="400"/>
+              </a:spcAft>
+              <a:defRPr sz="1200">
+                <a:solidFill>
+                  <a:srgbClr val="0B1B2D"/>
+                </a:solidFill>
+              </a:defRPr>
+            </a:pPr>
+            <a:r>
+              <a:t>• Processor memanggil new RealGateway() secara internal.</a:t>
+            </a:r>
+          </a:p>
+          <a:p>
+            <a:pPr>
+              <a:spcAft>
+                <a:spcPts val="400"/>
+              </a:spcAft>
+              <a:defRPr sz="1200">
+                <a:solidFill>
+                  <a:srgbClr val="0B1B2D"/>
+                </a:solidFill>
+              </a:defRPr>
+            </a:pPr>
+            <a:r>
+              <a:t>• Unit test terpaksa menghubungi server gateway nyata.</a:t>
+            </a:r>
+          </a:p>
+          <a:p>
+            <a:pPr>
+              <a:spcAft>
+                <a:spcPts val="400"/>
+              </a:spcAft>
+              <a:defRPr sz="1200">
+                <a:solidFill>
+                  <a:srgbClr val="0B1B2D"/>
+                </a:solidFill>
+              </a:defRPr>
+            </a:pPr>
+            <a:r>
+              <a:t>• Pergantian vendor menuntut perubahan di logika bisnis.</a:t>
+            </a:r>
+          </a:p>
+          <a:p>
+            <a:pPr>
+              <a:spcAft>
+                <a:spcPts val="400"/>
+              </a:spcAft>
+              <a:defRPr sz="1200">
+                <a:solidFill>
+                  <a:srgbClr val="0B1B2D"/>
+                </a:solidFill>
+              </a:defRPr>
+            </a:pPr>
+            <a:r>
+              <a:t>• Sulit menguji skenario kegagalan jaringan secara deterministik.</a:t>
+            </a:r>
+          </a:p>
+          <a:p>
+            <a:pPr>
+              <a:defRPr sz="1200" b="1">
+                <a:solidFill>
+                  <a:srgbClr val="087F76"/>
+                </a:solidFill>
+              </a:defRPr>
+            </a:pPr>
+            <a:r>
+              <a:t>SESUDAH: CONSTRUCTOR INJECTION</a:t>
+            </a:r>
+          </a:p>
+          <a:p>
+            <a:pPr>
+              <a:spcAft>
+                <a:spcPts val="400"/>
+              </a:spcAft>
+              <a:defRPr sz="1200">
+                <a:solidFill>
+                  <a:srgbClr val="0B1B2D"/>
+                </a:solidFill>
+              </a:defRPr>
+            </a:pPr>
+            <a:r>
+              <a:t>• Processor menerima PaymentGateway via NewProcessor.</a:t>
+            </a:r>
+          </a:p>
+          <a:p>
+            <a:pPr>
+              <a:spcAft>
+                <a:spcPts val="400"/>
+              </a:spcAft>
+              <a:defRPr sz="1200">
+                <a:solidFill>
+                  <a:srgbClr val="0B1B2D"/>
+                </a:solidFill>
+              </a:defRPr>
+            </a:pPr>
+            <a:r>
+              <a:t>• Unit test menyuntikkan MockGateway tanpa sentuh jaringan.</a:t>
+            </a:r>
+          </a:p>
+          <a:p>
+            <a:pPr>
+              <a:spcAft>
+                <a:spcPts val="400"/>
+              </a:spcAft>
+              <a:defRPr sz="1200">
+                <a:solidFill>
+                  <a:srgbClr val="0B1B2D"/>
+                </a:solidFill>
+              </a:defRPr>
+            </a:pPr>
+            <a:r>
+              <a:t>• Pergantian vendor hanya mengubah satu baris di main.go.</a:t>
+            </a:r>
+          </a:p>
+          <a:p>
+            <a:pPr>
+              <a:spcAft>
+                <a:spcPts val="400"/>
+              </a:spcAft>
+              <a:defRPr sz="1200">
+                <a:solidFill>
+                  <a:srgbClr val="0B1B2D"/>
+                </a:solidFill>
+              </a:defRPr>
+            </a:pPr>
+            <a:r>
+              <a:t>• Skenario kegagalan gateway dapat diuji deterministik 100%.</a:t>
+            </a:r>
           </a:p>
         </p:txBody>
       </p:sp>
@@ -7427,6 +8300,9 @@
                 </a:solidFill>
               </a:defRPr>
             </a:pPr>
+            <a:r>
+              <a:t>Sebelumnya, setiap pengujian bergantung pada kestabilan koneksi internet ke vendor. Sesudah DI, seluruh skenario ekstrim dapat disimulasikan seketika di memori lokal.</a:t>
+            </a:r>
           </a:p>
         </p:txBody>
       </p:sp>
@@ -7476,6 +8352,9 @@
                 </a:solidFill>
               </a:defRPr>
             </a:pPr>
+            <a:r>
+              <a:t>Decoupled interfaces turn brittle integration tests into ultra-fast deterministic unit tests.</a:t>
+            </a:r>
           </a:p>
         </p:txBody>
       </p:sp>
@@ -7508,6 +8387,9 @@
                 </a:solidFill>
               </a:defRPr>
             </a:pPr>
+            <a:r>
+              <a:t>content/02-master-draft.md • tests/processor_test.go</a:t>
+            </a:r>
           </a:p>
         </p:txBody>
       </p:sp>
@@ -7672,7 +8554,7 @@
               </a:defRPr>
             </a:pPr>
             <a:r>
-              <a:t>Test Coverage</a:t>
+              <a:t>Test Suite 01: Verifikasi Happy Path Terisolasi</a:t>
             </a:r>
           </a:p>
         </p:txBody>
@@ -7706,6 +8588,9 @@
                 </a:solidFill>
               </a:defRPr>
             </a:pPr>
+            <a:r>
+              <a:t>Pengujian mengeksekusi transfer 50 USD tanpa membuka koneksi jaringan.</a:t>
+            </a:r>
           </a:p>
         </p:txBody>
       </p:sp>
@@ -7738,6 +8623,9 @@
                 </a:solidFill>
               </a:defRPr>
             </a:pPr>
+            <a:r>
+              <a:t>VERIFIKASI SUKSES</a:t>
+            </a:r>
           </a:p>
           <a:p>
             <a:pPr>
@@ -7751,7 +8639,7 @@
               </a:defRPr>
             </a:pPr>
             <a:r>
-              <a:t>• Key assertion from processor_test.go</a:t>
+              <a:t>• :  ()</a:t>
             </a:r>
           </a:p>
           <a:p>
@@ -7766,7 +8654,7 @@
               </a:defRPr>
             </a:pPr>
             <a:r>
-              <a:t>• Demonstrates mock replacement</a:t>
+              <a:t>• :  ()</a:t>
             </a:r>
           </a:p>
           <a:p>
@@ -7781,7 +8669,7 @@
               </a:defRPr>
             </a:pPr>
             <a:r>
-              <a:t>• Shows panic recovery</a:t>
+              <a:t>• :  ()</a:t>
             </a:r>
           </a:p>
         </p:txBody>
@@ -7819,7 +8707,7 @@
               </a:defRPr>
             </a:pPr>
             <a:r>
-              <a:t>Key assertion from processor_test.go Demonstrates mock replacement Shows panic recovery</a:t>
+              <a:t>Test happy path membuktikan bahwa Processor mendelegasikan data secara akurat ke gateway tanpa perlu mengetahui implementasi di belakang interface.</a:t>
             </a:r>
           </a:p>
         </p:txBody>
@@ -7870,6 +8758,9 @@
                 </a:solidFill>
               </a:defRPr>
             </a:pPr>
+            <a:r>
+              <a:t>Mock substitution proves delegation accuracy without touching concrete infrastructure.</a:t>
+            </a:r>
           </a:p>
         </p:txBody>
       </p:sp>
@@ -7902,6 +8793,9 @@
                 </a:solidFill>
               </a:defRPr>
             </a:pPr>
+            <a:r>
+              <a:t>tests/processor_test.go:23-35</a:t>
+            </a:r>
           </a:p>
         </p:txBody>
       </p:sp>
@@ -8066,7 +8960,7 @@
               </a:defRPr>
             </a:pPr>
             <a:r>
-              <a:t>Mock Injection</a:t>
+              <a:t>Test Suite 02: Propagasi Kegagalan Gateway</a:t>
             </a:r>
           </a:p>
         </p:txBody>
@@ -8100,6 +8994,9 @@
                 </a:solidFill>
               </a:defRPr>
             </a:pPr>
+            <a:r>
+              <a:t>Memverifikasi error dari infrastruktur diteruskan utuh tanpa ditelan.</a:t>
+            </a:r>
           </a:p>
         </p:txBody>
       </p:sp>
@@ -8132,6 +9029,9 @@
                 </a:solidFill>
               </a:defRPr>
             </a:pPr>
+            <a:r>
+              <a:t>VERIFIKASI PROPAGASI ERROR</a:t>
+            </a:r>
           </a:p>
           <a:p>
             <a:pPr>
@@ -8145,7 +9045,7 @@
               </a:defRPr>
             </a:pPr>
             <a:r>
-              <a:t>• Key assertion from processor_test.go</a:t>
+              <a:t>• :  ()</a:t>
             </a:r>
           </a:p>
           <a:p>
@@ -8160,7 +9060,7 @@
               </a:defRPr>
             </a:pPr>
             <a:r>
-              <a:t>• Demonstrates mock replacement</a:t>
+              <a:t>• :  ()</a:t>
             </a:r>
           </a:p>
           <a:p>
@@ -8175,7 +9075,7 @@
               </a:defRPr>
             </a:pPr>
             <a:r>
-              <a:t>• Shows panic recovery</a:t>
+              <a:t>• :  ()</a:t>
             </a:r>
           </a:p>
         </p:txBody>
@@ -8213,7 +9113,7 @@
               </a:defRPr>
             </a:pPr>
             <a:r>
-              <a:t>Key assertion from processor_test.go Demonstrates mock replacement Shows panic recovery</a:t>
+              <a:t>Menguji kegagalan gateway pada arsitektur tightly coupled sangat sulit. Dengan DI, kegagalan vendor dapat disimulasikan hanya dengan mengaktifkan flag pada test double.</a:t>
             </a:r>
           </a:p>
         </p:txBody>
@@ -8264,6 +9164,9 @@
                 </a:solidFill>
               </a:defRPr>
             </a:pPr>
+            <a:r>
+              <a:t>Deterministic error simulation verifies resilient error propagation paths.</a:t>
+            </a:r>
           </a:p>
         </p:txBody>
       </p:sp>
@@ -8296,6 +9199,9 @@
                 </a:solidFill>
               </a:defRPr>
             </a:pPr>
+            <a:r>
+              <a:t>tests/processor_test.go:37-45</a:t>
+            </a:r>
           </a:p>
         </p:txBody>
       </p:sp>
@@ -8460,7 +9366,7 @@
               </a:defRPr>
             </a:pPr>
             <a:r>
-              <a:t>Error Propagation</a:t>
+              <a:t>Test Suite 03: Short-Circuit Invalid Amount</a:t>
             </a:r>
           </a:p>
         </p:txBody>
@@ -8494,6 +9400,9 @@
                 </a:solidFill>
               </a:defRPr>
             </a:pPr>
+            <a:r>
+              <a:t>Memastikan gateway tidak pernah dipanggil jika parameter nominal salah.</a:t>
+            </a:r>
           </a:p>
         </p:txBody>
       </p:sp>
@@ -8526,6 +9435,9 @@
                 </a:solidFill>
               </a:defRPr>
             </a:pPr>
+            <a:r>
+              <a:t>VERIFIKASI SHORT-CIRCUIT</a:t>
+            </a:r>
           </a:p>
           <a:p>
             <a:pPr>
@@ -8539,7 +9451,7 @@
               </a:defRPr>
             </a:pPr>
             <a:r>
-              <a:t>• Key assertion from processor_test.go</a:t>
+              <a:t>• :  ()</a:t>
             </a:r>
           </a:p>
           <a:p>
@@ -8554,7 +9466,7 @@
               </a:defRPr>
             </a:pPr>
             <a:r>
-              <a:t>• Demonstrates mock replacement</a:t>
+              <a:t>• :  ()</a:t>
             </a:r>
           </a:p>
           <a:p>
@@ -8569,7 +9481,7 @@
               </a:defRPr>
             </a:pPr>
             <a:r>
-              <a:t>• Shows panic recovery</a:t>
+              <a:t>• :  ()</a:t>
             </a:r>
           </a:p>
         </p:txBody>
@@ -8607,7 +9519,7 @@
               </a:defRPr>
             </a:pPr>
             <a:r>
-              <a:t>Key assertion from processor_test.go Demonstrates mock replacement Shows panic recovery</a:t>
+              <a:t>Kombinasi assertion error dan pemeriksaan nilai 0 pada mock membuktikan bahwa validasi pre-check berhasil menghentikan alur sebelum mencapai lapisan infrastruktur.</a:t>
             </a:r>
           </a:p>
         </p:txBody>
@@ -8658,6 +9570,9 @@
                 </a:solidFill>
               </a:defRPr>
             </a:pPr>
+            <a:r>
+              <a:t>Asserting zero interaction with downstream services proves boundary validation effectiveness.</a:t>
+            </a:r>
           </a:p>
         </p:txBody>
       </p:sp>
@@ -8690,6 +9605,9 @@
                 </a:solidFill>
               </a:defRPr>
             </a:pPr>
+            <a:r>
+              <a:t>tests/processor_test.go:47-59</a:t>
+            </a:r>
           </a:p>
         </p:txBody>
       </p:sp>
@@ -8854,7 +9772,7 @@
               </a:defRPr>
             </a:pPr>
             <a:r>
-              <a:t>Performance Benchmark</a:t>
+              <a:t>Desain Rasional: Value Object Bebas DI</a:t>
             </a:r>
           </a:p>
         </p:txBody>
@@ -8888,6 +9806,9 @@
                 </a:solidFill>
               </a:defRPr>
             </a:pPr>
+            <a:r>
+              <a:t>Money dan DTO murni dibuat langsung tanpa melewati container injector.</a:t>
+            </a:r>
           </a:p>
         </p:txBody>
       </p:sp>
@@ -8920,6 +9841,9 @@
                 </a:solidFill>
               </a:defRPr>
             </a:pPr>
+            <a:r>
+              <a:t>PRINSIP VALUE OBJECT</a:t>
+            </a:r>
           </a:p>
           <a:p>
             <a:pPr>
@@ -8933,7 +9857,7 @@
               </a:defRPr>
             </a:pPr>
             <a:r>
-              <a:t>• Key assertion from processor_test.go</a:t>
+              <a:t>• :  ()</a:t>
             </a:r>
           </a:p>
           <a:p>
@@ -8948,7 +9872,7 @@
               </a:defRPr>
             </a:pPr>
             <a:r>
-              <a:t>• Demonstrates mock replacement</a:t>
+              <a:t>• :  ()</a:t>
             </a:r>
           </a:p>
           <a:p>
@@ -8963,7 +9887,7 @@
               </a:defRPr>
             </a:pPr>
             <a:r>
-              <a:t>• Shows panic recovery</a:t>
+              <a:t>• :  ()</a:t>
             </a:r>
           </a:p>
         </p:txBody>
@@ -9001,7 +9925,7 @@
               </a:defRPr>
             </a:pPr>
             <a:r>
-              <a:t>Key assertion from processor_test.go Demonstrates mock replacement Shows panic recovery</a:t>
+              <a:t>Kesalahan umum pemula adalah menginjeksikan segalanya. Value object seperti Money, Date, atau Alamat adalah representasi data murni yang harus diinstansiasi langsung.</a:t>
             </a:r>
           </a:p>
         </p:txBody>
@@ -9052,6 +9976,9 @@
                 </a:solidFill>
               </a:defRPr>
             </a:pPr>
+            <a:r>
+              <a:t>Inject services that cross boundaries; instantiate pure value objects directly.</a:t>
+            </a:r>
           </a:p>
         </p:txBody>
       </p:sp>
@@ -9084,6 +10011,9 @@
                 </a:solidFill>
               </a:defRPr>
             </a:pPr>
+            <a:r>
+              <a:t>internal/di/gateway.go:5-9 • internal/di/processor.go:19</a:t>
+            </a:r>
           </a:p>
         </p:txBody>
       </p:sp>
@@ -9248,7 +10178,7 @@
               </a:defRPr>
             </a:pPr>
             <a:r>
-              <a:t>Reflection Safety</a:t>
+              <a:t>Bahaya Service Locator: PSR-11 Warning</a:t>
             </a:r>
           </a:p>
         </p:txBody>
@@ -9282,6 +10212,9 @@
                 </a:solidFill>
               </a:defRPr>
             </a:pPr>
+            <a:r>
+              <a:t>Menyuntikkan container ke domain menyamarkan dependensi dan merusak pengujian.</a:t>
+            </a:r>
           </a:p>
         </p:txBody>
       </p:sp>
@@ -9314,6 +10247,9 @@
                 </a:solidFill>
               </a:defRPr>
             </a:pPr>
+            <a:r>
+              <a:t>DAMPAK NEGATIF SERVICE LOCATOR</a:t>
+            </a:r>
           </a:p>
           <a:p>
             <a:pPr>
@@ -9327,7 +10263,7 @@
               </a:defRPr>
             </a:pPr>
             <a:r>
-              <a:t>• Key assertion from processor_test.go</a:t>
+              <a:t>• :  ()</a:t>
             </a:r>
           </a:p>
           <a:p>
@@ -9342,7 +10278,7 @@
               </a:defRPr>
             </a:pPr>
             <a:r>
-              <a:t>• Demonstrates mock replacement</a:t>
+              <a:t>• :  ()</a:t>
             </a:r>
           </a:p>
           <a:p>
@@ -9357,7 +10293,7 @@
               </a:defRPr>
             </a:pPr>
             <a:r>
-              <a:t>• Shows panic recovery</a:t>
+              <a:t>• :  ()</a:t>
             </a:r>
           </a:p>
         </p:txBody>
@@ -9395,7 +10331,7 @@
               </a:defRPr>
             </a:pPr>
             <a:r>
-              <a:t>Key assertion from processor_test.go Demonstrates mock replacement Shows panic recovery</a:t>
+              <a:t>Service Locator adalah ilusi decoupling. Alih-alih terikat pada RealGateway, kelas justru terikat erat pada API Container yang lebih rumit untuk di-mock.</a:t>
             </a:r>
           </a:p>
         </p:txBody>
@@ -9446,6 +10382,9 @@
                 </a:solidFill>
               </a:defRPr>
             </a:pPr>
+            <a:r>
+              <a:t>Passing a container to domain logic replaces one tight coupling with an even broader one.</a:t>
+            </a:r>
           </a:p>
         </p:txBody>
       </p:sp>
@@ -9478,6 +10417,9 @@
                 </a:solidFill>
               </a:defRPr>
             </a:pPr>
+            <a:r>
+              <a:t>internal/di/locator.go • tests/processor_test.go:61-108</a:t>
+            </a:r>
           </a:p>
         </p:txBody>
       </p:sp>
@@ -9642,7 +10584,7 @@
               </a:defRPr>
             </a:pPr>
             <a:r>
-              <a:t>Kegagalan Komponen Tanpa DI</a:t>
+              <a:t>Infrastruktur Terkunci di Logika Bisnis</a:t>
             </a:r>
           </a:p>
         </p:txBody>
@@ -9677,7 +10619,7 @@
               </a:defRPr>
             </a:pPr>
             <a:r>
-              <a:t>Hard‑coded dependencies menyebabkan test flakiness &amp; scaling issues.</a:t>
+              <a:t>Ketika modul bisnis membuat dependensinya sendiri, isolasi dan pengujian runtuh.</a:t>
             </a:r>
           </a:p>
         </p:txBody>
@@ -9712,7 +10654,7 @@
               </a:defRPr>
             </a:pPr>
             <a:r>
-              <a:t>MASALAH NYATA</a:t>
+              <a:t>MASALAH PRODUKSI</a:t>
             </a:r>
           </a:p>
           <a:p>
@@ -9727,7 +10669,7 @@
               </a:defRPr>
             </a:pPr>
             <a:r>
-              <a:t>• Komponen menginisialisasi dependensi internal secara langsung.</a:t>
+              <a:t>• :  ()</a:t>
             </a:r>
           </a:p>
           <a:p>
@@ -9742,7 +10684,7 @@
               </a:defRPr>
             </a:pPr>
             <a:r>
-              <a:t>• Mocking menjadi mustahil, sehingga unit test tidak isolasi.</a:t>
+              <a:t>• :  ()</a:t>
             </a:r>
           </a:p>
           <a:p>
@@ -9757,7 +10699,7 @@
               </a:defRPr>
             </a:pPr>
             <a:r>
-              <a:t>• Perubahan implementasi memaksa rebuild seluruh service.</a:t>
+              <a:t>• :  ()</a:t>
             </a:r>
           </a:p>
         </p:txBody>
@@ -9795,7 +10737,7 @@
               </a:defRPr>
             </a:pPr>
             <a:r>
-              <a:t>Komponen menginisialisasi dependensi internal secara langsung. Mocking menjadi mustahil, sehingga unit test tidak isolasi. Perubahan implementasi memaksa rebuild seluruh service.</a:t>
+              <a:t>Kopling keras antara logika domain dan implementasi infrastruktur merusak evolvability sistem. Pengujian unit menjadi mustahil dilakukan secara murni tanpa network overhead.</a:t>
             </a:r>
           </a:p>
         </p:txBody>
@@ -9846,6 +10788,9 @@
                 </a:solidFill>
               </a:defRPr>
             </a:pPr>
+            <a:r>
+              <a:t>Hard-coded dependencies fuse domain logic to external plumbing, destroying testability.</a:t>
+            </a:r>
           </a:p>
         </p:txBody>
       </p:sp>
@@ -9878,6 +10823,9 @@
                 </a:solidFill>
               </a:defRPr>
             </a:pPr>
+            <a:r>
+              <a:t>content/02-master-draft.md</a:t>
+            </a:r>
           </a:p>
         </p:txBody>
       </p:sp>
@@ -10042,7 +10990,7 @@
               </a:defRPr>
             </a:pPr>
             <a:r>
-              <a:t>Implementasi DI</a:t>
+              <a:t>Checklist Adopsi Dependency Injection</a:t>
             </a:r>
           </a:p>
         </p:txBody>
@@ -10077,7 +11025,7 @@
               </a:defRPr>
             </a:pPr>
             <a:r>
-              <a:t>Langkah‑langkah siap.</a:t>
+              <a:t>Panduan langkah praktis menerapkan DI yang bersih pada proyek produksi.</a:t>
             </a:r>
           </a:p>
         </p:txBody>
@@ -10111,6 +11059,9 @@
                 </a:solidFill>
               </a:defRPr>
             </a:pPr>
+            <a:r>
+              <a:t>CHECKLIST ARSITEKTUR</a:t>
+            </a:r>
           </a:p>
           <a:p>
             <a:pPr>
@@ -10124,7 +11075,7 @@
               </a:defRPr>
             </a:pPr>
             <a:r>
-              <a:t>• Define interfaces</a:t>
+              <a:t>• Deklarasikan dependensi sebagai interface, bukan tipe struct konkret.</a:t>
             </a:r>
           </a:p>
           <a:p>
@@ -10139,7 +11090,7 @@
               </a:defRPr>
             </a:pPr>
             <a:r>
-              <a:t>• Create providers</a:t>
+              <a:t>• Gunakan Constructor Injection sebagai standar default; tolak setter opsional.</a:t>
             </a:r>
           </a:p>
           <a:p>
@@ -10154,7 +11105,7 @@
               </a:defRPr>
             </a:pPr>
             <a:r>
-              <a:t>• Register in Registry</a:t>
+              <a:t>• Pusatkan instansiasi objek konkret hanya pada Composition Root (main.go).</a:t>
             </a:r>
           </a:p>
           <a:p>
@@ -10169,7 +11120,37 @@
               </a:defRPr>
             </a:pPr>
             <a:r>
-              <a:t>• Resolve in consumers</a:t>
+              <a:t>• Jangan pernah mengoper Container atau Service Locator ke dalam domain logic.</a:t>
+            </a:r>
+          </a:p>
+          <a:p>
+            <a:pPr>
+              <a:spcAft>
+                <a:spcPts val="400"/>
+              </a:spcAft>
+              <a:defRPr sz="1200">
+                <a:solidFill>
+                  <a:srgbClr val="0B1B2D"/>
+                </a:solidFill>
+              </a:defRPr>
+            </a:pPr>
+            <a:r>
+              <a:t>• Instansiasi struct data murni (Value Objects) langsung tanpa melalui DI.</a:t>
+            </a:r>
+          </a:p>
+          <a:p>
+            <a:pPr>
+              <a:spcAft>
+                <a:spcPts val="400"/>
+              </a:spcAft>
+              <a:defRPr sz="1200">
+                <a:solidFill>
+                  <a:srgbClr val="0B1B2D"/>
+                </a:solidFill>
+              </a:defRPr>
+            </a:pPr>
+            <a:r>
+              <a:t>• Pastikan setiap method bisnis memiliki unit test dengan test double terisolasi.</a:t>
             </a:r>
           </a:p>
         </p:txBody>
@@ -10207,7 +11188,7 @@
               </a:defRPr>
             </a:pPr>
             <a:r>
-              <a:t>Define interfaces Create providers Register in Registry Resolve in consumers</a:t>
+              <a:t>Checklist ini menjadi panduan praktis dalam code review untuk mencegah bocornya dependensi konkret ke dalam domain logic tim.</a:t>
             </a:r>
           </a:p>
         </p:txBody>
@@ -10258,6 +11239,9 @@
                 </a:solidFill>
               </a:defRPr>
             </a:pPr>
+            <a:r>
+              <a:t>Follow a disciplined checklist to keep architectural boundaries clean and tests fast.</a:t>
+            </a:r>
           </a:p>
         </p:txBody>
       </p:sp>
@@ -10290,6 +11274,9 @@
                 </a:solidFill>
               </a:defRPr>
             </a:pPr>
+            <a:r>
+              <a:t>content/02-master-draft.md:155-167</a:t>
+            </a:r>
           </a:p>
         </p:txBody>
       </p:sp>
@@ -10454,7 +11441,7 @@
               </a:defRPr>
             </a:pPr>
             <a:r>
-              <a:t>Service Locator Abuse</a:t>
+              <a:t>Tiga Anti-Pattern Umum Seputar DI</a:t>
             </a:r>
           </a:p>
         </p:txBody>
@@ -10489,7 +11476,7 @@
               </a:defRPr>
             </a:pPr>
             <a:r>
-              <a:t>Global locator hides dependencies.</a:t>
+              <a:t>Kesalahan arsitektural yang sering ditemui saat mengadopsi pola injeksi.</a:t>
             </a:r>
           </a:p>
         </p:txBody>
@@ -10523,6 +11510,9 @@
                 </a:solidFill>
               </a:defRPr>
             </a:pPr>
+            <a:r>
+              <a:t>ANTI-PATTERN UTAMA</a:t>
+            </a:r>
           </a:p>
           <a:p>
             <a:pPr>
@@ -10536,7 +11526,7 @@
               </a:defRPr>
             </a:pPr>
             <a:r>
-              <a:t>• Hard to track actual wiring</a:t>
+              <a:t>• :  ()</a:t>
             </a:r>
           </a:p>
           <a:p>
@@ -10551,7 +11541,7 @@
               </a:defRPr>
             </a:pPr>
             <a:r>
-              <a:t>• Testing suffers</a:t>
+              <a:t>• :  ()</a:t>
             </a:r>
           </a:p>
           <a:p>
@@ -10566,7 +11556,7 @@
               </a:defRPr>
             </a:pPr>
             <a:r>
-              <a:t>• Prefer constructor injection</a:t>
+              <a:t>• :  ()</a:t>
             </a:r>
           </a:p>
         </p:txBody>
@@ -10604,7 +11594,7 @@
               </a:defRPr>
             </a:pPr>
             <a:r>
-              <a:t>Hard to track actual wiring Testing suffers Prefer constructor injection</a:t>
+              <a:t>DI bukan alasan untuk membiarkan sebuah kelas menangani terlalu banyak hal. Jika parameter konstruktor membengkak, solusinya adalah memecah kelas, bukan memakai Service Locator.</a:t>
             </a:r>
           </a:p>
         </p:txBody>
@@ -10655,6 +11645,9 @@
                 </a:solidFill>
               </a:defRPr>
             </a:pPr>
+            <a:r>
+              <a:t>Constructor bloat is a design warning: split the class, don't hide the bloat in a container.</a:t>
+            </a:r>
           </a:p>
         </p:txBody>
       </p:sp>
@@ -10687,6 +11680,9 @@
                 </a:solidFill>
               </a:defRPr>
             </a:pPr>
+            <a:r>
+              <a:t>content/02-master-draft.md:135-146</a:t>
+            </a:r>
           </a:p>
         </p:txBody>
       </p:sp>
@@ -10851,7 +11847,7 @@
               </a:defRPr>
             </a:pPr>
             <a:r>
-              <a:t>Perintah Utama</a:t>
+              <a:t>Reproduksi Mandiri Suite Pengujian</a:t>
             </a:r>
           </a:p>
         </p:txBody>
@@ -10886,15 +11882,15 @@
               </a:defRPr>
             </a:pPr>
             <a:r>
-              <a:t>go run cmd/demo/main.go &amp;&amp; go test ./...</a:t>
-            </a:r>
-          </a:p>
-        </p:txBody>
-      </p:sp>
-      <p:sp>
-        <p:nvSpPr>
-          <p:cNvPr id="6" name="TextBox 5"/>
-          <p:cNvSpPr txBox="1"/>
+              <a:t>Verifikasi seluruh invarian dependency injection secara mandiri di mesin lokal.</a:t>
+            </a:r>
+          </a:p>
+        </p:txBody>
+      </p:sp>
+      <p:sp>
+        <p:nvSpPr>
+          <p:cNvPr id="6" name="Rounded Rectangle 5"/>
+          <p:cNvSpPr/>
           <p:nvPr/>
         </p:nvSpPr>
         <p:spPr>
@@ -10902,78 +11898,11 @@
             <a:off x="731520" y="1828800"/>
             <a:ext cx="5120640" cy="3383280"/>
           </a:xfrm>
-          <a:prstGeom prst="rect">
-            <a:avLst/>
-          </a:prstGeom>
-          <a:noFill/>
-        </p:spPr>
-        <p:txBody>
-          <a:bodyPr wrap="square">
-            <a:spAutoFit/>
-          </a:bodyPr>
-          <a:lstStyle/>
-          <a:p>
-            <a:pPr>
-              <a:defRPr sz="1200" b="1">
-                <a:solidFill>
-                  <a:srgbClr val="087F76"/>
-                </a:solidFill>
-              </a:defRPr>
-            </a:pPr>
-          </a:p>
-        </p:txBody>
-      </p:sp>
-      <p:sp>
-        <p:nvSpPr>
-          <p:cNvPr id="7" name="TextBox 6"/>
-          <p:cNvSpPr txBox="1"/>
-          <p:nvPr/>
-        </p:nvSpPr>
-        <p:spPr>
-          <a:xfrm>
-            <a:off x="6217920" y="1828800"/>
-            <a:ext cx="5303520" cy="3383280"/>
-          </a:xfrm>
-          <a:prstGeom prst="rect">
-            <a:avLst/>
-          </a:prstGeom>
-          <a:noFill/>
-        </p:spPr>
-        <p:txBody>
-          <a:bodyPr wrap="square">
-            <a:spAutoFit/>
-          </a:bodyPr>
-          <a:lstStyle/>
-          <a:p>
-            <a:pPr>
-              <a:lnSpc>
-                <a:spcPct val="135000"/>
-              </a:lnSpc>
-              <a:defRPr sz="1300">
-                <a:solidFill>
-                  <a:srgbClr val="0B1B2D"/>
-                </a:solidFill>
-              </a:defRPr>
-            </a:pPr>
-          </a:p>
-        </p:txBody>
-      </p:sp>
-      <p:sp>
-        <p:nvSpPr>
-          <p:cNvPr id="8" name="Rectangle 7"/>
-          <p:cNvSpPr/>
-          <p:nvPr/>
-        </p:nvSpPr>
-        <p:spPr>
-          <a:xfrm>
-            <a:off x="731520" y="5394960"/>
-            <a:ext cx="10728655" cy="594360"/>
-          </a:xfrm>
-          <a:prstGeom prst="rect">
+          <a:prstGeom prst="roundRect">
             <a:avLst/>
           </a:prstGeom>
           <a:solidFill>
-            <a:srgbClr val="087F76"/>
+            <a:srgbClr val="0B1B2D"/>
           </a:solidFill>
           <a:ln>
             <a:noFill/>
@@ -10994,6 +11923,109 @@
           </a:fontRef>
         </p:style>
         <p:txBody>
+          <a:bodyPr rtlCol="0" anchor="ctr" wrap="square"/>
+          <a:lstStyle/>
+          <a:p>
+            <a:pPr algn="ctr">
+              <a:defRPr sz="1100">
+                <a:solidFill>
+                  <a:srgbClr val="E2E8F0"/>
+                </a:solidFill>
+                <a:latin typeface="Courier New"/>
+              </a:defRPr>
+            </a:pPr>
+            <a:r>
+              <a:t>cd labs/16-dependency-injection</a:t>
+            </a:r>
+            <a:br/>
+            <a:r>
+              <a:t>go test -v ./...       # Verifikasi 6 skenario test suite</a:t>
+            </a:r>
+            <a:br/>
+            <a:r>
+              <a:t>go test -race ./...    # Verifikasi thread-safety zero data race</a:t>
+            </a:r>
+            <a:br/>
+            <a:r>
+              <a:t>go run ./cmd/demo      # Eksekusi demo komparasi Ctor vs Locator</a:t>
+            </a:r>
+          </a:p>
+        </p:txBody>
+      </p:sp>
+      <p:sp>
+        <p:nvSpPr>
+          <p:cNvPr id="7" name="TextBox 6"/>
+          <p:cNvSpPr txBox="1"/>
+          <p:nvPr/>
+        </p:nvSpPr>
+        <p:spPr>
+          <a:xfrm>
+            <a:off x="6217920" y="1828800"/>
+            <a:ext cx="5303520" cy="3383280"/>
+          </a:xfrm>
+          <a:prstGeom prst="rect">
+            <a:avLst/>
+          </a:prstGeom>
+          <a:noFill/>
+        </p:spPr>
+        <p:txBody>
+          <a:bodyPr wrap="square">
+            <a:spAutoFit/>
+          </a:bodyPr>
+          <a:lstStyle/>
+          <a:p>
+            <a:pPr>
+              <a:lnSpc>
+                <a:spcPct val="135000"/>
+              </a:lnSpc>
+              <a:defRPr sz="1300">
+                <a:solidFill>
+                  <a:srgbClr val="0B1B2D"/>
+                </a:solidFill>
+              </a:defRPr>
+            </a:pPr>
+            <a:r>
+              <a:t>Lab ini sepenuhnya berbasis Go standard library tanpa external dependencies. Seluruh verifikasi dapat direproduksi dalam hitungan detik di lingkungan apa pun.</a:t>
+            </a:r>
+          </a:p>
+        </p:txBody>
+      </p:sp>
+      <p:sp>
+        <p:nvSpPr>
+          <p:cNvPr id="8" name="Rectangle 7"/>
+          <p:cNvSpPr/>
+          <p:nvPr/>
+        </p:nvSpPr>
+        <p:spPr>
+          <a:xfrm>
+            <a:off x="731520" y="5394960"/>
+            <a:ext cx="10728655" cy="594360"/>
+          </a:xfrm>
+          <a:prstGeom prst="rect">
+            <a:avLst/>
+          </a:prstGeom>
+          <a:solidFill>
+            <a:srgbClr val="087F76"/>
+          </a:solidFill>
+          <a:ln>
+            <a:noFill/>
+          </a:ln>
+        </p:spPr>
+        <p:style>
+          <a:lnRef idx="1">
+            <a:schemeClr val="accent1"/>
+          </a:lnRef>
+          <a:fillRef idx="3">
+            <a:schemeClr val="accent1"/>
+          </a:fillRef>
+          <a:effectRef idx="2">
+            <a:schemeClr val="accent1"/>
+          </a:effectRef>
+          <a:fontRef idx="minor">
+            <a:schemeClr val="lt1"/>
+          </a:fontRef>
+        </p:style>
+        <p:txBody>
           <a:bodyPr rtlCol="0" anchor="ctr"/>
           <a:lstStyle/>
           <a:p>
@@ -11004,6 +12036,9 @@
                 </a:solidFill>
               </a:defRPr>
             </a:pPr>
+            <a:r>
+              <a:t>Zero-dependency standard tests guarantee instant, reproducible verification anywhere.</a:t>
+            </a:r>
           </a:p>
         </p:txBody>
       </p:sp>
@@ -11036,6 +12071,9 @@
                 </a:solidFill>
               </a:defRPr>
             </a:pPr>
+            <a:r>
+              <a:t>README.md • go.mod • tests/processor_test.go</a:t>
+            </a:r>
           </a:p>
         </p:txBody>
       </p:sp>
@@ -11200,7 +12238,7 @@
               </a:defRPr>
             </a:pPr>
             <a:r>
-              <a:t>Inversi Dependensi Sepanjang Siklus Hidup</a:t>
+              <a:t>Prinsip Arsitektur: Hollywood Principle</a:t>
             </a:r>
           </a:p>
         </p:txBody>
@@ -11235,7 +12273,7 @@
               </a:defRPr>
             </a:pPr>
             <a:r>
-              <a:t>Keep abstractions stable, implementations fluid.</a:t>
+              <a:t>Don't call us, we'll call you — membalikkan arah kendali dependensi sistem.</a:t>
             </a:r>
           </a:p>
         </p:txBody>
@@ -11269,6 +12307,54 @@
                 </a:solidFill>
               </a:defRPr>
             </a:pPr>
+            <a:r>
+              <a:t>PRINSIP REKAYASA PERANGKAT LUNAK</a:t>
+            </a:r>
+          </a:p>
+          <a:p>
+            <a:pPr>
+              <a:spcAft>
+                <a:spcPts val="400"/>
+              </a:spcAft>
+              <a:defRPr sz="1200">
+                <a:solidFill>
+                  <a:srgbClr val="0B1B2D"/>
+                </a:solidFill>
+              </a:defRPr>
+            </a:pPr>
+            <a:r>
+              <a:t>• Inversion of Control: Logika bisnis fokus mengeksekusi use case; framework/assembler yang menyediakan instrumen.</a:t>
+            </a:r>
+          </a:p>
+          <a:p>
+            <a:pPr>
+              <a:spcAft>
+                <a:spcPts val="400"/>
+              </a:spcAft>
+              <a:defRPr sz="1200">
+                <a:solidFill>
+                  <a:srgbClr val="0B1B2D"/>
+                </a:solidFill>
+              </a:defRPr>
+            </a:pPr>
+            <a:r>
+              <a:t>• Program to Interfaces: Modul tingkat tinggi tidak boleh bergantung pada modul tingkat rendah.</a:t>
+            </a:r>
+          </a:p>
+          <a:p>
+            <a:pPr>
+              <a:spcAft>
+                <a:spcPts val="400"/>
+              </a:spcAft>
+              <a:defRPr sz="1200">
+                <a:solidFill>
+                  <a:srgbClr val="0B1B2D"/>
+                </a:solidFill>
+              </a:defRPr>
+            </a:pPr>
+            <a:r>
+              <a:t>• Evolvability: Kemampuan menukar provider atau infrastruktur tanpa memicu modifikasi pada logika inti domain.</a:t>
+            </a:r>
           </a:p>
         </p:txBody>
       </p:sp>
@@ -11304,6 +12390,9 @@
                 </a:solidFill>
               </a:defRPr>
             </a:pPr>
+            <a:r>
+              <a:t>Dependency Injection adalah perwujudan konkret dari Dependency Inversion Principle. Dengan membalik kontrol pembuatan objek, sistem menjadi adaptif terhadap perubahan zaman.</a:t>
+            </a:r>
           </a:p>
         </p:txBody>
       </p:sp>
@@ -11353,6 +12442,9 @@
                 </a:solidFill>
               </a:defRPr>
             </a:pPr>
+            <a:r>
+              <a:t>Invert the control of construction to protect domain logic from infrastructure churn.</a:t>
+            </a:r>
           </a:p>
         </p:txBody>
       </p:sp>
@@ -11385,6 +12477,9 @@
                 </a:solidFill>
               </a:defRPr>
             </a:pPr>
+            <a:r>
+              <a:t>content/05-key-takeaways.md</a:t>
+            </a:r>
           </a:p>
         </p:txBody>
       </p:sp>
@@ -11549,7 +12644,7 @@
               </a:defRPr>
             </a:pPr>
             <a:r>
-              <a:t>Terima Kasih</a:t>
+              <a:t>Pisahkan perakitan dari pemakaian; isolasi logika dari infrastruktur.</a:t>
             </a:r>
           </a:p>
         </p:txBody>
@@ -11583,6 +12678,9 @@
                 </a:solidFill>
               </a:defRPr>
             </a:pPr>
+            <a:r>
+              <a:t>Separate configuration from use: outside world assembles, inner logic executes.</a:t>
+            </a:r>
           </a:p>
         </p:txBody>
       </p:sp>
@@ -11627,6 +12725,9 @@
                 </a:solidFill>
               </a:defRPr>
             </a:pPr>
+            <a:r>
+              <a:t>https://github.com/lukman-ss/software-engineering-lab/tree/main/labs/16-dependency-injection</a:t>
+            </a:r>
           </a:p>
           <a:p>
             <a:br/>
@@ -11698,7 +12799,7 @@
               </a:defRPr>
             </a:pPr>
             <a:r>
-              <a:t>Sumber: commit $(git re</a:t>
+              <a:t>Sumber: commit 8678a90</a:t>
             </a:r>
           </a:p>
           <a:p>
@@ -11757,7 +12858,7 @@
               </a:defRPr>
             </a:pPr>
             <a:r>
-              <a:t>DI • Go • Interfaces • Provider • Testability</a:t>
+              <a:t>Dependency Injection • Inversion of Control • Go • Test Doubles • Software Architecture</a:t>
             </a:r>
           </a:p>
         </p:txBody>
@@ -11923,7 +13024,7 @@
               </a:defRPr>
             </a:pPr>
             <a:r>
-              <a:t>Refactor Manual Cepat Menyisakan Leak</a:t>
+              <a:t>Review Manual Melewatkan Hidden Dependencies</a:t>
             </a:r>
           </a:p>
         </p:txBody>
@@ -11958,7 +13059,7 @@
               </a:defRPr>
             </a:pPr>
             <a:r>
-              <a:t>Developer mengganti konstruktor tapi melupakan wiring di provider.</a:t>
+              <a:t>Service Locator tampak bersih di permukaan namun menyembunyikan kontrak asli.</a:t>
             </a:r>
           </a:p>
         </p:txBody>
@@ -11993,7 +13094,7 @@
               </a:defRPr>
             </a:pPr>
             <a:r>
-              <a:t>KEGAGALAN</a:t>
+              <a:t>KELEMAHAN PENDEKATAN NAIF</a:t>
             </a:r>
           </a:p>
           <a:p>
@@ -12008,7 +13109,7 @@
               </a:defRPr>
             </a:pPr>
             <a:r>
-              <a:t>• Instansi tetap dibuat di tempat lama.</a:t>
+              <a:t>• :  ()</a:t>
             </a:r>
           </a:p>
           <a:p>
@@ -12023,7 +13124,7 @@
               </a:defRPr>
             </a:pPr>
             <a:r>
-              <a:t>• Provider tidak di‑update, menyebabkan nil panic.</a:t>
+              <a:t>• :  ()</a:t>
             </a:r>
           </a:p>
           <a:p>
@@ -12038,7 +13139,7 @@
               </a:defRPr>
             </a:pPr>
             <a:r>
-              <a:t>• Tidak ada compile‑time guard untuk missing bindings.</a:t>
+              <a:t>• :  ()</a:t>
             </a:r>
           </a:p>
         </p:txBody>
@@ -12076,7 +13177,7 @@
               </a:defRPr>
             </a:pPr>
             <a:r>
-              <a:t>Instansi tetap dibuat di tempat lama. Provider tidak di‑update, menyebabkan nil panic. Tidak ada compile‑time guard untuk missing bindings.</a:t>
+              <a:t>Reviewer manusia melihat parameter Container dan menganggap modularitas tercapai. Faktanya, Service Locator hanya memindahkan kopling dari compile-time ke runtime.</a:t>
             </a:r>
           </a:p>
         </p:txBody>
@@ -12127,6 +13228,9 @@
                 </a:solidFill>
               </a:defRPr>
             </a:pPr>
+            <a:r>
+              <a:t>Service Locator hides dependencies inside methods; constructor injection makes them explicit at creation.</a:t>
+            </a:r>
           </a:p>
         </p:txBody>
       </p:sp>
@@ -12159,6 +13263,9 @@
                 </a:solidFill>
               </a:defRPr>
             </a:pPr>
+            <a:r>
+              <a:t>internal/di/locator.go</a:t>
+            </a:r>
           </a:p>
         </p:txBody>
       </p:sp>
@@ -12323,7 +13430,7 @@
               </a:defRPr>
             </a:pPr>
             <a:r>
-              <a:t>Graf DI sebagai DAG</a:t>
+              <a:t>Separation of Configuration from Use</a:t>
             </a:r>
           </a:p>
         </p:txBody>
@@ -12358,7 +13465,7 @@
               </a:defRPr>
             </a:pPr>
             <a:r>
-              <a:t>Nodes = Interfaces, Edges = Providers, acyclic guarantee.</a:t>
+              <a:t>Fowler: fase perakitan objek terpisah total dari fase eksekusi logika bisnis.</a:t>
             </a:r>
           </a:p>
         </p:txBody>
@@ -12393,7 +13500,37 @@
               </a:defRPr>
             </a:pPr>
             <a:r>
-              <a:t>DI GRAPH</a:t>
+              <a:t>DUA FASE TERISOLASI</a:t>
+            </a:r>
+          </a:p>
+          <a:p>
+            <a:pPr>
+              <a:spcAft>
+                <a:spcPts val="400"/>
+              </a:spcAft>
+              <a:defRPr sz="1200">
+                <a:solidFill>
+                  <a:srgbClr val="0B1B2D"/>
+                </a:solidFill>
+              </a:defRPr>
+            </a:pPr>
+            <a:r>
+              <a:t>• :  ()</a:t>
+            </a:r>
+          </a:p>
+          <a:p>
+            <a:pPr>
+              <a:spcAft>
+                <a:spcPts val="400"/>
+              </a:spcAft>
+              <a:defRPr sz="1200">
+                <a:solidFill>
+                  <a:srgbClr val="0B1B2D"/>
+                </a:solidFill>
+              </a:defRPr>
+            </a:pPr>
+            <a:r>
+              <a:t>• :  ()</a:t>
             </a:r>
           </a:p>
         </p:txBody>
@@ -12430,6 +13567,9 @@
                 </a:solidFill>
               </a:defRPr>
             </a:pPr>
+            <a:r>
+              <a:t>Prinsip paling fundamental dari DI bukanlah framework atau container, melainkan pemisahan waktu pembuatan objek dari waktu penggunaan objek.</a:t>
+            </a:r>
           </a:p>
         </p:txBody>
       </p:sp>
@@ -12479,6 +13619,9 @@
                 </a:solidFill>
               </a:defRPr>
             </a:pPr>
+            <a:r>
+              <a:t>Assemble the graph once at startup; execute pure business logic during runtime.</a:t>
+            </a:r>
           </a:p>
         </p:txBody>
       </p:sp>
@@ -12511,6 +13654,9 @@
                 </a:solidFill>
               </a:defRPr>
             </a:pPr>
+            <a:r>
+              <a:t>content/02-master-draft.md</a:t>
+            </a:r>
           </a:p>
         </p:txBody>
       </p:sp>
@@ -12675,7 +13821,7 @@
               </a:defRPr>
             </a:pPr>
             <a:r>
-              <a:t>Alur Injeksi</a:t>
+              <a:t>Pipeline Alur Eksekusi Dependency Injection</a:t>
             </a:r>
           </a:p>
         </p:txBody>
@@ -12710,7 +13856,7 @@
               </a:defRPr>
             </a:pPr>
             <a:r>
-              <a:t>Parser → Provider Registry → Resolver → Consumer</a:t>
+              <a:t>Dari entry point aplikasi hingga eksekusi infrastruktur terabstraksi.</a:t>
             </a:r>
           </a:p>
         </p:txBody>
@@ -12744,6 +13890,66 @@
                 </a:solidFill>
               </a:defRPr>
             </a:pPr>
+          </a:p>
+          <a:p>
+            <a:pPr>
+              <a:spcAft>
+                <a:spcPts val="400"/>
+              </a:spcAft>
+              <a:defRPr sz="1200">
+                <a:solidFill>
+                  <a:srgbClr val="0B1B2D"/>
+                </a:solidFill>
+              </a:defRPr>
+            </a:pPr>
+            <a:r>
+              <a:t>• cmd/demo/main.go | Composition Root inisialisasi RealGateway</a:t>
+            </a:r>
+          </a:p>
+          <a:p>
+            <a:pPr>
+              <a:spcAft>
+                <a:spcPts val="400"/>
+              </a:spcAft>
+              <a:defRPr sz="1200">
+                <a:solidFill>
+                  <a:srgbClr val="0B1B2D"/>
+                </a:solidFill>
+              </a:defRPr>
+            </a:pPr>
+            <a:r>
+              <a:t>• di.NewProcessor(gateway) | Konstruktor menerima kontrak PaymentGateway</a:t>
+            </a:r>
+          </a:p>
+          <a:p>
+            <a:pPr>
+              <a:spcAft>
+                <a:spcPts val="400"/>
+              </a:spcAft>
+              <a:defRPr sz="1200">
+                <a:solidFill>
+                  <a:srgbClr val="0B1B2D"/>
+                </a:solidFill>
+              </a:defRPr>
+            </a:pPr>
+            <a:r>
+              <a:t>• processor.ProcessPayment(100) | Validasi input amount &lt;= 0 &amp; buat Money</a:t>
+            </a:r>
+          </a:p>
+          <a:p>
+            <a:pPr>
+              <a:spcAft>
+                <a:spcPts val="400"/>
+              </a:spcAft>
+              <a:defRPr sz="1200">
+                <a:solidFill>
+                  <a:srgbClr val="0B1B2D"/>
+                </a:solidFill>
+              </a:defRPr>
+            </a:pPr>
+            <a:r>
+              <a:t>• gateway.Charge(Money) | Delegasi eksekusi ke implementasi konkret</a:t>
+            </a:r>
           </a:p>
         </p:txBody>
       </p:sp>
@@ -12779,6 +13985,9 @@
                 </a:solidFill>
               </a:defRPr>
             </a:pPr>
+            <a:r>
+              <a:t>Pipeline memperlihatkan batasan tanggung jawab yang jelas: composition root menangani konstruksi, processor menangani validasi, dan gateway menangani charge.</a:t>
+            </a:r>
           </a:p>
         </p:txBody>
       </p:sp>
@@ -12828,6 +14037,9 @@
                 </a:solidFill>
               </a:defRPr>
             </a:pPr>
+            <a:r>
+              <a:t>Separate configuration from use: simple linear stages create decoupled architecture.</a:t>
+            </a:r>
           </a:p>
         </p:txBody>
       </p:sp>
@@ -12860,6 +14072,9 @@
                 </a:solidFill>
               </a:defRPr>
             </a:pPr>
+            <a:r>
+              <a:t>cmd/demo/main.go • internal/di/processor.go</a:t>
+            </a:r>
           </a:p>
         </p:txBody>
       </p:sp>
@@ -13024,7 +14239,7 @@
               </a:defRPr>
             </a:pPr>
             <a:r>
-              <a:t>Contoh Provider</a:t>
+              <a:t>Constructor Injection: Valid State at Birth</a:t>
             </a:r>
           </a:p>
         </p:txBody>
@@ -13059,7 +14274,7 @@
               </a:defRPr>
             </a:pPr>
             <a:r>
-              <a:t>Registrasi sederhana dengan func.</a:t>
+              <a:t>Field unexported, dependensi eksplisit, dan objek dijamin lengkap.</a:t>
             </a:r>
           </a:p>
         </p:txBody>
@@ -13111,6 +14326,30 @@
                 <a:latin typeface="Courier New"/>
               </a:defRPr>
             </a:pPr>
+            <a:r>
+              <a:t>type Processor struct {</a:t>
+            </a:r>
+            <a:br/>
+            <a:r>
+              <a:t>    gateway PaymentGateway</a:t>
+            </a:r>
+            <a:br/>
+            <a:r>
+              <a:t>}</a:t>
+            </a:r>
+            <a:br/>
+            <a:br/>
+            <a:r>
+              <a:t>func NewProcessor(g PaymentGateway) *Processor {</a:t>
+            </a:r>
+            <a:br/>
+            <a:r>
+              <a:t>    return &amp;Processor{gateway: g}</a:t>
+            </a:r>
+            <a:br/>
+            <a:r>
+              <a:t>}</a:t>
+            </a:r>
           </a:p>
         </p:txBody>
       </p:sp>
@@ -13146,6 +14385,9 @@
                 </a:solidFill>
               </a:defRPr>
             </a:pPr>
+            <a:r>
+              <a:t>Dengan Constructor Injection, Processor tidak mungkin dibuat dalam keadaan setengah matang. Signature constructor menyatakan secara gamblang apa yang dibutuhkan.</a:t>
+            </a:r>
           </a:p>
         </p:txBody>
       </p:sp>
@@ -13195,6 +14437,9 @@
                 </a:solidFill>
               </a:defRPr>
             </a:pPr>
+            <a:r>
+              <a:t>Explicit constructor parameters enforce immutable, valid instances at creation time.</a:t>
+            </a:r>
           </a:p>
         </p:txBody>
       </p:sp>
@@ -13227,6 +14472,9 @@
                 </a:solidFill>
               </a:defRPr>
             </a:pPr>
+            <a:r>
+              <a:t>internal/di/processor.go:6-13</a:t>
+            </a:r>
           </a:p>
         </p:txBody>
       </p:sp>
@@ -13391,7 +14639,7 @@
               </a:defRPr>
             </a:pPr>
             <a:r>
-              <a:t>Path Failure: Missing Binding</a:t>
+              <a:t>Failure Path: Pencegahan Eksekusi I/O Sia-sia</a:t>
             </a:r>
           </a:p>
         </p:txBody>
@@ -13426,7 +14674,7 @@
               </a:defRPr>
             </a:pPr>
             <a:r>
-              <a:t>Resolver panic when binding absent.</a:t>
+              <a:t>Validasi domain memotong eksekusi sebelum memanggil payment gateway.</a:t>
             </a:r>
           </a:p>
         </p:txBody>
@@ -13460,9 +14708,6 @@
                 </a:solidFill>
               </a:defRPr>
             </a:pPr>
-            <a:r>
-              <a:t>ALUR</a:t>
-            </a:r>
           </a:p>
           <a:p>
             <a:pPr>
@@ -13476,7 +14721,7 @@
               </a:defRPr>
             </a:pPr>
             <a:r>
-              <a:t>• Consumer requests InterfaceX.</a:t>
+              <a:t>• Input Transaksi | amount = -10 (invalid input)</a:t>
             </a:r>
           </a:p>
           <a:p>
@@ -13491,7 +14736,7 @@
               </a:defRPr>
             </a:pPr>
             <a:r>
-              <a:t>Resolver looks up binding → not found.</a:t>
+              <a:t>• Processor Pre-check | if amount &lt;= 0 { return error }</a:t>
             </a:r>
           </a:p>
           <a:p>
@@ -13506,7 +14751,22 @@
               </a:defRPr>
             </a:pPr>
             <a:r>
-              <a:t>• panic: no provider for InterfaceX.</a:t>
+              <a:t>• Short-Circuit Exit | Return errors.New("invalid amount")</a:t>
+            </a:r>
+          </a:p>
+          <a:p>
+            <a:pPr>
+              <a:spcAft>
+                <a:spcPts val="400"/>
+              </a:spcAft>
+              <a:defRPr sz="1200">
+                <a:solidFill>
+                  <a:srgbClr val="0B1B2D"/>
+                </a:solidFill>
+              </a:defRPr>
+            </a:pPr>
+            <a:r>
+              <a:t>• Infrastruktur Aman | gateway.Charge() tidak pernah dipanggil (Amount = 0)</a:t>
             </a:r>
           </a:p>
         </p:txBody>
@@ -13544,7 +14804,7 @@
               </a:defRPr>
             </a:pPr>
             <a:r>
-              <a:t>Consumer requests InterfaceX. Resolver looks up binding → not found. panic: no provider for InterfaceX.</a:t>
+              <a:t>DI tidak menghilangkan kebutuhan validasi. Pre-check di Processor memastikan gateway tidak pernah dipanggil ketika parameter bisnis tidak valid.</a:t>
             </a:r>
           </a:p>
         </p:txBody>
@@ -13595,6 +14855,9 @@
                 </a:solidFill>
               </a:defRPr>
             </a:pPr>
+            <a:r>
+              <a:t>Validate at domain boundary; never leak invalid data into infrastructure calls.</a:t>
+            </a:r>
           </a:p>
         </p:txBody>
       </p:sp>
@@ -13627,6 +14890,9 @@
                 </a:solidFill>
               </a:defRPr>
             </a:pPr>
+            <a:r>
+              <a:t>internal/di/processor.go:15-21 • tests/processor_test.go:47-59</a:t>
+            </a:r>
           </a:p>
         </p:txBody>
       </p:sp>
@@ -13791,7 +15057,7 @@
               </a:defRPr>
             </a:pPr>
             <a:r>
-              <a:t>DI vs Tanpa DI</a:t>
+              <a:t>Tabel Evaluasi Mekanisme Dependensi</a:t>
             </a:r>
           </a:p>
         </p:txBody>
@@ -13826,14 +15092,512 @@
               </a:defRPr>
             </a:pPr>
             <a:r>
-              <a:t>Efek pada testability &amp; startup time.</a:t>
-            </a:r>
-          </a:p>
-        </p:txBody>
-      </p:sp>
-      <p:sp>
-        <p:nvSpPr>
-          <p:cNvPr id="6" name="TextBox 5"/>
+              <a:t>Perbandingan struktural antara Constructor Injection, Service Locator, dan Hard-Coded.</a:t>
+            </a:r>
+          </a:p>
+        </p:txBody>
+      </p:sp>
+      <p:graphicFrame>
+        <p:nvGraphicFramePr>
+          <p:cNvPr id="6" name="Table 5"/>
+          <p:cNvGraphicFramePr>
+            <a:graphicFrameLocks noGrp="1"/>
+          </p:cNvGraphicFramePr>
+          <p:nvPr/>
+        </p:nvGraphicFramePr>
+        <p:xfrm>
+          <a:off x="731520" y="1828800"/>
+          <a:ext cx="5120640" cy="2286000"/>
+        </p:xfrm>
+        <a:graphic>
+          <a:graphicData uri="http://schemas.openxmlformats.org/drawingml/2006/table">
+            <a:tbl>
+              <a:tblPr firstRow="1" bandRow="1">
+                <a:tableStyleId>{5C22544A-7EE6-4342-B048-85BDC9FD1C3A}</a:tableStyleId>
+              </a:tblPr>
+              <a:tblGrid>
+                <a:gridCol w="1280160"/>
+                <a:gridCol w="1280160"/>
+                <a:gridCol w="1280160"/>
+                <a:gridCol w="1280160"/>
+              </a:tblGrid>
+              <a:tr h="457200">
+                <a:tc>
+                  <a:txBody>
+                    <a:bodyPr/>
+                    <a:lstStyle/>
+                    <a:p>
+                      <a:pPr>
+                        <a:defRPr b="1" sz="1100">
+                          <a:solidFill>
+                            <a:srgbClr val="FFFFFF"/>
+                          </a:solidFill>
+                        </a:defRPr>
+                      </a:pPr>
+                      <a:r>
+                        <a:t>Kriteria</a:t>
+                      </a:r>
+                    </a:p>
+                  </a:txBody>
+                  <a:tcPr>
+                    <a:solidFill>
+                      <a:srgbClr val="0B1B2D"/>
+                    </a:solidFill>
+                  </a:tcPr>
+                </a:tc>
+                <a:tc>
+                  <a:txBody>
+                    <a:bodyPr/>
+                    <a:lstStyle/>
+                    <a:p>
+                      <a:pPr>
+                        <a:defRPr b="1" sz="1100">
+                          <a:solidFill>
+                            <a:srgbClr val="FFFFFF"/>
+                          </a:solidFill>
+                        </a:defRPr>
+                      </a:pPr>
+                      <a:r>
+                        <a:t>Hard-Coded New</a:t>
+                      </a:r>
+                    </a:p>
+                  </a:txBody>
+                  <a:tcPr>
+                    <a:solidFill>
+                      <a:srgbClr val="0B1B2D"/>
+                    </a:solidFill>
+                  </a:tcPr>
+                </a:tc>
+                <a:tc>
+                  <a:txBody>
+                    <a:bodyPr/>
+                    <a:lstStyle/>
+                    <a:p>
+                      <a:pPr>
+                        <a:defRPr b="1" sz="1100">
+                          <a:solidFill>
+                            <a:srgbClr val="FFFFFF"/>
+                          </a:solidFill>
+                        </a:defRPr>
+                      </a:pPr>
+                      <a:r>
+                        <a:t>Service Locator</a:t>
+                      </a:r>
+                    </a:p>
+                  </a:txBody>
+                  <a:tcPr>
+                    <a:solidFill>
+                      <a:srgbClr val="0B1B2D"/>
+                    </a:solidFill>
+                  </a:tcPr>
+                </a:tc>
+                <a:tc>
+                  <a:txBody>
+                    <a:bodyPr/>
+                    <a:lstStyle/>
+                    <a:p>
+                      <a:pPr>
+                        <a:defRPr b="1" sz="1100">
+                          <a:solidFill>
+                            <a:srgbClr val="FFFFFF"/>
+                          </a:solidFill>
+                        </a:defRPr>
+                      </a:pPr>
+                      <a:r>
+                        <a:t>Constructor Injection</a:t>
+                      </a:r>
+                    </a:p>
+                  </a:txBody>
+                  <a:tcPr>
+                    <a:solidFill>
+                      <a:srgbClr val="0B1B2D"/>
+                    </a:solidFill>
+                  </a:tcPr>
+                </a:tc>
+              </a:tr>
+              <a:tr h="457200">
+                <a:tc>
+                  <a:txBody>
+                    <a:bodyPr/>
+                    <a:lstStyle/>
+                    <a:p>
+                      <a:pPr>
+                        <a:defRPr sz="1000">
+                          <a:solidFill>
+                            <a:srgbClr val="0B1B2D"/>
+                          </a:solidFill>
+                        </a:defRPr>
+                      </a:pPr>
+                      <a:r>
+                        <a:t>Transparansi Kontrak</a:t>
+                      </a:r>
+                    </a:p>
+                  </a:txBody>
+                  <a:tcPr>
+                    <a:solidFill>
+                      <a:srgbClr val="FFFFFF"/>
+                    </a:solidFill>
+                  </a:tcPr>
+                </a:tc>
+                <a:tc>
+                  <a:txBody>
+                    <a:bodyPr/>
+                    <a:lstStyle/>
+                    <a:p>
+                      <a:pPr>
+                        <a:defRPr sz="1000">
+                          <a:solidFill>
+                            <a:srgbClr val="0B1B2D"/>
+                          </a:solidFill>
+                        </a:defRPr>
+                      </a:pPr>
+                      <a:r>
+                        <a:t>Tertutup di method</a:t>
+                      </a:r>
+                    </a:p>
+                  </a:txBody>
+                  <a:tcPr>
+                    <a:solidFill>
+                      <a:srgbClr val="FFFFFF"/>
+                    </a:solidFill>
+                  </a:tcPr>
+                </a:tc>
+                <a:tc>
+                  <a:txBody>
+                    <a:bodyPr/>
+                    <a:lstStyle/>
+                    <a:p>
+                      <a:pPr>
+                        <a:defRPr sz="1000">
+                          <a:solidFill>
+                            <a:srgbClr val="0B1B2D"/>
+                          </a:solidFill>
+                        </a:defRPr>
+                      </a:pPr>
+                      <a:r>
+                        <a:t>Tertutup di container</a:t>
+                      </a:r>
+                    </a:p>
+                  </a:txBody>
+                  <a:tcPr>
+                    <a:solidFill>
+                      <a:srgbClr val="FFFFFF"/>
+                    </a:solidFill>
+                  </a:tcPr>
+                </a:tc>
+                <a:tc>
+                  <a:txBody>
+                    <a:bodyPr/>
+                    <a:lstStyle/>
+                    <a:p>
+                      <a:pPr>
+                        <a:defRPr sz="1000">
+                          <a:solidFill>
+                            <a:srgbClr val="0B1B2D"/>
+                          </a:solidFill>
+                        </a:defRPr>
+                      </a:pPr>
+                      <a:r>
+                        <a:t>Terbuka di constructor</a:t>
+                      </a:r>
+                    </a:p>
+                  </a:txBody>
+                  <a:tcPr>
+                    <a:solidFill>
+                      <a:srgbClr val="FFFFFF"/>
+                    </a:solidFill>
+                  </a:tcPr>
+                </a:tc>
+              </a:tr>
+              <a:tr h="457200">
+                <a:tc>
+                  <a:txBody>
+                    <a:bodyPr/>
+                    <a:lstStyle/>
+                    <a:p>
+                      <a:pPr>
+                        <a:defRPr sz="1000">
+                          <a:solidFill>
+                            <a:srgbClr val="0B1B2D"/>
+                          </a:solidFill>
+                        </a:defRPr>
+                      </a:pPr>
+                      <a:r>
+                        <a:t>Validasi Compiler</a:t>
+                      </a:r>
+                    </a:p>
+                  </a:txBody>
+                  <a:tcPr>
+                    <a:solidFill>
+                      <a:srgbClr val="FFFFFF"/>
+                    </a:solidFill>
+                  </a:tcPr>
+                </a:tc>
+                <a:tc>
+                  <a:txBody>
+                    <a:bodyPr/>
+                    <a:lstStyle/>
+                    <a:p>
+                      <a:pPr>
+                        <a:defRPr sz="1000">
+                          <a:solidFill>
+                            <a:srgbClr val="0B1B2D"/>
+                          </a:solidFill>
+                        </a:defRPr>
+                      </a:pPr>
+                      <a:r>
+                        <a:t>Kuat (tipe konkret)</a:t>
+                      </a:r>
+                    </a:p>
+                  </a:txBody>
+                  <a:tcPr>
+                    <a:solidFill>
+                      <a:srgbClr val="FFFFFF"/>
+                    </a:solidFill>
+                  </a:tcPr>
+                </a:tc>
+                <a:tc>
+                  <a:txBody>
+                    <a:bodyPr/>
+                    <a:lstStyle/>
+                    <a:p>
+                      <a:pPr>
+                        <a:defRPr sz="1000">
+                          <a:solidFill>
+                            <a:srgbClr val="0B1B2D"/>
+                          </a:solidFill>
+                        </a:defRPr>
+                      </a:pPr>
+                      <a:r>
+                        <a:t>Lemah (runtime get)</a:t>
+                      </a:r>
+                    </a:p>
+                  </a:txBody>
+                  <a:tcPr>
+                    <a:solidFill>
+                      <a:srgbClr val="FFFFFF"/>
+                    </a:solidFill>
+                  </a:tcPr>
+                </a:tc>
+                <a:tc>
+                  <a:txBody>
+                    <a:bodyPr/>
+                    <a:lstStyle/>
+                    <a:p>
+                      <a:pPr>
+                        <a:defRPr sz="1000">
+                          <a:solidFill>
+                            <a:srgbClr val="0B1B2D"/>
+                          </a:solidFill>
+                        </a:defRPr>
+                      </a:pPr>
+                      <a:r>
+                        <a:t>Sangat Kuat (interface)</a:t>
+                      </a:r>
+                    </a:p>
+                  </a:txBody>
+                  <a:tcPr>
+                    <a:solidFill>
+                      <a:srgbClr val="FFFFFF"/>
+                    </a:solidFill>
+                  </a:tcPr>
+                </a:tc>
+              </a:tr>
+              <a:tr h="457200">
+                <a:tc>
+                  <a:txBody>
+                    <a:bodyPr/>
+                    <a:lstStyle/>
+                    <a:p>
+                      <a:pPr>
+                        <a:defRPr sz="1000">
+                          <a:solidFill>
+                            <a:srgbClr val="0B1B2D"/>
+                          </a:solidFill>
+                        </a:defRPr>
+                      </a:pPr>
+                      <a:r>
+                        <a:t>Kompleksitas Test</a:t>
+                      </a:r>
+                    </a:p>
+                  </a:txBody>
+                  <a:tcPr>
+                    <a:solidFill>
+                      <a:srgbClr val="FFFFFF"/>
+                    </a:solidFill>
+                  </a:tcPr>
+                </a:tc>
+                <a:tc>
+                  <a:txBody>
+                    <a:bodyPr/>
+                    <a:lstStyle/>
+                    <a:p>
+                      <a:pPr>
+                        <a:defRPr sz="1000">
+                          <a:solidFill>
+                            <a:srgbClr val="0B1B2D"/>
+                          </a:solidFill>
+                        </a:defRPr>
+                      </a:pPr>
+                      <a:r>
+                        <a:t>Sangat tinggi (mock I/O)</a:t>
+                      </a:r>
+                    </a:p>
+                  </a:txBody>
+                  <a:tcPr>
+                    <a:solidFill>
+                      <a:srgbClr val="FFFFFF"/>
+                    </a:solidFill>
+                  </a:tcPr>
+                </a:tc>
+                <a:tc>
+                  <a:txBody>
+                    <a:bodyPr/>
+                    <a:lstStyle/>
+                    <a:p>
+                      <a:pPr>
+                        <a:defRPr sz="1000">
+                          <a:solidFill>
+                            <a:srgbClr val="0B1B2D"/>
+                          </a:solidFill>
+                        </a:defRPr>
+                      </a:pPr>
+                      <a:r>
+                        <a:t>Sedang (mock container)</a:t>
+                      </a:r>
+                    </a:p>
+                  </a:txBody>
+                  <a:tcPr>
+                    <a:solidFill>
+                      <a:srgbClr val="FFFFFF"/>
+                    </a:solidFill>
+                  </a:tcPr>
+                </a:tc>
+                <a:tc>
+                  <a:txBody>
+                    <a:bodyPr/>
+                    <a:lstStyle/>
+                    <a:p>
+                      <a:pPr>
+                        <a:defRPr sz="1000">
+                          <a:solidFill>
+                            <a:srgbClr val="0B1B2D"/>
+                          </a:solidFill>
+                        </a:defRPr>
+                      </a:pPr>
+                      <a:r>
+                        <a:t>Minimal (mock interface)</a:t>
+                      </a:r>
+                    </a:p>
+                  </a:txBody>
+                  <a:tcPr>
+                    <a:solidFill>
+                      <a:srgbClr val="FFFFFF"/>
+                    </a:solidFill>
+                  </a:tcPr>
+                </a:tc>
+              </a:tr>
+              <a:tr h="457200">
+                <a:tc>
+                  <a:txBody>
+                    <a:bodyPr/>
+                    <a:lstStyle/>
+                    <a:p>
+                      <a:pPr>
+                        <a:defRPr sz="1000">
+                          <a:solidFill>
+                            <a:srgbClr val="0B1B2D"/>
+                          </a:solidFill>
+                        </a:defRPr>
+                      </a:pPr>
+                      <a:r>
+                        <a:t>Standar Industri</a:t>
+                      </a:r>
+                    </a:p>
+                  </a:txBody>
+                  <a:tcPr>
+                    <a:solidFill>
+                      <a:srgbClr val="FFFFFF"/>
+                    </a:solidFill>
+                  </a:tcPr>
+                </a:tc>
+                <a:tc>
+                  <a:txBody>
+                    <a:bodyPr/>
+                    <a:lstStyle/>
+                    <a:p>
+                      <a:pPr>
+                        <a:defRPr sz="1000">
+                          <a:solidFill>
+                            <a:srgbClr val="0B1B2D"/>
+                          </a:solidFill>
+                        </a:defRPr>
+                      </a:pPr>
+                      <a:r>
+                        <a:t>Anti-pattern monolit</a:t>
+                      </a:r>
+                    </a:p>
+                  </a:txBody>
+                  <a:tcPr>
+                    <a:solidFill>
+                      <a:srgbClr val="FFFFFF"/>
+                    </a:solidFill>
+                  </a:tcPr>
+                </a:tc>
+                <a:tc>
+                  <a:txBody>
+                    <a:bodyPr/>
+                    <a:lstStyle/>
+                    <a:p>
+                      <a:pPr>
+                        <a:defRPr sz="1000">
+                          <a:solidFill>
+                            <a:srgbClr val="0B1B2D"/>
+                          </a:solidFill>
+                        </a:defRPr>
+                      </a:pPr>
+                      <a:r>
+                        <a:t>PSR-11: SHOULD NOT</a:t>
+                      </a:r>
+                    </a:p>
+                  </a:txBody>
+                  <a:tcPr>
+                    <a:solidFill>
+                      <a:srgbClr val="FFFFFF"/>
+                    </a:solidFill>
+                  </a:tcPr>
+                </a:tc>
+                <a:tc>
+                  <a:txBody>
+                    <a:bodyPr/>
+                    <a:lstStyle/>
+                    <a:p>
+                      <a:pPr>
+                        <a:defRPr sz="1000">
+                          <a:solidFill>
+                            <a:srgbClr val="0B1B2D"/>
+                          </a:solidFill>
+                        </a:defRPr>
+                      </a:pPr>
+                      <a:r>
+                        <a:t>Rekomendasi Fowler / Default</a:t>
+                      </a:r>
+                    </a:p>
+                  </a:txBody>
+                  <a:tcPr>
+                    <a:solidFill>
+                      <a:srgbClr val="FFFFFF"/>
+                    </a:solidFill>
+                  </a:tcPr>
+                </a:tc>
+              </a:tr>
+            </a:tbl>
+          </a:graphicData>
+        </a:graphic>
+      </p:graphicFrame>
+      <p:sp>
+        <p:nvSpPr>
+          <p:cNvPr id="7" name="TextBox 6"/>
           <p:cNvSpPr txBox="1"/>
           <p:nvPr/>
         </p:nvSpPr>
@@ -13863,12 +15627,15 @@
                 </a:solidFill>
               </a:defRPr>
             </a:pPr>
-          </a:p>
-        </p:txBody>
-      </p:sp>
-      <p:sp>
-        <p:nvSpPr>
-          <p:cNvPr id="7" name="Rectangle 6"/>
+            <a:r>
+              <a:t>Constructor injection memberikan kombinasi terbaik: dependensi terlihat transparan, compiler memvalidasi pemenuhan interface, dan test double dapat diinjeksi tanpa overhead.</a:t>
+            </a:r>
+          </a:p>
+        </p:txBody>
+      </p:sp>
+      <p:sp>
+        <p:nvSpPr>
+          <p:cNvPr id="8" name="Rectangle 7"/>
           <p:cNvSpPr/>
           <p:nvPr/>
         </p:nvSpPr>
@@ -13912,12 +15679,15 @@
                 </a:solidFill>
               </a:defRPr>
             </a:pPr>
-          </a:p>
-        </p:txBody>
-      </p:sp>
-      <p:sp>
-        <p:nvSpPr>
-          <p:cNvPr id="8" name="TextBox 7"/>
+            <a:r>
+              <a:t>Constructor injection provides compiler-enforced transparency; service locator delays failures to runtime.</a:t>
+            </a:r>
+          </a:p>
+        </p:txBody>
+      </p:sp>
+      <p:sp>
+        <p:nvSpPr>
+          <p:cNvPr id="9" name="TextBox 8"/>
           <p:cNvSpPr txBox="1"/>
           <p:nvPr/>
         </p:nvSpPr>
@@ -13944,12 +15714,15 @@
                 </a:solidFill>
               </a:defRPr>
             </a:pPr>
-          </a:p>
-        </p:txBody>
-      </p:sp>
-      <p:sp>
-        <p:nvSpPr>
-          <p:cNvPr id="9" name="TextBox 8"/>
+            <a:r>
+              <a:t>content/02-master-draft.md</a:t>
+            </a:r>
+          </a:p>
+        </p:txBody>
+      </p:sp>
+      <p:sp>
+        <p:nvSpPr>
+          <p:cNvPr id="10" name="TextBox 9"/>
           <p:cNvSpPr txBox="1"/>
           <p:nvPr/>
         </p:nvSpPr>
@@ -14108,7 +15881,7 @@
               </a:defRPr>
             </a:pPr>
             <a:r>
-              <a:t>3 Keputusan Kunci</a:t>
+              <a:t>Tiga Keputusan Desain Dependensi</a:t>
             </a:r>
           </a:p>
         </p:txBody>
@@ -14143,7 +15916,7 @@
               </a:defRPr>
             </a:pPr>
             <a:r>
-              <a:t>When to bind, scope, and replace.</a:t>
+              <a:t>Urutan keputusan arsitektur untuk menjaga kemurnian boundary sistem.</a:t>
             </a:r>
           </a:p>
         </p:txBody>
@@ -14177,6 +15950,9 @@
                 </a:solidFill>
               </a:defRPr>
             </a:pPr>
+            <a:r>
+              <a:t>DECISION SEQUENCE</a:t>
+            </a:r>
           </a:p>
           <a:p>
             <a:pPr>
@@ -14190,7 +15966,7 @@
               </a:defRPr>
             </a:pPr>
             <a:r>
-              <a:t>• Bind per request vs singleton.</a:t>
+              <a:t>• :  ()</a:t>
             </a:r>
           </a:p>
           <a:p>
@@ -14205,7 +15981,7 @@
               </a:defRPr>
             </a:pPr>
             <a:r>
-              <a:t>• Prefer interface over concrete.</a:t>
+              <a:t>• :  ()</a:t>
             </a:r>
           </a:p>
           <a:p>
@@ -14220,7 +15996,7 @@
               </a:defRPr>
             </a:pPr>
             <a:r>
-              <a:t>• Use lazy provider for heavy deps.</a:t>
+              <a:t>• :  ()</a:t>
             </a:r>
           </a:p>
         </p:txBody>
@@ -14258,7 +16034,7 @@
               </a:defRPr>
             </a:pPr>
             <a:r>
-              <a:t>Bind per request vs singleton. Prefer interface over concrete. Use lazy provider for heavy deps.</a:t>
+              <a:t>Keputusan ini memastikan bahwa abstraksi hanya diterapkan pada batas sistem eksternal, sementara struktur data murni tetap ringan tanpa beban overhead DI.</a:t>
             </a:r>
           </a:p>
         </p:txBody>
@@ -14309,6 +16085,9 @@
                 </a:solidFill>
               </a:defRPr>
             </a:pPr>
+            <a:r>
+              <a:t>Interface external boundaries, inject at constructors, instantiate value objects directly.</a:t>
+            </a:r>
           </a:p>
         </p:txBody>
       </p:sp>
@@ -14341,6 +16120,9 @@
                 </a:solidFill>
               </a:defRPr>
             </a:pPr>
+            <a:r>
+              <a:t>internal/di/gateway.go • internal/di/processor.go</a:t>
+            </a:r>
           </a:p>
         </p:txBody>
       </p:sp>

</xml_diff>

<commit_message>
docs: update content audit report, verdict, and generated dev.to and LinkedIn deliverables for lab 16 dependency injection
</commit_message>
<xml_diff>
--- a/labs/16-dependency-injection/result/linkedin/lab-16-dependency-injection-carousel.pptx
+++ b/labs/16-dependency-injection/result/linkedin/lab-16-dependency-injection-carousel.pptx
@@ -1225,17 +1225,17 @@
           </a:p>
           <a:p>
             <a:r>
-              <a:t>- : </a:t>
-            </a:r>
-          </a:p>
-          <a:p>
-            <a:r>
-              <a:t>- : </a:t>
-            </a:r>
-          </a:p>
-          <a:p>
-            <a:r>
-              <a:t>- : </a:t>
+              <a:t>- Substitusi Bersih: mock := &amp;MockGateway{} disuntikkan ke NewProcessor(mock); tidak ada panggilan TCP atau setup database.</a:t>
+            </a:r>
+          </a:p>
+          <a:p>
+            <a:r>
+              <a:t>- Validasi Status Mutasi: mock.ChargedMoney mencatat persis Amount: 50 dan Currency: 'USD' setelah ProcessPayment(50) berhasil.</a:t>
+            </a:r>
+          </a:p>
+          <a:p>
+            <a:r>
+              <a:t>- Zero-Latency Run: Eksekusi test selesai dalam 0.00s deterministik, bebas dari network flakiness atau rate-limit vendor.</a:t>
             </a:r>
           </a:p>
           <a:p/>
@@ -1323,17 +1323,17 @@
           </a:p>
           <a:p>
             <a:r>
-              <a:t>- : </a:t>
-            </a:r>
-          </a:p>
-          <a:p>
-            <a:r>
-              <a:t>- : </a:t>
-            </a:r>
-          </a:p>
-          <a:p>
-            <a:r>
-              <a:t>- : </a:t>
+              <a:t>- Simulasi Down Time: MockGateway dengan ShouldFail: true mensimulasikan kondisi 'gateway unavailable' secara instan.</a:t>
+            </a:r>
+          </a:p>
+          <a:p>
+            <a:r>
+              <a:t>- Error Forwarding: Processor mengembalikan error gateway langsung ke caller tanpa menelan (swallow) pesan kesalahan.</a:t>
+            </a:r>
+          </a:p>
+          <a:p>
+            <a:r>
+              <a:t>- Audit Integritas: Caller menerima sinyal kegagalan deterministik untuk memicu mekanisme retry atau fallback otomatis.</a:t>
             </a:r>
           </a:p>
           <a:p/>
@@ -1421,17 +1421,17 @@
           </a:p>
           <a:p>
             <a:r>
-              <a:t>- : </a:t>
-            </a:r>
-          </a:p>
-          <a:p>
-            <a:r>
-              <a:t>- : </a:t>
-            </a:r>
-          </a:p>
-          <a:p>
-            <a:r>
-              <a:t>- : </a:t>
+              <a:t>- Input Negatif / Nol: ProcessPayment(-10) menghasilkan error 'invalid amount' seketika pada boundary validasi.</a:t>
+            </a:r>
+          </a:p>
+          <a:p>
+            <a:r>
+              <a:t>- Assertion Gateway Call: Assertion mock.ChargedMoney.Amount == 0 membuktikan Charge() tidak pernah disentuh sama sekali.</a:t>
+            </a:r>
+          </a:p>
+          <a:p>
+            <a:r>
+              <a:t>- Cost &amp; Traffic Saving: Mencegah overhead biaya API call vendor dan transmisi data yang ditakdirkan gagal sejak awal.</a:t>
             </a:r>
           </a:p>
           <a:p/>
@@ -1519,17 +1519,17 @@
           </a:p>
           <a:p>
             <a:r>
-              <a:t>- : </a:t>
-            </a:r>
-          </a:p>
-          <a:p>
-            <a:r>
-              <a:t>- : </a:t>
-            </a:r>
-          </a:p>
-          <a:p>
-            <a:r>
-              <a:t>- : </a:t>
+              <a:t>- Data Murni Tanpa Efek: Struct Money{Amount, Currency} tidak berinteraksi dengan database, network, atau state eksternal.</a:t>
+            </a:r>
+          </a:p>
+          <a:p>
+            <a:r>
+              <a:t>- Bahaya Over-Injection: Memasukkan struct data ke dalam container DI menambah layer indirection tanpa keuntungan testability.</a:t>
+            </a:r>
+          </a:p>
+          <a:p>
+            <a:r>
+              <a:t>- Heuristik Desain: Gunakan DI untuk Service ber-efek samping (I/O); gunakan direct instantiation untuk data value murni.</a:t>
             </a:r>
           </a:p>
           <a:p/>
@@ -1617,17 +1617,17 @@
           </a:p>
           <a:p>
             <a:r>
-              <a:t>- : </a:t>
-            </a:r>
-          </a:p>
-          <a:p>
-            <a:r>
-              <a:t>- : </a:t>
-            </a:r>
-          </a:p>
-          <a:p>
-            <a:r>
-              <a:t>- : </a:t>
+              <a:t>- Pelanggaran PSR-11: Standar PHP-FIG PSR-11 menegaskan: 'Users SHOULD NOT pass a container into an object'.</a:t>
+            </a:r>
+          </a:p>
+          <a:p>
+            <a:r>
+              <a:t>- Double-Mocking Overhead: Pengujian BadProcessor mewajibkan pembuatan MockContainer hanya untuk mengembalikan MockGateway.</a:t>
+            </a:r>
+          </a:p>
+          <a:p>
+            <a:r>
+              <a:t>- Kopling ke API Container: Kelas bisnis menjadi terikat pada method GetPaymentGateway() milik container, bukan antarmuka generik.</a:t>
             </a:r>
           </a:p>
           <a:p/>
@@ -1715,17 +1715,17 @@
           </a:p>
           <a:p>
             <a:r>
-              <a:t>- : </a:t>
-            </a:r>
-          </a:p>
-          <a:p>
-            <a:r>
-              <a:t>- : </a:t>
-            </a:r>
-          </a:p>
-          <a:p>
-            <a:r>
-              <a:t>- : </a:t>
+              <a:t>- Tightly Coupled Code: Processor menginstansiasi RealGateway langsung di method; logika bisnis terkunci ke implementasi vendor tunggal.</a:t>
+            </a:r>
+          </a:p>
+          <a:p>
+            <a:r>
+              <a:t>- Pengujian Lambat &amp; Flaky: Unit test terpaksa membuka koneksi jaringan nyata atau memerlukan mock REST API server yang lambat dan rapuh.</a:t>
+            </a:r>
+          </a:p>
+          <a:p>
+            <a:r>
+              <a:t>- Ripple Effect Perubahan: Mengganti vendor payment gateway memaksa refactoring dan rekompilasi menyeluruh di seluruh lapisan consumer.</a:t>
             </a:r>
           </a:p>
           <a:p/>
@@ -1926,17 +1926,17 @@
           </a:p>
           <a:p>
             <a:r>
-              <a:t>- : </a:t>
-            </a:r>
-          </a:p>
-          <a:p>
-            <a:r>
-              <a:t>- : </a:t>
-            </a:r>
-          </a:p>
-          <a:p>
-            <a:r>
-              <a:t>- : </a:t>
+              <a:t>- Constructor Bloat: Konstruktor dengan belasan parameter adalah sinyal kuat pelanggaran Single Responsibility (SRP).</a:t>
+            </a:r>
+          </a:p>
+          <a:p>
+            <a:r>
+              <a:t>- Service Locator Disguise: Membungkus dependensi ke dalam satu Map atau Container serbaguna demi menyederhanakan signature ctor.</a:t>
+            </a:r>
+          </a:p>
+          <a:p>
+            <a:r>
+              <a:t>- Over-Abstracting Everything: Membuat interface untuk setiap kelas tanpa pernah memiliki lebih dari satu implementasi atau kebutuhan mock.</a:t>
             </a:r>
           </a:p>
           <a:p/>
@@ -2343,17 +2343,17 @@
           </a:p>
           <a:p>
             <a:r>
-              <a:t>- : </a:t>
-            </a:r>
-          </a:p>
-          <a:p>
-            <a:r>
-              <a:t>- : </a:t>
-            </a:r>
-          </a:p>
-          <a:p>
-            <a:r>
-              <a:t>- : </a:t>
+              <a:t>- Kontrak Opaque: Signature NewBadProcessor(c Container) tidak menyatakan butuh PaymentGateway; dependensi baru terlihat di dalam baris method.</a:t>
+            </a:r>
+          </a:p>
+          <a:p>
+            <a:r>
+              <a:t>- Mocking Menjadi Rumit: Test tidak bisa menyuntikkan MockGateway langsung, melainkan harus membuat MockContainer yang membungkus MockGateway.</a:t>
+            </a:r>
+          </a:p>
+          <a:p>
+            <a:r>
+              <a:t>- Ledakan Runtime: Jika container lupa meregistrasikan gateway, compiler tetap lolos namun aplikasi meledak panic saat dipanggil di production.</a:t>
             </a:r>
           </a:p>
           <a:p/>
@@ -2441,12 +2441,12 @@
           </a:p>
           <a:p>
             <a:r>
-              <a:t>- : </a:t>
-            </a:r>
-          </a:p>
-          <a:p>
-            <a:r>
-              <a:t>- : </a:t>
+              <a:t>- Fase Konfigurasi (Composition Root) (main.go / Assembler): Bertanggung jawab membuat objek konkret (RealGateway), merakit relasi, dan menginjeksikan ke consumer.</a:t>
+            </a:r>
+          </a:p>
+          <a:p>
+            <a:r>
+              <a:t>- Fase Penggunaan (Domain Execution) (Processor (Business Service)): Hanya menerima PaymentGateway via interface; mengeksekusi ProcessPayment tanpa tahu kelas konkret di baliknya.</a:t>
             </a:r>
           </a:p>
           <a:p/>
@@ -2966,17 +2966,17 @@
           </a:p>
           <a:p>
             <a:r>
-              <a:t>- : </a:t>
-            </a:r>
-          </a:p>
-          <a:p>
-            <a:r>
-              <a:t>- : </a:t>
-            </a:r>
-          </a:p>
-          <a:p>
-            <a:r>
-              <a:t>- : </a:t>
+              <a:t>- Program to Interface: Definisikan PaymentGateway Charge(Money) error untuk mengabstraksi seluruh varian vendor pembayaran.</a:t>
+            </a:r>
+          </a:p>
+          <a:p>
+            <a:r>
+              <a:t>- Explicit Dependencies: Tolak Service Locator; oper PaymentGateway langsung ke konstruktor NewProcessor.</a:t>
+            </a:r>
+          </a:p>
+          <a:p>
+            <a:r>
+              <a:t>- Exempt Pure Data: Instansiasi Money{Amount, Currency} langsung tanpa DI container karena tidak memiliki efek I/O.</a:t>
             </a:r>
           </a:p>
           <a:p/>
@@ -8639,7 +8639,7 @@
               </a:defRPr>
             </a:pPr>
             <a:r>
-              <a:t>• :  ()</a:t>
+              <a:t>• Substitusi Bersih: mock := &amp;MockGateway{} disuntikkan ke NewProcessor(mock); tidak ada panggilan TCP atau setup database.</a:t>
             </a:r>
           </a:p>
           <a:p>
@@ -8654,7 +8654,7 @@
               </a:defRPr>
             </a:pPr>
             <a:r>
-              <a:t>• :  ()</a:t>
+              <a:t>• Validasi Status Mutasi: mock.ChargedMoney mencatat persis Amount: 50 dan Currency: 'USD' setelah ProcessPayment(50) berhasil.</a:t>
             </a:r>
           </a:p>
           <a:p>
@@ -8669,7 +8669,7 @@
               </a:defRPr>
             </a:pPr>
             <a:r>
-              <a:t>• :  ()</a:t>
+              <a:t>• Zero-Latency Run: Eksekusi test selesai dalam 0.00s deterministik, bebas dari network flakiness atau rate-limit vendor.</a:t>
             </a:r>
           </a:p>
         </p:txBody>
@@ -9045,7 +9045,7 @@
               </a:defRPr>
             </a:pPr>
             <a:r>
-              <a:t>• :  ()</a:t>
+              <a:t>• Simulasi Down Time: MockGateway dengan ShouldFail: true mensimulasikan kondisi 'gateway unavailable' secara instan.</a:t>
             </a:r>
           </a:p>
           <a:p>
@@ -9060,7 +9060,7 @@
               </a:defRPr>
             </a:pPr>
             <a:r>
-              <a:t>• :  ()</a:t>
+              <a:t>• Error Forwarding: Processor mengembalikan error gateway langsung ke caller tanpa menelan (swallow) pesan kesalahan.</a:t>
             </a:r>
           </a:p>
           <a:p>
@@ -9075,7 +9075,7 @@
               </a:defRPr>
             </a:pPr>
             <a:r>
-              <a:t>• :  ()</a:t>
+              <a:t>• Audit Integritas: Caller menerima sinyal kegagalan deterministik untuk memicu mekanisme retry atau fallback otomatis.</a:t>
             </a:r>
           </a:p>
         </p:txBody>
@@ -9451,7 +9451,7 @@
               </a:defRPr>
             </a:pPr>
             <a:r>
-              <a:t>• :  ()</a:t>
+              <a:t>• Input Negatif / Nol: ProcessPayment(-10) menghasilkan error 'invalid amount' seketika pada boundary validasi.</a:t>
             </a:r>
           </a:p>
           <a:p>
@@ -9466,7 +9466,7 @@
               </a:defRPr>
             </a:pPr>
             <a:r>
-              <a:t>• :  ()</a:t>
+              <a:t>• Assertion Gateway Call: Assertion mock.ChargedMoney.Amount == 0 membuktikan Charge() tidak pernah disentuh sama sekali.</a:t>
             </a:r>
           </a:p>
           <a:p>
@@ -9481,7 +9481,7 @@
               </a:defRPr>
             </a:pPr>
             <a:r>
-              <a:t>• :  ()</a:t>
+              <a:t>• Cost &amp; Traffic Saving: Mencegah overhead biaya API call vendor dan transmisi data yang ditakdirkan gagal sejak awal.</a:t>
             </a:r>
           </a:p>
         </p:txBody>
@@ -9857,7 +9857,7 @@
               </a:defRPr>
             </a:pPr>
             <a:r>
-              <a:t>• :  ()</a:t>
+              <a:t>• Data Murni Tanpa Efek: Struct Money{Amount, Currency} tidak berinteraksi dengan database, network, atau state eksternal.</a:t>
             </a:r>
           </a:p>
           <a:p>
@@ -9872,7 +9872,7 @@
               </a:defRPr>
             </a:pPr>
             <a:r>
-              <a:t>• :  ()</a:t>
+              <a:t>• Bahaya Over-Injection: Memasukkan struct data ke dalam container DI menambah layer indirection tanpa keuntungan testability.</a:t>
             </a:r>
           </a:p>
           <a:p>
@@ -9887,7 +9887,7 @@
               </a:defRPr>
             </a:pPr>
             <a:r>
-              <a:t>• :  ()</a:t>
+              <a:t>• Heuristik Desain: Gunakan DI untuk Service ber-efek samping (I/O); gunakan direct instantiation untuk data value murni.</a:t>
             </a:r>
           </a:p>
         </p:txBody>
@@ -10263,7 +10263,7 @@
               </a:defRPr>
             </a:pPr>
             <a:r>
-              <a:t>• :  ()</a:t>
+              <a:t>• Pelanggaran PSR-11: Standar PHP-FIG PSR-11 menegaskan: 'Users SHOULD NOT pass a container into an object'.</a:t>
             </a:r>
           </a:p>
           <a:p>
@@ -10278,7 +10278,7 @@
               </a:defRPr>
             </a:pPr>
             <a:r>
-              <a:t>• :  ()</a:t>
+              <a:t>• Double-Mocking Overhead: Pengujian BadProcessor mewajibkan pembuatan MockContainer hanya untuk mengembalikan MockGateway.</a:t>
             </a:r>
           </a:p>
           <a:p>
@@ -10293,7 +10293,7 @@
               </a:defRPr>
             </a:pPr>
             <a:r>
-              <a:t>• :  ()</a:t>
+              <a:t>• Kopling ke API Container: Kelas bisnis menjadi terikat pada method GetPaymentGateway() milik container, bukan antarmuka generik.</a:t>
             </a:r>
           </a:p>
         </p:txBody>
@@ -10669,7 +10669,7 @@
               </a:defRPr>
             </a:pPr>
             <a:r>
-              <a:t>• :  ()</a:t>
+              <a:t>• Tightly Coupled Code: Processor menginstansiasi RealGateway langsung di method; logika bisnis terkunci ke implementasi vendor tunggal.</a:t>
             </a:r>
           </a:p>
           <a:p>
@@ -10684,7 +10684,7 @@
               </a:defRPr>
             </a:pPr>
             <a:r>
-              <a:t>• :  ()</a:t>
+              <a:t>• Pengujian Lambat &amp; Flaky: Unit test terpaksa membuka koneksi jaringan nyata atau memerlukan mock REST API server yang lambat dan rapuh.</a:t>
             </a:r>
           </a:p>
           <a:p>
@@ -10699,7 +10699,7 @@
               </a:defRPr>
             </a:pPr>
             <a:r>
-              <a:t>• :  ()</a:t>
+              <a:t>• Ripple Effect Perubahan: Mengganti vendor payment gateway memaksa refactoring dan rekompilasi menyeluruh di seluruh lapisan consumer.</a:t>
             </a:r>
           </a:p>
         </p:txBody>
@@ -11526,7 +11526,7 @@
               </a:defRPr>
             </a:pPr>
             <a:r>
-              <a:t>• :  ()</a:t>
+              <a:t>• Constructor Bloat: Konstruktor dengan belasan parameter adalah sinyal kuat pelanggaran Single Responsibility (SRP).</a:t>
             </a:r>
           </a:p>
           <a:p>
@@ -11541,7 +11541,7 @@
               </a:defRPr>
             </a:pPr>
             <a:r>
-              <a:t>• :  ()</a:t>
+              <a:t>• Service Locator Disguise: Membungkus dependensi ke dalam satu Map atau Container serbaguna demi menyederhanakan signature ctor.</a:t>
             </a:r>
           </a:p>
           <a:p>
@@ -11556,7 +11556,7 @@
               </a:defRPr>
             </a:pPr>
             <a:r>
-              <a:t>• :  ()</a:t>
+              <a:t>• Over-Abstracting Everything: Membuat interface untuk setiap kelas tanpa pernah memiliki lebih dari satu implementasi atau kebutuhan mock.</a:t>
             </a:r>
           </a:p>
         </p:txBody>
@@ -13109,7 +13109,7 @@
               </a:defRPr>
             </a:pPr>
             <a:r>
-              <a:t>• :  ()</a:t>
+              <a:t>• Kontrak Opaque: Signature NewBadProcessor(c Container) tidak menyatakan butuh PaymentGateway; dependensi baru terlihat di dalam baris method.</a:t>
             </a:r>
           </a:p>
           <a:p>
@@ -13124,7 +13124,7 @@
               </a:defRPr>
             </a:pPr>
             <a:r>
-              <a:t>• :  ()</a:t>
+              <a:t>• Mocking Menjadi Rumit: Test tidak bisa menyuntikkan MockGateway langsung, melainkan harus membuat MockContainer yang membungkus MockGateway.</a:t>
             </a:r>
           </a:p>
           <a:p>
@@ -13139,7 +13139,7 @@
               </a:defRPr>
             </a:pPr>
             <a:r>
-              <a:t>• :  ()</a:t>
+              <a:t>• Ledakan Runtime: Jika container lupa meregistrasikan gateway, compiler tetap lolos namun aplikasi meledak panic saat dipanggil di production.</a:t>
             </a:r>
           </a:p>
         </p:txBody>
@@ -13515,7 +13515,7 @@
               </a:defRPr>
             </a:pPr>
             <a:r>
-              <a:t>• :  ()</a:t>
+              <a:t>• Fase Konfigurasi (Composition Root) (main.go / Assembler): Bertanggung jawab membuat objek konkret (RealGateway), merakit relasi, dan menginjeksikan ke consumer.</a:t>
             </a:r>
           </a:p>
           <a:p>
@@ -13530,7 +13530,7 @@
               </a:defRPr>
             </a:pPr>
             <a:r>
-              <a:t>• :  ()</a:t>
+              <a:t>• Fase Penggunaan (Domain Execution) (Processor (Business Service)): Hanya menerima PaymentGateway via interface; mengeksekusi ProcessPayment tanpa tahu kelas konkret di baliknya.</a:t>
             </a:r>
           </a:p>
         </p:txBody>
@@ -15966,7 +15966,7 @@
               </a:defRPr>
             </a:pPr>
             <a:r>
-              <a:t>• :  ()</a:t>
+              <a:t>• Program to Interface: Definisikan PaymentGateway Charge(Money) error untuk mengabstraksi seluruh varian vendor pembayaran.</a:t>
             </a:r>
           </a:p>
           <a:p>
@@ -15981,7 +15981,7 @@
               </a:defRPr>
             </a:pPr>
             <a:r>
-              <a:t>• :  ()</a:t>
+              <a:t>• Explicit Dependencies: Tolak Service Locator; oper PaymentGateway langsung ke konstruktor NewProcessor.</a:t>
             </a:r>
           </a:p>
           <a:p>
@@ -15996,7 +15996,7 @@
               </a:defRPr>
             </a:pPr>
             <a:r>
-              <a:t>• :  ()</a:t>
+              <a:t>• Exempt Pure Data: Instansiasi Money{Amount, Currency} langsung tanpa DI container karena tidak memiliki efek I/O.</a:t>
             </a:r>
           </a:p>
         </p:txBody>

</xml_diff>

<commit_message>
chore: add content audit reports and update verdicts for various labs
</commit_message>
<xml_diff>
--- a/labs/16-dependency-injection/result/linkedin/lab-16-dependency-injection-carousel.pptx
+++ b/labs/16-dependency-injection/result/linkedin/lab-16-dependency-injection-carousel.pptx
@@ -891,17 +891,17 @@
           </a:p>
           <a:p>
             <a:r>
-              <a:t>- Boilerplate vs Convenience: Manual wiring memerlukan kode extra di main.go; framework mengurangi boilerplate tetapi menambah kompleksitas.</a:t>
-            </a:r>
-          </a:p>
-          <a:p>
-            <a:r>
-              <a:t>- Type Safety vs Flexibilitas: Constructor injection enforced pada compile time; reflection-based framework lebih fleksibel tetapi kurang aman.</a:t>
-            </a:r>
-          </a:p>
-          <a:p>
-            <a:r>
-              <a:t>- Tidak Otomatis_scalable: Pada object graph sangat besar, manual wiring menjadi sulit dikelola; bukan berarti DI framework selalu diperlukan.</a:t>
+              <a:t>- Boilerplate vs Kemudahan: Manual wiring memerlukan kode ekstra di main.go; framework mengurangi boilerplate tetapi menambah kompleksitas.</a:t>
+            </a:r>
+          </a:p>
+          <a:p>
+            <a:r>
+              <a:t>- Type Safety vs Fleksibilitas: Compiler memeriksa tipe parameter, bukan seluruh validitas graph; framework refleksi lebih fleksibel tetapi menambah risiko runtime.</a:t>
+            </a:r>
+          </a:p>
+          <a:p>
+            <a:r>
+              <a:t>- Tidak Otomatis Skalabel: Pada object graph sangat besar, manual wiring memerlukan ketelitian perakitan; bukan berarti framework refleksi selalu diperlukan.</a:t>
             </a:r>
           </a:p>
           <a:p/>
@@ -978,7 +978,7 @@
           <a:p/>
           <a:p>
             <a:r>
-              <a:t>Mental Model: Dependency injection promotes stateless, testable components that naturally avoid race conditions.</a:t>
+              <a:t>Mental Model: Skenario test ini tidak menunjukkan race pada jalur yang dieksekusi.</a:t>
             </a:r>
           </a:p>
           <a:p/>
@@ -1117,7 +1117,7 @@
           </a:p>
           <a:p>
             <a:r>
-              <a:t>- Sebelum: Hard-Coded: Processor baru RealGateway di dalam method; tidak bisa di-mock tanpa mengubah kode sumber.</a:t>
+              <a:t>- Sebelum: Hard-Coded: Processor membuat RealGateway di dalam method; tidak bisa di-mock tanpa mengubah kode sumber.</a:t>
             </a:r>
           </a:p>
           <a:p>
@@ -1127,7 +1127,7 @@
           </a:p>
           <a:p>
             <a:r>
-              <a:t>- Bukan Berarti Sempurna: DI bukan solusi ajaib; tetap perlu disiplin composition root dan避免 over-injection.</a:t>
+              <a:t>- Bukan Berarti Sempurna: DI bukan solusi ajaib; tetap perlu disiplin composition root dan hindari over-injection.</a:t>
             </a:r>
           </a:p>
           <a:p/>
@@ -2184,7 +2184,7 @@
           </a:p>
           <a:p>
             <a:r>
-              <a:t>- go test -race ./... # verifikasi race safety</a:t>
+              <a:t>- go test -race ./... # skenario test ini tidak menunjukkan race pada jalur yang dieksekusi</a:t>
             </a:r>
           </a:p>
           <a:p>
@@ -2395,7 +2395,7 @@
           </a:p>
           <a:p>
             <a:r>
-              <a:t>- Commit: 3d936ba • Status: APPROVED</a:t>
+              <a:t>- Commit: 3d936ba • Repositori: software-engineering-lab</a:t>
             </a:r>
           </a:p>
           <a:p>
@@ -2405,7 +2405,7 @@
           </a:p>
           <a:p>
             <a:r>
-              <a:t>- Race detector: Clean (go test -race ./... PASS)</a:t>
+              <a:t>- Race detector: Skenario test ini tidak menunjukkan race pada jalur yang dieksekusi (PASS)</a:t>
             </a:r>
           </a:p>
           <a:p>
@@ -2579,7 +2579,7 @@
           <a:lstStyle/>
           <a:p>
             <a:r>
-              <a:t>SLIDE 4: Separation of Configuration from Use</a:t>
+              <a:t>SLIDE 4: Pemisahan Konfigurasi dari Penggunaan</a:t>
             </a:r>
           </a:p>
           <a:p/>
@@ -2786,7 +2786,7 @@
           <a:p/>
           <a:p>
             <a:r>
-              <a:t>Mental Model: Inject dependencies via constructor parameters to enforce immutability and explicit contracts.</a:t>
+              <a:t>Mental Model: Constructor injection membuat dependensi eksplisit saat konstruksi.</a:t>
             </a:r>
           </a:p>
           <a:p/>
@@ -2965,12 +2965,12 @@
           </a:p>
           <a:p>
             <a:r>
-              <a:t>- Pengujian Ribet: Test harus membuat MockContainer yang mengembalikan MockGateway, bukan MockGateway langsung.</a:t>
-            </a:r>
-          </a:p>
-          <a:p>
-            <a:r>
-              <a:t>- Bukan Berarti Lebih Baik: Service Locator bukan berarti anti-pattern mutlak; PSR-11 menggunakan SHOULD NOT, bukan MUST NOT.</a:t>
+              <a:t>- Beban Mocking Tambahan: Pengujian unit terpaksa menyusun MockContainer bertingkat hanya untuk menyuplai gateway konkret.</a:t>
+            </a:r>
+          </a:p>
+          <a:p>
+            <a:r>
+              <a:t>- Kopling Container Kaku: BadProcessor terikat langsung pada interface Container, bukan abstraksi domain spesifik.</a:t>
             </a:r>
           </a:p>
           <a:p/>
@@ -3073,7 +3073,7 @@
           </a:p>
           <a:p>
             <a:r>
-              <a:t>- Kekekalan | Field immutable setelah konstruksi | Bisa berubah jika container berubah</a:t>
+              <a:t>- Kontrak Dependensi | Membuat dependensi eksplisit saat konstruksi | Tersembunyi di balik lookup container</a:t>
             </a:r>
           </a:p>
           <a:p>
@@ -3083,7 +3083,7 @@
           </a:p>
           <a:p>
             <a:r>
-              <a:t>- Standar Industri | Diproleh sebagai best practice | Disebabkan sebagai anti-pattern</a:t>
+              <a:t>- Standar Industri | Diterima sebagai best practice | Dipandang sebagai anti-pattern</a:t>
             </a:r>
           </a:p>
           <a:p/>
@@ -3160,7 +3160,7 @@
           <a:p/>
           <a:p>
             <a:r>
-              <a:t>Mental Model: Choose constructor injection for explicit dependencies, avoid service locator in domain code, instantiate value objects directly.</a:t>
+              <a:t>Mental Model: Choose constructor injection to make dependencies explicit at construction time.</a:t>
             </a:r>
           </a:p>
           <a:p/>
@@ -3171,7 +3171,7 @@
           </a:p>
           <a:p>
             <a:r>
-              <a:t>- Pilih Constructor Injection: Default modern; menjamin valid state sejak objek lahir dan dependensi eksplisit.</a:t>
+              <a:t>- Pilih Constructor Injection: Default modern; membantu menjaga kontrak dependensi tetap terlihat dan eksplisit.</a:t>
             </a:r>
           </a:p>
           <a:p>
@@ -7369,7 +7369,7 @@
               </a:defRPr>
             </a:pPr>
             <a:r>
-              <a:t>Manual wiring menambah boilerplate tetapi menjamin type safety tanpa dependensi eksternal.</a:t>
+              <a:t>Manual wiring menambah boilerplate tetapi memperjelas kontrak tipe tanpa dependensi eksternal.</a:t>
             </a:r>
           </a:p>
         </p:txBody>
@@ -7419,7 +7419,7 @@
               </a:defRPr>
             </a:pPr>
             <a:r>
-              <a:t>• Boilerplate vs Convenience: Manual wiring memerlukan kode extra di main.go; framework mengurangi boilerplate tetapi menambah kompleksitas.</a:t>
+              <a:t>• Boilerplate vs Kemudahan: Manual wiring memerlukan kode ekstra di main.go; framework mengurangi boilerplate tetapi menambah kompleksitas.</a:t>
             </a:r>
           </a:p>
           <a:p>
@@ -7434,7 +7434,7 @@
               </a:defRPr>
             </a:pPr>
             <a:r>
-              <a:t>• Type Safety vs Flexibilitas: Constructor injection enforced pada compile time; reflection-based framework lebih fleksibel tetapi kurang aman.</a:t>
+              <a:t>• Type Safety vs Fleksibilitas: Compiler memeriksa tipe parameter, bukan seluruh validitas graph; framework refleksi lebih fleksibel tetapi menambah risiko runtime.</a:t>
             </a:r>
           </a:p>
           <a:p>
@@ -7449,7 +7449,7 @@
               </a:defRPr>
             </a:pPr>
             <a:r>
-              <a:t>• Tidak Otomatis_scalable: Pada object graph sangat besar, manual wiring menjadi sulit dikelola; bukan berarti DI framework selalu diperlukan.</a:t>
+              <a:t>• Tidak Otomatis Skalabel: Pada object graph sangat besar, manual wiring memerlukan ketelitian perakitan; bukan berarti framework refleksi selalu diperlukan.</a:t>
             </a:r>
           </a:p>
         </p:txBody>
@@ -7487,7 +7487,7 @@
               </a:defRPr>
             </a:pPr>
             <a:r>
-              <a:t>Penerapan DI manual menuntut penulis composition root yang jelas. Pada skala besar, overhead boilerplate dapat signifikan, namun trade-off ini sering diterima demi kejelasan dan kemudahan pengujian.</a:t>
+              <a:t>Penerapan DI manual menuntut penulisan composition root yang jelas. Pada skala besar, overhead boilerplate dapat bertambah, namun trade-off ini sering diterima demi kejelasan kontrak dan kemudahan pengujian.</a:t>
             </a:r>
           </a:p>
         </p:txBody>
@@ -7898,7 +7898,7 @@
               </a:defRPr>
             </a:pPr>
             <a:r>
-              <a:t>Race detector Go memeriksa akses konkuren ke memori. Implementasi DI ini tidak menggunakan goroutine atau shared state, sehingga test berlari bersih tanpa warning race condition.</a:t>
+              <a:t>Race detector Go memeriksa akses memori konkuren. Pada pengujian ini, skenario test ini tidak menunjukkan race pada jalur yang dieksekusi karena komponen bersifat stateless.</a:t>
             </a:r>
           </a:p>
         </p:txBody>
@@ -7950,7 +7950,7 @@
               </a:defRPr>
             </a:pPr>
             <a:r>
-              <a:t>Dependency injection promotes stateless, testable components that naturally avoid race conditions.</a:t>
+              <a:t>Skenario test ini tidak menunjukkan race pada jalur yang dieksekusi.</a:t>
             </a:r>
           </a:p>
         </p:txBody>
@@ -8236,7 +8236,7 @@
               </a:defRPr>
             </a:pPr>
             <a:r>
-              <a:t>• Sebelum: Hard-Coded: Processor baru RealGateway di dalam method; tidak bisa di-mock tanpa mengubah kode sumber.</a:t>
+              <a:t>• Sebelum: Hard-Coded: Processor membuat RealGateway di dalam method; tidak bisa di-mock tanpa mengubah kode sumber.</a:t>
             </a:r>
           </a:p>
           <a:p>
@@ -8266,7 +8266,7 @@
               </a:defRPr>
             </a:pPr>
             <a:r>
-              <a:t>• Bukan Berarti Sempurna: DI bukan solusi ajaib; tetap perlu disiplin composition root dan避免 over-injection.</a:t>
+              <a:t>• Bukan Berarti Sempurna: DI bukan solusi ajaib; tetap perlu disiplin composition root dan hindari over-injection.</a:t>
             </a:r>
           </a:p>
         </p:txBody>
@@ -8304,7 +8304,7 @@
               </a:defRPr>
             </a:pPr>
             <a:r>
-              <a:t>Sebelum DI, kelas bisnis langsung menginstal dependensi kongkrit, mengunci pada satu implementasi. Setelah DI, dependensi datang dari luar, memungkinkan penggantian dan pengujian terisolasi.</a:t>
+              <a:t>Sebelum DI, kelas bisnis langsung menginstansiasi dependensi konkret, mengunci pada satu implementasi. Setelah DI, dependensi datang dari luar, memungkinkan penggantian dan pengujian terisolasi.</a:t>
             </a:r>
           </a:p>
         </p:txBody>
@@ -9942,7 +9942,7 @@
               </a:defRPr>
             </a:pPr>
             <a:r>
-              <a:t>Composition root adalah fungsi main yang bertanggung jawab merakit object graph. Ia satu-satunya place yang mengimpor implementasi konkret RealGateway.</a:t>
+              <a:t>Composition root adalah fungsi main yang bertanggung jawab merakit object graph. Ia satu-satunya tempat yang mengimpor implementasi konkret RealGateway.</a:t>
             </a:r>
           </a:p>
         </p:txBody>
@@ -12028,7 +12028,7 @@
             </a:r>
             <a:br/>
             <a:r>
-              <a:t>go test -race ./... # verifikasi race safety</a:t>
+              <a:t>go test -race ./... # skenario test ini tidak menunjukkan race pada jalur yang dieksekusi</a:t>
             </a:r>
             <a:br/>
             <a:r>
@@ -12837,7 +12837,11 @@
               </a:defRPr>
             </a:pPr>
             <a:r>
-              <a:t>github.com/lukman-ss/software-engineering-lab/tree/main/labs/16-dependency-injection</a:t>
+              <a:t>github.com/lukman-ss/software-engineering-lab</a:t>
+            </a:r>
+            <a:br/>
+            <a:r>
+              <a:t>labs/16-dependency-injection</a:t>
             </a:r>
           </a:p>
         </p:txBody>
@@ -13515,7 +13519,7 @@
               </a:defRPr>
             </a:pPr>
             <a:r>
-              <a:t>Separation of Configuration from Use</a:t>
+              <a:t>Pemisahan Konfigurasi dari Penggunaan</a:t>
             </a:r>
           </a:p>
         </p:txBody>
@@ -14518,7 +14522,7 @@
               </a:defRPr>
             </a:pPr>
             <a:r>
-              <a:t>Constructor injection menjamin Processor hanya mengenal interface PaymentGateway, bukan implementasi konkrét RealGateway. Dependensi dibuat eksplisit di signature constructor.</a:t>
+              <a:t>Constructor injection membuat Processor hanya mengenal interface PaymentGateway, bukan implementasi konkret RealGateway. Dependensi dibuat eksplisit di signature constructor.</a:t>
             </a:r>
           </a:p>
         </p:txBody>
@@ -14570,7 +14574,7 @@
               </a:defRPr>
             </a:pPr>
             <a:r>
-              <a:t>Inject dependencies via constructor parameters to enforce immutability and explicit contracts.</a:t>
+              <a:t>Constructor injection membuat dependensi eksplisit saat konstruksi.</a:t>
             </a:r>
           </a:p>
         </p:txBody>
@@ -14886,7 +14890,7 @@
               </a:defRPr>
             </a:pPr>
             <a:r>
-              <a:t>• Pengujian Ribet: Test harus membuat MockContainer yang mengembalikan MockGateway, bukan MockGateway langsung.</a:t>
+              <a:t>• Beban Mocking Tambahan: Pengujian unit terpaksa menyusun MockContainer bertingkat hanya untuk menyuplai gateway konkret.</a:t>
             </a:r>
           </a:p>
           <a:p>
@@ -14901,7 +14905,7 @@
               </a:defRPr>
             </a:pPr>
             <a:r>
-              <a:t>• Bukan Berarti Lebih Baik: Service Locator bukan berarti anti-pattern mutlak; PSR-11 menggunakan SHOULD NOT, bukan MUST NOT.</a:t>
+              <a:t>• Kopling Container Kaku: BadProcessor terikat langsung pada interface Container, bukan abstraksi domain spesifik.</a:t>
             </a:r>
           </a:p>
         </p:txBody>
@@ -14939,7 +14943,7 @@
               </a:defRPr>
             </a:pPr>
             <a:r>
-              <a:t>Service Locator menyembunyikan dependensi sebenarnya di balik interface container. Hal ini mengurangi keterbacaan dan mempersulit mocking karena test harus menyiapkan container, bukan dependensi langsung.</a:t>
+              <a:t>Service Locator menyembunyikan dependensi nyata di balik lookup method container saat runtime. Hal ini menyulitkan pelacakan dependensi dan membebani pengujian unit karena developer wajib menyiapkan MockContainer bertingkat hanya untuk menyuplai gateway konkret.</a:t>
             </a:r>
           </a:p>
         </p:txBody>
@@ -15482,7 +15486,7 @@
                         </a:defRPr>
                       </a:pPr>
                       <a:r>
-                        <a:t>Kekekalan</a:t>
+                        <a:t>Kontrak Dependensi</a:t>
                       </a:r>
                     </a:p>
                   </a:txBody>
@@ -15505,7 +15509,7 @@
                         </a:defRPr>
                       </a:pPr>
                       <a:r>
-                        <a:t>Field immutable setelah konstruksi</a:t>
+                        <a:t>Membuat dependensi eksplisit saat konstruksi</a:t>
                       </a:r>
                     </a:p>
                   </a:txBody>
@@ -15528,7 +15532,7 @@
                         </a:defRPr>
                       </a:pPr>
                       <a:r>
-                        <a:t>Bisa berubah jika container berubah</a:t>
+                        <a:t>Tersembunyi di balik lookup container</a:t>
                       </a:r>
                     </a:p>
                   </a:txBody>
@@ -15647,7 +15651,7 @@
                         </a:defRPr>
                       </a:pPr>
                       <a:r>
-                        <a:t>Diproleh sebagai best practice</a:t>
+                        <a:t>Diterima sebagai best practice</a:t>
                       </a:r>
                     </a:p>
                   </a:txBody>
@@ -15670,7 +15674,7 @@
                         </a:defRPr>
                       </a:pPr>
                       <a:r>
-                        <a:t>Disebabkan sebagai anti-pattern</a:t>
+                        <a:t>Dipandang sebagai anti-pattern</a:t>
                       </a:r>
                     </a:p>
                   </a:txBody>
@@ -16056,7 +16060,7 @@
               </a:defRPr>
             </a:pPr>
             <a:r>
-              <a:t>• Pilih Constructor Injection: Default modern; menjamin valid state sejak objek lahir dan dependensi eksplisit.</a:t>
+              <a:t>• Pilih Constructor Injection: Default modern; membantu menjaga kontrak dependensi tetap terlihat dan eksplisit.</a:t>
             </a:r>
           </a:p>
           <a:p>
@@ -16124,7 +16128,7 @@
               </a:defRPr>
             </a:pPr>
             <a:r>
-              <a:t>Lab ini memilih constructor injection sebagai pola default karena memberikan kekekalan dan kejelasan dependensi. Service Locator hanya digunakan untuk mendemonstrasikan anti-pattern, bukan sebagai solusi.</a:t>
+              <a:t>Lab ini memilih constructor injection sebagai pola default karena membantu menjaga kontrak dependensi tetap terlihat. Service Locator hanya digunakan untuk mendemonstrasikan anti-pattern, bukan sebagai solusi arsitektur utama.</a:t>
             </a:r>
           </a:p>
         </p:txBody>
@@ -16176,7 +16180,7 @@
               </a:defRPr>
             </a:pPr>
             <a:r>
-              <a:t>Choose constructor injection for explicit dependencies, avoid service locator in domain code, instantiate value objects directly.</a:t>
+              <a:t>Choose constructor injection to make dependencies explicit at construction time.</a:t>
             </a:r>
           </a:p>
         </p:txBody>

</xml_diff>